<commit_message>
fix: align hybrid retrieval deck with notebook
</commit_message>
<xml_diff>
--- a/decks/06-hybrid-retrieval.pptx
+++ b/decks/06-hybrid-retrieval.pptx
@@ -2,19 +2,19 @@
 <file path=ppt/presentation.xml><?xml version="1.0" encoding="utf-8"?>
 <p:presentation xmlns:p="http://schemas.openxmlformats.org/presentationml/2006/main">
   <p:sldMasterIdLst>
-    <p:sldMasterId xmlns:r="http://schemas.openxmlformats.org/officeDocument/2006/relationships" id="2147483648" r:id="R7a3590ff5edd4568"/>
+    <p:sldMasterId xmlns:r="http://schemas.openxmlformats.org/officeDocument/2006/relationships" id="2147483648" r:id="Rff2a6bd326ba4500"/>
   </p:sldMasterIdLst>
   <p:notesMasterIdLst>
-    <p:notesMasterId xmlns:r="http://schemas.openxmlformats.org/officeDocument/2006/relationships" r:id="R3229cb831de24874"/>
+    <p:notesMasterId xmlns:r="http://schemas.openxmlformats.org/officeDocument/2006/relationships" r:id="R2d124c29d7c847f7"/>
   </p:notesMasterIdLst>
   <p:sldIdLst>
-    <p:sldId xmlns:r="http://schemas.openxmlformats.org/officeDocument/2006/relationships" id="256" r:id="Ra17d1ba37f8349c9"/>
-    <p:sldId xmlns:r="http://schemas.openxmlformats.org/officeDocument/2006/relationships" id="257" r:id="R77e5b8d4e9fc4269"/>
-    <p:sldId xmlns:r="http://schemas.openxmlformats.org/officeDocument/2006/relationships" id="258" r:id="R87965c9f0fd74b91"/>
-    <p:sldId xmlns:r="http://schemas.openxmlformats.org/officeDocument/2006/relationships" id="259" r:id="Rf390063c12ca482e"/>
-    <p:sldId xmlns:r="http://schemas.openxmlformats.org/officeDocument/2006/relationships" id="260" r:id="R4032437350f54019"/>
-    <p:sldId xmlns:r="http://schemas.openxmlformats.org/officeDocument/2006/relationships" id="261" r:id="Ra66a7cae931a408d"/>
-    <p:sldId xmlns:r="http://schemas.openxmlformats.org/officeDocument/2006/relationships" id="262" r:id="Rca7c2c90f2e0491d"/>
+    <p:sldId xmlns:r="http://schemas.openxmlformats.org/officeDocument/2006/relationships" id="256" r:id="Rb89dd0c19e57470d"/>
+    <p:sldId xmlns:r="http://schemas.openxmlformats.org/officeDocument/2006/relationships" id="257" r:id="R2136b62ef76d4267"/>
+    <p:sldId xmlns:r="http://schemas.openxmlformats.org/officeDocument/2006/relationships" id="258" r:id="Rc088ebefff85449b"/>
+    <p:sldId xmlns:r="http://schemas.openxmlformats.org/officeDocument/2006/relationships" id="259" r:id="R220e4196087a4e81"/>
+    <p:sldId xmlns:r="http://schemas.openxmlformats.org/officeDocument/2006/relationships" id="260" r:id="R04b7aede4f354d2c"/>
+    <p:sldId xmlns:r="http://schemas.openxmlformats.org/officeDocument/2006/relationships" id="261" r:id="Re353eb7811e940c2"/>
+    <p:sldId xmlns:r="http://schemas.openxmlformats.org/officeDocument/2006/relationships" id="262" r:id="Rd10b2f14c8ff49e9"/>
   </p:sldIdLst>
   <p:sldSz cx="15240000" cy="8572500"/>
   <p:notesSz cx="6858000" cy="9144000"/>
@@ -1091,7 +1091,7 @@
   </p:cSld>
   <p:clrMap bg1="lt1" tx1="dk1" bg2="lt2" tx2="dk2" accent1="accent1" accent2="accent2" accent3="accent3" accent4="accent4" accent5="accent5" accent6="accent6" hlink="hlink" folHlink="folHlink"/>
   <p:sldLayoutIdLst>
-    <p:sldLayoutId xmlns:r="http://schemas.openxmlformats.org/officeDocument/2006/relationships" id="2147483649" r:id="Rb3aa1bdeb21b432f"/>
+    <p:sldLayoutId xmlns:r="http://schemas.openxmlformats.org/officeDocument/2006/relationships" id="2147483649" r:id="R48334c3f187d4adf"/>
   </p:sldLayoutIdLst>
   <p:txStyles>
     <p:titleStyle>
@@ -2039,7 +2039,7 @@
         </p:spPr>
         <p:txBody>
           <a:bodyPr xmlns:a="http://schemas.openxmlformats.org/drawingml/2006/main" wrap="square" lIns="0" tIns="0" rIns="0" bIns="0" anchor="ctr">
-            <a:normAutofit fontScale="100000"/>
+            <a:noAutofit/>
           </a:bodyPr>
           <a:lstStyle xmlns:a="http://schemas.openxmlformats.org/drawingml/2006/main"/>
           <a:p xmlns:a="http://schemas.openxmlformats.org/drawingml/2006/main">
@@ -2058,7 +2058,7 @@
               </a:defRPr>
             </a:pPr>
             <a:r>
-              <a:rPr sz="1425" b="1">
+              <a:rPr sz="1800" b="1">
                 <a:solidFill>
                   <a:srgbClr val="1F40CB"/>
                 </a:solidFill>
@@ -2163,7 +2163,7 @@
         </p:spPr>
         <p:txBody>
           <a:bodyPr xmlns:a="http://schemas.openxmlformats.org/drawingml/2006/main" wrap="square" lIns="0" tIns="0" rIns="0" bIns="0" anchor="ctr">
-            <a:normAutofit fontScale="100000"/>
+            <a:noAutofit/>
           </a:bodyPr>
           <a:lstStyle xmlns:a="http://schemas.openxmlformats.org/drawingml/2006/main"/>
           <a:p xmlns:a="http://schemas.openxmlformats.org/drawingml/2006/main">
@@ -2182,7 +2182,7 @@
               </a:defRPr>
             </a:pPr>
             <a:r>
-              <a:rPr sz="1275" b="1">
+              <a:rPr sz="1800" b="1">
                 <a:solidFill>
                   <a:srgbClr val="1F40CB"/>
                 </a:solidFill>
@@ -2551,7 +2551,7 @@
         </p:spPr>
         <p:txBody>
           <a:bodyPr xmlns:a="http://schemas.openxmlformats.org/drawingml/2006/main" wrap="square" lIns="0" tIns="0" rIns="0" bIns="0" anchor="ctr">
-            <a:normAutofit fontScale="100000"/>
+            <a:noAutofit/>
           </a:bodyPr>
           <a:lstStyle xmlns:a="http://schemas.openxmlformats.org/drawingml/2006/main"/>
           <a:p xmlns:a="http://schemas.openxmlformats.org/drawingml/2006/main">
@@ -2570,7 +2570,7 @@
               </a:defRPr>
             </a:pPr>
             <a:r>
-              <a:rPr sz="1275" b="1">
+              <a:rPr sz="1800" b="1">
                 <a:solidFill>
                   <a:srgbClr val="1F40CB"/>
                 </a:solidFill>
@@ -2973,7 +2973,7 @@
       </p:sp>
       <p:cxnSp>
         <p:nvCxnSpPr>
-          <p:cNvPr id="110" name=""/>
+          <p:cNvPr id="230" name=""/>
           <p:cNvCxnSpPr>
             <a:stCxn xmlns:a="http://schemas.openxmlformats.org/drawingml/2006/main" id="14" idx="2"/>
             <a:endCxn xmlns:a="http://schemas.openxmlformats.org/drawingml/2006/main" id="16" idx="0"/>
@@ -2999,7 +2999,7 @@
       </p:cxnSp>
       <p:cxnSp>
         <p:nvCxnSpPr>
-          <p:cNvPr id="111" name=""/>
+          <p:cNvPr id="231" name=""/>
           <p:cNvCxnSpPr>
             <a:stCxn xmlns:a="http://schemas.openxmlformats.org/drawingml/2006/main" id="14" idx="2"/>
             <a:endCxn xmlns:a="http://schemas.openxmlformats.org/drawingml/2006/main" id="18" idx="0"/>
@@ -3025,7 +3025,7 @@
       </p:cxnSp>
       <p:cxnSp>
         <p:nvCxnSpPr>
-          <p:cNvPr id="112" name=""/>
+          <p:cNvPr id="232" name=""/>
           <p:cNvCxnSpPr>
             <a:stCxn xmlns:a="http://schemas.openxmlformats.org/drawingml/2006/main" id="14" idx="2"/>
             <a:endCxn xmlns:a="http://schemas.openxmlformats.org/drawingml/2006/main" id="20" idx="0"/>
@@ -3141,7 +3141,7 @@
         </p:spPr>
         <p:txBody>
           <a:bodyPr xmlns:a="http://schemas.openxmlformats.org/drawingml/2006/main" wrap="square" lIns="0" tIns="0" rIns="0" bIns="0" anchor="ctr">
-            <a:normAutofit fontScale="100000"/>
+            <a:noAutofit/>
           </a:bodyPr>
           <a:lstStyle xmlns:a="http://schemas.openxmlformats.org/drawingml/2006/main"/>
           <a:p xmlns:a="http://schemas.openxmlformats.org/drawingml/2006/main">
@@ -3160,7 +3160,7 @@
               </a:defRPr>
             </a:pPr>
             <a:r>
-              <a:rPr sz="1275" b="1">
+              <a:rPr sz="1800" b="1">
                 <a:solidFill>
                   <a:srgbClr val="1F40CB"/>
                 </a:solidFill>
@@ -3238,7 +3238,7 @@
         </p:spPr>
         <p:txBody>
           <a:bodyPr xmlns:a="http://schemas.openxmlformats.org/drawingml/2006/main" wrap="square" lIns="0" tIns="0" rIns="0" bIns="0" anchor="ctr">
-            <a:normAutofit fontScale="100000"/>
+            <a:noAutofit/>
           </a:bodyPr>
           <a:lstStyle xmlns:a="http://schemas.openxmlformats.org/drawingml/2006/main"/>
           <a:p xmlns:a="http://schemas.openxmlformats.org/drawingml/2006/main">
@@ -3257,7 +3257,7 @@
               </a:defRPr>
             </a:pPr>
             <a:r>
-              <a:rPr sz="1350" b="1">
+              <a:rPr sz="1800" b="1">
                 <a:solidFill>
                   <a:srgbClr val="1F40CB"/>
                 </a:solidFill>
@@ -3383,8 +3383,8 @@
         </p:nvSpPr>
         <p:spPr>
           <a:xfrm xmlns:a="http://schemas.openxmlformats.org/drawingml/2006/main">
-            <a:off x="10953750" y="4476750"/>
-            <a:ext cx="2952750" cy="266700"/>
+            <a:off x="10953750" y="4457700"/>
+            <a:ext cx="2952750" cy="304800"/>
           </a:xfrm>
           <a:prstGeom xmlns:a="http://schemas.openxmlformats.org/drawingml/2006/main" prst="rect">
             <a:avLst/>
@@ -3397,7 +3397,7 @@
         </p:spPr>
         <p:txBody>
           <a:bodyPr xmlns:a="http://schemas.openxmlformats.org/drawingml/2006/main" wrap="square" lIns="0" tIns="0" rIns="0" bIns="0" anchor="ctr">
-            <a:normAutofit fontScale="100000"/>
+            <a:noAutofit/>
           </a:bodyPr>
           <a:lstStyle xmlns:a="http://schemas.openxmlformats.org/drawingml/2006/main"/>
           <a:p xmlns:a="http://schemas.openxmlformats.org/drawingml/2006/main">
@@ -3416,7 +3416,7 @@
               </a:defRPr>
             </a:pPr>
             <a:r>
-              <a:rPr sz="1200" b="1">
+              <a:rPr sz="1800" b="1">
                 <a:solidFill>
                   <a:srgbClr val="F07D00"/>
                 </a:solidFill>
@@ -3988,7 +3988,7 @@
         </p:spPr>
         <p:txBody>
           <a:bodyPr xmlns:a="http://schemas.openxmlformats.org/drawingml/2006/main" wrap="square" lIns="0" tIns="0" rIns="0" bIns="0" anchor="ctr">
-            <a:normAutofit fontScale="100000"/>
+            <a:noAutofit/>
           </a:bodyPr>
           <a:lstStyle xmlns:a="http://schemas.openxmlformats.org/drawingml/2006/main"/>
           <a:p xmlns:a="http://schemas.openxmlformats.org/drawingml/2006/main">
@@ -4007,7 +4007,7 @@
               </a:defRPr>
             </a:pPr>
             <a:r>
-              <a:rPr sz="1425" b="1">
+              <a:rPr sz="1800" b="1">
                 <a:solidFill>
                   <a:srgbClr val="1F40CB"/>
                 </a:solidFill>
@@ -4112,7 +4112,7 @@
         </p:spPr>
         <p:txBody>
           <a:bodyPr xmlns:a="http://schemas.openxmlformats.org/drawingml/2006/main" wrap="square" lIns="0" tIns="0" rIns="0" bIns="0" anchor="ctr">
-            <a:normAutofit fontScale="100000"/>
+            <a:noAutofit/>
           </a:bodyPr>
           <a:lstStyle xmlns:a="http://schemas.openxmlformats.org/drawingml/2006/main"/>
           <a:p xmlns:a="http://schemas.openxmlformats.org/drawingml/2006/main">
@@ -4131,7 +4131,7 @@
               </a:defRPr>
             </a:pPr>
             <a:r>
-              <a:rPr sz="1350" b="1">
+              <a:rPr sz="1800" b="1">
                 <a:solidFill>
                   <a:srgbClr val="F07D00"/>
                 </a:solidFill>
@@ -4139,7 +4139,7 @@
                 <a:ea typeface="Calibri"/>
                 <a:cs typeface="Calibri"/>
               </a:rPr>
-              <a:t>KEYWORD · EXACT TERMS</a:t>
+              <a:t>KEYWORD · EXACT</a:t>
             </a:r>
           </a:p>
         </p:txBody>
@@ -4236,7 +4236,7 @@
                 <a:ea typeface="Courier New"/>
                 <a:cs typeface="Courier New"/>
               </a:rPr>
-              <a:t>R1  SU-MARGIN  18.7%</a:t>
+              <a:t>R1  SU-TABLE  18.7%</a:t>
             </a:r>
           </a:p>
           <a:p xmlns:a="http://schemas.openxmlformats.org/drawingml/2006/main">
@@ -4395,7 +4395,7 @@
         </p:spPr>
         <p:txBody>
           <a:bodyPr xmlns:a="http://schemas.openxmlformats.org/drawingml/2006/main" wrap="square" lIns="0" tIns="0" rIns="0" bIns="0" anchor="ctr">
-            <a:normAutofit fontScale="100000"/>
+            <a:noAutofit/>
           </a:bodyPr>
           <a:lstStyle xmlns:a="http://schemas.openxmlformats.org/drawingml/2006/main"/>
           <a:p xmlns:a="http://schemas.openxmlformats.org/drawingml/2006/main">
@@ -4414,7 +4414,7 @@
               </a:defRPr>
             </a:pPr>
             <a:r>
-              <a:rPr sz="1575" b="1">
+              <a:rPr sz="1800" b="1">
                 <a:solidFill>
                   <a:srgbClr val="F07D00"/>
                 </a:solidFill>
@@ -4457,7 +4457,7 @@
         </p:spPr>
         <p:txBody>
           <a:bodyPr xmlns:a="http://schemas.openxmlformats.org/drawingml/2006/main" wrap="square" lIns="0" tIns="0" rIns="0" bIns="0" anchor="ctr">
-            <a:normAutofit fontScale="100000"/>
+            <a:noAutofit/>
           </a:bodyPr>
           <a:lstStyle xmlns:a="http://schemas.openxmlformats.org/drawingml/2006/main"/>
           <a:p xmlns:a="http://schemas.openxmlformats.org/drawingml/2006/main">
@@ -4476,7 +4476,7 @@
               </a:defRPr>
             </a:pPr>
             <a:r>
-              <a:rPr sz="1350" b="1">
+              <a:rPr sz="1800" b="1">
                 <a:solidFill>
                   <a:srgbClr val="2E8B57"/>
                 </a:solidFill>
@@ -4554,7 +4554,7 @@
         </p:spPr>
         <p:txBody>
           <a:bodyPr xmlns:a="http://schemas.openxmlformats.org/drawingml/2006/main" wrap="square" lIns="0" tIns="0" rIns="0" bIns="0" anchor="ctr">
-            <a:normAutofit fontScale="100000"/>
+            <a:noAutofit/>
           </a:bodyPr>
           <a:lstStyle xmlns:a="http://schemas.openxmlformats.org/drawingml/2006/main"/>
           <a:p xmlns:a="http://schemas.openxmlformats.org/drawingml/2006/main">
@@ -4573,7 +4573,7 @@
               </a:defRPr>
             </a:pPr>
             <a:r>
-              <a:rPr sz="1350" b="1">
+              <a:rPr sz="1800" b="1">
                 <a:solidFill>
                   <a:srgbClr val="051C2A"/>
                 </a:solidFill>
@@ -4651,7 +4651,7 @@
         </p:spPr>
         <p:txBody>
           <a:bodyPr xmlns:a="http://schemas.openxmlformats.org/drawingml/2006/main" wrap="square" lIns="0" tIns="0" rIns="0" bIns="0" anchor="ctr">
-            <a:normAutofit fontScale="100000"/>
+            <a:noAutofit/>
           </a:bodyPr>
           <a:lstStyle xmlns:a="http://schemas.openxmlformats.org/drawingml/2006/main"/>
           <a:p xmlns:a="http://schemas.openxmlformats.org/drawingml/2006/main">
@@ -4670,7 +4670,7 @@
               </a:defRPr>
             </a:pPr>
             <a:r>
-              <a:rPr sz="1350" b="1">
+              <a:rPr sz="1800" b="1">
                 <a:solidFill>
                   <a:srgbClr val="051C2A"/>
                 </a:solidFill>
@@ -4748,7 +4748,7 @@
         </p:spPr>
         <p:txBody>
           <a:bodyPr xmlns:a="http://schemas.openxmlformats.org/drawingml/2006/main" wrap="square" lIns="0" tIns="0" rIns="0" bIns="0" anchor="ctr">
-            <a:normAutofit fontScale="100000"/>
+            <a:noAutofit/>
           </a:bodyPr>
           <a:lstStyle xmlns:a="http://schemas.openxmlformats.org/drawingml/2006/main"/>
           <a:p xmlns:a="http://schemas.openxmlformats.org/drawingml/2006/main">
@@ -4767,7 +4767,7 @@
               </a:defRPr>
             </a:pPr>
             <a:r>
-              <a:rPr sz="1350" b="1">
+              <a:rPr sz="1800" b="1">
                 <a:solidFill>
                   <a:srgbClr val="051C2A"/>
                 </a:solidFill>
@@ -5419,7 +5419,7 @@
         </p:spPr>
         <p:txBody>
           <a:bodyPr xmlns:a="http://schemas.openxmlformats.org/drawingml/2006/main" wrap="square" lIns="0" tIns="0" rIns="0" bIns="0" anchor="ctr">
-            <a:normAutofit fontScale="100000"/>
+            <a:noAutofit/>
           </a:bodyPr>
           <a:lstStyle xmlns:a="http://schemas.openxmlformats.org/drawingml/2006/main"/>
           <a:p xmlns:a="http://schemas.openxmlformats.org/drawingml/2006/main">
@@ -5438,7 +5438,7 @@
               </a:defRPr>
             </a:pPr>
             <a:r>
-              <a:rPr sz="1575" b="1">
+              <a:rPr sz="1800" b="1">
                 <a:solidFill>
                   <a:srgbClr val="2E8B57"/>
                 </a:solidFill>
@@ -5514,7 +5514,7 @@
         </p:spPr>
         <p:txBody>
           <a:bodyPr xmlns:a="http://schemas.openxmlformats.org/drawingml/2006/main" wrap="square" lIns="0" tIns="0" rIns="0" bIns="0" anchor="ctr">
-            <a:normAutofit fontScale="100000"/>
+            <a:noAutofit/>
           </a:bodyPr>
           <a:lstStyle xmlns:a="http://schemas.openxmlformats.org/drawingml/2006/main"/>
           <a:p xmlns:a="http://schemas.openxmlformats.org/drawingml/2006/main">
@@ -5533,7 +5533,7 @@
               </a:defRPr>
             </a:pPr>
             <a:r>
-              <a:rPr sz="1275" b="1">
+              <a:rPr sz="1800" b="1">
                 <a:solidFill>
                   <a:srgbClr val="1F40CB"/>
                 </a:solidFill>
@@ -5576,7 +5576,7 @@
         </p:spPr>
         <p:txBody>
           <a:bodyPr xmlns:a="http://schemas.openxmlformats.org/drawingml/2006/main" wrap="square" lIns="0" tIns="0" rIns="0" bIns="0" anchor="ctr">
-            <a:normAutofit fontScale="100000"/>
+            <a:noAutofit/>
           </a:bodyPr>
           <a:lstStyle xmlns:a="http://schemas.openxmlformats.org/drawingml/2006/main"/>
           <a:p xmlns:a="http://schemas.openxmlformats.org/drawingml/2006/main">
@@ -5595,7 +5595,7 @@
               </a:defRPr>
             </a:pPr>
             <a:r>
-              <a:rPr sz="1275" b="0">
+              <a:rPr sz="1800" b="0">
                 <a:solidFill>
                   <a:srgbClr val="64748B"/>
                 </a:solidFill>
@@ -5700,7 +5700,7 @@
         </p:spPr>
         <p:txBody>
           <a:bodyPr xmlns:a="http://schemas.openxmlformats.org/drawingml/2006/main" wrap="square" lIns="0" tIns="0" rIns="0" bIns="0" anchor="ctr">
-            <a:normAutofit fontScale="100000"/>
+            <a:noAutofit/>
           </a:bodyPr>
           <a:lstStyle xmlns:a="http://schemas.openxmlformats.org/drawingml/2006/main"/>
           <a:p xmlns:a="http://schemas.openxmlformats.org/drawingml/2006/main">
@@ -5719,7 +5719,7 @@
               </a:defRPr>
             </a:pPr>
             <a:r>
-              <a:rPr sz="1275" b="0">
+              <a:rPr sz="1800" b="0">
                 <a:solidFill>
                   <a:srgbClr val="64748B"/>
                 </a:solidFill>
@@ -5824,7 +5824,7 @@
         </p:spPr>
         <p:txBody>
           <a:bodyPr xmlns:a="http://schemas.openxmlformats.org/drawingml/2006/main" wrap="square" lIns="0" tIns="0" rIns="0" bIns="0" anchor="ctr">
-            <a:normAutofit fontScale="100000"/>
+            <a:noAutofit/>
           </a:bodyPr>
           <a:lstStyle xmlns:a="http://schemas.openxmlformats.org/drawingml/2006/main"/>
           <a:p xmlns:a="http://schemas.openxmlformats.org/drawingml/2006/main">
@@ -5843,7 +5843,7 @@
               </a:defRPr>
             </a:pPr>
             <a:r>
-              <a:rPr sz="1275" b="0">
+              <a:rPr sz="1800" b="0">
                 <a:solidFill>
                   <a:srgbClr val="64748B"/>
                 </a:solidFill>
@@ -5948,7 +5948,7 @@
         </p:spPr>
         <p:txBody>
           <a:bodyPr xmlns:a="http://schemas.openxmlformats.org/drawingml/2006/main" wrap="square" lIns="0" tIns="0" rIns="0" bIns="0" anchor="ctr">
-            <a:normAutofit fontScale="100000"/>
+            <a:noAutofit/>
           </a:bodyPr>
           <a:lstStyle xmlns:a="http://schemas.openxmlformats.org/drawingml/2006/main"/>
           <a:p xmlns:a="http://schemas.openxmlformats.org/drawingml/2006/main">
@@ -5967,7 +5967,7 @@
               </a:defRPr>
             </a:pPr>
             <a:r>
-              <a:rPr sz="1275" b="0">
+              <a:rPr sz="1800" b="0">
                 <a:solidFill>
                   <a:srgbClr val="64748B"/>
                 </a:solidFill>
@@ -6353,7 +6353,7 @@
         </p:spPr>
         <p:txBody>
           <a:bodyPr xmlns:a="http://schemas.openxmlformats.org/drawingml/2006/main" wrap="square" lIns="0" tIns="0" rIns="0" bIns="0" anchor="ctr">
-            <a:normAutofit fontScale="100000"/>
+            <a:noAutofit/>
           </a:bodyPr>
           <a:lstStyle xmlns:a="http://schemas.openxmlformats.org/drawingml/2006/main"/>
           <a:p xmlns:a="http://schemas.openxmlformats.org/drawingml/2006/main">
@@ -6372,7 +6372,7 @@
               </a:defRPr>
             </a:pPr>
             <a:r>
-              <a:rPr sz="1425" b="1">
+              <a:rPr sz="1800" b="1">
                 <a:solidFill>
                   <a:srgbClr val="1F40CB"/>
                 </a:solidFill>
@@ -6779,8 +6779,8 @@
         </p:nvSpPr>
         <p:spPr>
           <a:xfrm xmlns:a="http://schemas.openxmlformats.org/drawingml/2006/main">
-            <a:off x="1257300" y="2838450"/>
-            <a:ext cx="2781300" cy="266700"/>
+            <a:off x="1257300" y="2819400"/>
+            <a:ext cx="2781300" cy="304800"/>
           </a:xfrm>
           <a:prstGeom xmlns:a="http://schemas.openxmlformats.org/drawingml/2006/main" prst="rect">
             <a:avLst/>
@@ -6793,7 +6793,7 @@
         </p:spPr>
         <p:txBody>
           <a:bodyPr xmlns:a="http://schemas.openxmlformats.org/drawingml/2006/main" wrap="square" lIns="0" tIns="0" rIns="0" bIns="0" anchor="ctr">
-            <a:normAutofit fontScale="100000"/>
+            <a:noAutofit/>
           </a:bodyPr>
           <a:lstStyle xmlns:a="http://schemas.openxmlformats.org/drawingml/2006/main"/>
           <a:p xmlns:a="http://schemas.openxmlformats.org/drawingml/2006/main">
@@ -6812,7 +6812,7 @@
               </a:defRPr>
             </a:pPr>
             <a:r>
-              <a:rPr sz="1200" b="1">
+              <a:rPr sz="1800" b="1">
                 <a:solidFill>
                   <a:srgbClr val="1F40CB"/>
                 </a:solidFill>
@@ -6938,8 +6938,8 @@
         </p:nvSpPr>
         <p:spPr>
           <a:xfrm xmlns:a="http://schemas.openxmlformats.org/drawingml/2006/main">
-            <a:off x="1257300" y="4038600"/>
-            <a:ext cx="2781300" cy="266700"/>
+            <a:off x="1257300" y="4019550"/>
+            <a:ext cx="2781300" cy="304800"/>
           </a:xfrm>
           <a:prstGeom xmlns:a="http://schemas.openxmlformats.org/drawingml/2006/main" prst="rect">
             <a:avLst/>
@@ -6952,7 +6952,7 @@
         </p:spPr>
         <p:txBody>
           <a:bodyPr xmlns:a="http://schemas.openxmlformats.org/drawingml/2006/main" wrap="square" lIns="0" tIns="0" rIns="0" bIns="0" anchor="ctr">
-            <a:normAutofit fontScale="100000"/>
+            <a:noAutofit/>
           </a:bodyPr>
           <a:lstStyle xmlns:a="http://schemas.openxmlformats.org/drawingml/2006/main"/>
           <a:p xmlns:a="http://schemas.openxmlformats.org/drawingml/2006/main">
@@ -6971,7 +6971,7 @@
               </a:defRPr>
             </a:pPr>
             <a:r>
-              <a:rPr sz="1200" b="1">
+              <a:rPr sz="1800" b="1">
                 <a:solidFill>
                   <a:srgbClr val="1F40CB"/>
                 </a:solidFill>
@@ -7097,8 +7097,8 @@
         </p:nvSpPr>
         <p:spPr>
           <a:xfrm xmlns:a="http://schemas.openxmlformats.org/drawingml/2006/main">
-            <a:off x="1257300" y="5238750"/>
-            <a:ext cx="2781300" cy="266700"/>
+            <a:off x="1257300" y="5219700"/>
+            <a:ext cx="2781300" cy="304800"/>
           </a:xfrm>
           <a:prstGeom xmlns:a="http://schemas.openxmlformats.org/drawingml/2006/main" prst="rect">
             <a:avLst/>
@@ -7111,7 +7111,7 @@
         </p:spPr>
         <p:txBody>
           <a:bodyPr xmlns:a="http://schemas.openxmlformats.org/drawingml/2006/main" wrap="square" lIns="0" tIns="0" rIns="0" bIns="0" anchor="ctr">
-            <a:normAutofit fontScale="100000"/>
+            <a:noAutofit/>
           </a:bodyPr>
           <a:lstStyle xmlns:a="http://schemas.openxmlformats.org/drawingml/2006/main"/>
           <a:p xmlns:a="http://schemas.openxmlformats.org/drawingml/2006/main">
@@ -7130,7 +7130,7 @@
               </a:defRPr>
             </a:pPr>
             <a:r>
-              <a:rPr sz="1200" b="1">
+              <a:rPr sz="1800" b="1">
                 <a:solidFill>
                   <a:srgbClr val="1F40CB"/>
                 </a:solidFill>
@@ -7256,8 +7256,8 @@
         </p:nvSpPr>
         <p:spPr>
           <a:xfrm xmlns:a="http://schemas.openxmlformats.org/drawingml/2006/main">
-            <a:off x="11201400" y="2838450"/>
-            <a:ext cx="2781300" cy="266700"/>
+            <a:off x="11201400" y="2819400"/>
+            <a:ext cx="2781300" cy="304800"/>
           </a:xfrm>
           <a:prstGeom xmlns:a="http://schemas.openxmlformats.org/drawingml/2006/main" prst="rect">
             <a:avLst/>
@@ -7270,7 +7270,7 @@
         </p:spPr>
         <p:txBody>
           <a:bodyPr xmlns:a="http://schemas.openxmlformats.org/drawingml/2006/main" wrap="square" lIns="0" tIns="0" rIns="0" bIns="0" anchor="ctr">
-            <a:normAutofit fontScale="100000"/>
+            <a:noAutofit/>
           </a:bodyPr>
           <a:lstStyle xmlns:a="http://schemas.openxmlformats.org/drawingml/2006/main"/>
           <a:p xmlns:a="http://schemas.openxmlformats.org/drawingml/2006/main">
@@ -7289,7 +7289,7 @@
               </a:defRPr>
             </a:pPr>
             <a:r>
-              <a:rPr sz="1200" b="1">
+              <a:rPr sz="1800" b="1">
                 <a:solidFill>
                   <a:srgbClr val="1F40CB"/>
                 </a:solidFill>
@@ -7415,8 +7415,8 @@
         </p:nvSpPr>
         <p:spPr>
           <a:xfrm xmlns:a="http://schemas.openxmlformats.org/drawingml/2006/main">
-            <a:off x="11201400" y="4038600"/>
-            <a:ext cx="2781300" cy="266700"/>
+            <a:off x="11201400" y="4019550"/>
+            <a:ext cx="2781300" cy="304800"/>
           </a:xfrm>
           <a:prstGeom xmlns:a="http://schemas.openxmlformats.org/drawingml/2006/main" prst="rect">
             <a:avLst/>
@@ -7429,7 +7429,7 @@
         </p:spPr>
         <p:txBody>
           <a:bodyPr xmlns:a="http://schemas.openxmlformats.org/drawingml/2006/main" wrap="square" lIns="0" tIns="0" rIns="0" bIns="0" anchor="ctr">
-            <a:normAutofit fontScale="100000"/>
+            <a:noAutofit/>
           </a:bodyPr>
           <a:lstStyle xmlns:a="http://schemas.openxmlformats.org/drawingml/2006/main"/>
           <a:p xmlns:a="http://schemas.openxmlformats.org/drawingml/2006/main">
@@ -7448,7 +7448,7 @@
               </a:defRPr>
             </a:pPr>
             <a:r>
-              <a:rPr sz="1200" b="1">
+              <a:rPr sz="1800" b="1">
                 <a:solidFill>
                   <a:srgbClr val="1F40CB"/>
                 </a:solidFill>
@@ -7574,8 +7574,70 @@
         </p:nvSpPr>
         <p:spPr>
           <a:xfrm xmlns:a="http://schemas.openxmlformats.org/drawingml/2006/main">
-            <a:off x="11201400" y="5238750"/>
-            <a:ext cx="2781300" cy="266700"/>
+            <a:off x="11201400" y="5219700"/>
+            <a:ext cx="2781300" cy="304800"/>
+          </a:xfrm>
+          <a:prstGeom xmlns:a="http://schemas.openxmlformats.org/drawingml/2006/main" prst="rect">
+            <a:avLst/>
+          </a:prstGeom>
+          <a:noFill xmlns:a="http://schemas.openxmlformats.org/drawingml/2006/main"/>
+          <a:ln xmlns:a="http://schemas.openxmlformats.org/drawingml/2006/main" w="0">
+            <a:noFill/>
+            <a:prstDash val="solid"/>
+          </a:ln>
+        </p:spPr>
+        <p:txBody>
+          <a:bodyPr xmlns:a="http://schemas.openxmlformats.org/drawingml/2006/main" wrap="square" lIns="0" tIns="0" rIns="0" bIns="0" anchor="ctr">
+            <a:noAutofit/>
+          </a:bodyPr>
+          <a:lstStyle xmlns:a="http://schemas.openxmlformats.org/drawingml/2006/main"/>
+          <a:p xmlns:a="http://schemas.openxmlformats.org/drawingml/2006/main">
+            <a:pPr algn="l">
+              <a:lnSpc>
+                <a:spcPct val="100000"/>
+              </a:lnSpc>
+              <a:buNone/>
+              <a:defRPr sz="1200" b="1">
+                <a:solidFill>
+                  <a:srgbClr val="1F40CB"/>
+                </a:solidFill>
+                <a:latin typeface="Calibri"/>
+                <a:ea typeface="Calibri"/>
+                <a:cs typeface="Calibri"/>
+              </a:defRPr>
+            </a:pPr>
+            <a:r>
+              <a:rPr sz="1800" b="1">
+                <a:solidFill>
+                  <a:srgbClr val="1F40CB"/>
+                </a:solidFill>
+                <a:latin typeface="Calibri"/>
+                <a:ea typeface="Calibri"/>
+                <a:cs typeface="Calibri"/>
+              </a:rPr>
+              <a:t>ABSTAIN</a:t>
+            </a:r>
+          </a:p>
+        </p:txBody>
+      </p:sp>
+      <p:sp>
+        <p:nvSpPr>
+          <p:cNvPr id="25" name="">
+            <a:extLst xmlns:a="http://schemas.openxmlformats.org/drawingml/2006/main">
+              <a:ext uri="{FF2B5EF4-FFF2-40B4-BE49-F238E27FC236}">
+                <a16:creationId xmlns:a16="http://schemas.microsoft.com/office/drawing/2014/main" id="{4B137DBE-0373-4B7D-89B2-62CEDDD2AF0A}"/>
+              </a:ext>
+            </a:extLst>
+          </p:cNvPr>
+          <p:cNvSpPr>
+            <a:spLocks xmlns:a="http://schemas.openxmlformats.org/drawingml/2006/main" noGrp="1"/>
+          </p:cNvSpPr>
+          <p:nvPr/>
+        </p:nvSpPr>
+        <p:spPr>
+          <a:xfrm xmlns:a="http://schemas.openxmlformats.org/drawingml/2006/main">
+            <a:off x="11201400" y="5524500"/>
+            <a:ext cx="2781300" cy="361950"/>
           </a:xfrm>
           <a:prstGeom xmlns:a="http://schemas.openxmlformats.org/drawingml/2006/main" prst="rect">
             <a:avLst/>
@@ -7597,68 +7659,6 @@
                 <a:spcPct val="100000"/>
               </a:lnSpc>
               <a:buNone/>
-              <a:defRPr sz="1200" b="1">
-                <a:solidFill>
-                  <a:srgbClr val="1F40CB"/>
-                </a:solidFill>
-                <a:latin typeface="Calibri"/>
-                <a:ea typeface="Calibri"/>
-                <a:cs typeface="Calibri"/>
-              </a:defRPr>
-            </a:pPr>
-            <a:r>
-              <a:rPr sz="1200" b="1">
-                <a:solidFill>
-                  <a:srgbClr val="1F40CB"/>
-                </a:solidFill>
-                <a:latin typeface="Calibri"/>
-                <a:ea typeface="Calibri"/>
-                <a:cs typeface="Calibri"/>
-              </a:rPr>
-              <a:t>ABSTAIN</a:t>
-            </a:r>
-          </a:p>
-        </p:txBody>
-      </p:sp>
-      <p:sp>
-        <p:nvSpPr>
-          <p:cNvPr id="25" name="">
-            <a:extLst xmlns:a="http://schemas.openxmlformats.org/drawingml/2006/main">
-              <a:ext uri="{FF2B5EF4-FFF2-40B4-BE49-F238E27FC236}">
-                <a16:creationId xmlns:a16="http://schemas.microsoft.com/office/drawing/2014/main" id="{4B137DBE-0373-4B7D-89B2-62CEDDD2AF0A}"/>
-              </a:ext>
-            </a:extLst>
-          </p:cNvPr>
-          <p:cNvSpPr>
-            <a:spLocks xmlns:a="http://schemas.openxmlformats.org/drawingml/2006/main" noGrp="1"/>
-          </p:cNvSpPr>
-          <p:nvPr/>
-        </p:nvSpPr>
-        <p:spPr>
-          <a:xfrm xmlns:a="http://schemas.openxmlformats.org/drawingml/2006/main">
-            <a:off x="11201400" y="5524500"/>
-            <a:ext cx="2781300" cy="361950"/>
-          </a:xfrm>
-          <a:prstGeom xmlns:a="http://schemas.openxmlformats.org/drawingml/2006/main" prst="rect">
-            <a:avLst/>
-          </a:prstGeom>
-          <a:noFill xmlns:a="http://schemas.openxmlformats.org/drawingml/2006/main"/>
-          <a:ln xmlns:a="http://schemas.openxmlformats.org/drawingml/2006/main" w="0">
-            <a:noFill/>
-            <a:prstDash val="solid"/>
-          </a:ln>
-        </p:spPr>
-        <p:txBody>
-          <a:bodyPr xmlns:a="http://schemas.openxmlformats.org/drawingml/2006/main" wrap="square" lIns="0" tIns="0" rIns="0" bIns="0" anchor="ctr">
-            <a:normAutofit fontScale="100000"/>
-          </a:bodyPr>
-          <a:lstStyle xmlns:a="http://schemas.openxmlformats.org/drawingml/2006/main"/>
-          <a:p xmlns:a="http://schemas.openxmlformats.org/drawingml/2006/main">
-            <a:pPr algn="l">
-              <a:lnSpc>
-                <a:spcPct val="100000"/>
-              </a:lnSpc>
-              <a:buNone/>
               <a:defRPr sz="1500" b="1">
                 <a:solidFill>
                   <a:srgbClr val="051C2A"/>
@@ -7684,7 +7684,7 @@
       </p:sp>
       <p:cxnSp>
         <p:nvCxnSpPr>
-          <p:cNvPr id="125" name=""/>
+          <p:cNvPr id="280" name=""/>
           <p:cNvCxnSpPr>
             <a:stCxn xmlns:a="http://schemas.openxmlformats.org/drawingml/2006/main" id="8" idx="3"/>
             <a:endCxn xmlns:a="http://schemas.openxmlformats.org/drawingml/2006/main" id="3" idx="1"/>
@@ -7710,7 +7710,7 @@
       </p:cxnSp>
       <p:cxnSp>
         <p:nvCxnSpPr>
-          <p:cNvPr id="126" name=""/>
+          <p:cNvPr id="281" name=""/>
           <p:cNvCxnSpPr>
             <a:stCxn xmlns:a="http://schemas.openxmlformats.org/drawingml/2006/main" id="11" idx="3"/>
             <a:endCxn xmlns:a="http://schemas.openxmlformats.org/drawingml/2006/main" id="3" idx="1"/>
@@ -7736,7 +7736,7 @@
       </p:cxnSp>
       <p:cxnSp>
         <p:nvCxnSpPr>
-          <p:cNvPr id="127" name=""/>
+          <p:cNvPr id="282" name=""/>
           <p:cNvCxnSpPr>
             <a:stCxn xmlns:a="http://schemas.openxmlformats.org/drawingml/2006/main" id="14" idx="3"/>
             <a:endCxn xmlns:a="http://schemas.openxmlformats.org/drawingml/2006/main" id="3" idx="1"/>
@@ -7762,7 +7762,7 @@
       </p:cxnSp>
       <p:cxnSp>
         <p:nvCxnSpPr>
-          <p:cNvPr id="128" name=""/>
+          <p:cNvPr id="283" name=""/>
           <p:cNvCxnSpPr>
             <a:stCxn xmlns:a="http://schemas.openxmlformats.org/drawingml/2006/main" id="3" idx="3"/>
             <a:endCxn xmlns:a="http://schemas.openxmlformats.org/drawingml/2006/main" id="17" idx="1"/>
@@ -7788,7 +7788,7 @@
       </p:cxnSp>
       <p:cxnSp>
         <p:nvCxnSpPr>
-          <p:cNvPr id="129" name=""/>
+          <p:cNvPr id="284" name=""/>
           <p:cNvCxnSpPr>
             <a:stCxn xmlns:a="http://schemas.openxmlformats.org/drawingml/2006/main" id="3" idx="3"/>
             <a:endCxn xmlns:a="http://schemas.openxmlformats.org/drawingml/2006/main" id="20" idx="1"/>
@@ -7814,7 +7814,7 @@
       </p:cxnSp>
       <p:cxnSp>
         <p:nvCxnSpPr>
-          <p:cNvPr id="130" name=""/>
+          <p:cNvPr id="285" name=""/>
           <p:cNvCxnSpPr>
             <a:stCxn xmlns:a="http://schemas.openxmlformats.org/drawingml/2006/main" id="3" idx="3"/>
             <a:endCxn xmlns:a="http://schemas.openxmlformats.org/drawingml/2006/main" id="23" idx="1"/>
@@ -8211,7 +8211,7 @@
         </p:spPr>
         <p:txBody>
           <a:bodyPr xmlns:a="http://schemas.openxmlformats.org/drawingml/2006/main" wrap="square" lIns="0" tIns="0" rIns="0" bIns="0" anchor="ctr">
-            <a:normAutofit fontScale="100000"/>
+            <a:noAutofit/>
           </a:bodyPr>
           <a:lstStyle xmlns:a="http://schemas.openxmlformats.org/drawingml/2006/main"/>
           <a:p xmlns:a="http://schemas.openxmlformats.org/drawingml/2006/main">
@@ -8230,7 +8230,7 @@
               </a:defRPr>
             </a:pPr>
             <a:r>
-              <a:rPr sz="1425" b="1">
+              <a:rPr sz="1800" b="1">
                 <a:solidFill>
                   <a:srgbClr val="1F40CB"/>
                 </a:solidFill>
@@ -8335,7 +8335,7 @@
         </p:spPr>
         <p:txBody>
           <a:bodyPr xmlns:a="http://schemas.openxmlformats.org/drawingml/2006/main" wrap="square" lIns="0" tIns="0" rIns="0" bIns="0" anchor="ctr">
-            <a:normAutofit fontScale="100000"/>
+            <a:noAutofit/>
           </a:bodyPr>
           <a:lstStyle xmlns:a="http://schemas.openxmlformats.org/drawingml/2006/main"/>
           <a:p xmlns:a="http://schemas.openxmlformats.org/drawingml/2006/main">
@@ -8354,7 +8354,7 @@
               </a:defRPr>
             </a:pPr>
             <a:r>
-              <a:rPr sz="1350" b="1">
+              <a:rPr sz="1800" b="1">
                 <a:solidFill>
                   <a:srgbClr val="F07D00"/>
                 </a:solidFill>
@@ -8362,7 +8362,7 @@
                 <a:ea typeface="Calibri"/>
                 <a:cs typeface="Calibri"/>
               </a:rPr>
-              <a:t>KEYWORD RANKS · w=1</a:t>
+              <a:t>KEYWORD · w=1</a:t>
             </a:r>
           </a:p>
         </p:txBody>
@@ -8432,7 +8432,7 @@
         </p:spPr>
         <p:txBody>
           <a:bodyPr xmlns:a="http://schemas.openxmlformats.org/drawingml/2006/main" wrap="square" lIns="0" tIns="0" rIns="0" bIns="0" anchor="ctr">
-            <a:normAutofit fontScale="100000"/>
+            <a:noAutofit/>
           </a:bodyPr>
           <a:lstStyle xmlns:a="http://schemas.openxmlformats.org/drawingml/2006/main"/>
           <a:p xmlns:a="http://schemas.openxmlformats.org/drawingml/2006/main">
@@ -8451,7 +8451,7 @@
               </a:defRPr>
             </a:pPr>
             <a:r>
-              <a:rPr sz="1275" b="1">
+              <a:rPr sz="1800" b="1">
                 <a:solidFill>
                   <a:srgbClr val="FFFFFF"/>
                 </a:solidFill>
@@ -8529,7 +8529,7 @@
         </p:spPr>
         <p:txBody>
           <a:bodyPr xmlns:a="http://schemas.openxmlformats.org/drawingml/2006/main" wrap="square" lIns="0" tIns="0" rIns="0" bIns="0" anchor="ctr">
-            <a:normAutofit fontScale="100000"/>
+            <a:noAutofit/>
           </a:bodyPr>
           <a:lstStyle xmlns:a="http://schemas.openxmlformats.org/drawingml/2006/main"/>
           <a:p xmlns:a="http://schemas.openxmlformats.org/drawingml/2006/main">
@@ -8548,7 +8548,7 @@
               </a:defRPr>
             </a:pPr>
             <a:r>
-              <a:rPr sz="1275" b="1">
+              <a:rPr sz="1800" b="1">
                 <a:solidFill>
                   <a:srgbClr val="FFFFFF"/>
                 </a:solidFill>
@@ -8626,7 +8626,7 @@
         </p:spPr>
         <p:txBody>
           <a:bodyPr xmlns:a="http://schemas.openxmlformats.org/drawingml/2006/main" wrap="square" lIns="0" tIns="0" rIns="0" bIns="0" anchor="ctr">
-            <a:normAutofit fontScale="100000"/>
+            <a:noAutofit/>
           </a:bodyPr>
           <a:lstStyle xmlns:a="http://schemas.openxmlformats.org/drawingml/2006/main"/>
           <a:p xmlns:a="http://schemas.openxmlformats.org/drawingml/2006/main">
@@ -8645,7 +8645,7 @@
               </a:defRPr>
             </a:pPr>
             <a:r>
-              <a:rPr sz="1275" b="1">
+              <a:rPr sz="1800" b="1">
                 <a:solidFill>
                   <a:srgbClr val="FFFFFF"/>
                 </a:solidFill>
@@ -8723,7 +8723,7 @@
         </p:spPr>
         <p:txBody>
           <a:bodyPr xmlns:a="http://schemas.openxmlformats.org/drawingml/2006/main" wrap="square" lIns="0" tIns="0" rIns="0" bIns="0" anchor="ctr">
-            <a:normAutofit fontScale="100000"/>
+            <a:noAutofit/>
           </a:bodyPr>
           <a:lstStyle xmlns:a="http://schemas.openxmlformats.org/drawingml/2006/main"/>
           <a:p xmlns:a="http://schemas.openxmlformats.org/drawingml/2006/main">
@@ -8742,7 +8742,7 @@
               </a:defRPr>
             </a:pPr>
             <a:r>
-              <a:rPr sz="1275" b="1">
+              <a:rPr sz="1800" b="1">
                 <a:solidFill>
                   <a:srgbClr val="FFFFFF"/>
                 </a:solidFill>
@@ -8785,7 +8785,7 @@
         </p:spPr>
         <p:txBody>
           <a:bodyPr xmlns:a="http://schemas.openxmlformats.org/drawingml/2006/main" wrap="square" lIns="0" tIns="0" rIns="0" bIns="0" anchor="ctr">
-            <a:normAutofit fontScale="100000"/>
+            <a:noAutofit/>
           </a:bodyPr>
           <a:lstStyle xmlns:a="http://schemas.openxmlformats.org/drawingml/2006/main"/>
           <a:p xmlns:a="http://schemas.openxmlformats.org/drawingml/2006/main">
@@ -8804,7 +8804,7 @@
               </a:defRPr>
             </a:pPr>
             <a:r>
-              <a:rPr sz="1350" b="1">
+              <a:rPr sz="1800" b="1">
                 <a:solidFill>
                   <a:srgbClr val="F07D00"/>
                 </a:solidFill>
@@ -8812,7 +8812,7 @@
                 <a:ea typeface="Calibri"/>
                 <a:cs typeface="Calibri"/>
               </a:rPr>
-              <a:t>exact-term order</a:t>
+              <a:t>B = .03252</a:t>
             </a:r>
           </a:p>
         </p:txBody>
@@ -8847,7 +8847,7 @@
         </p:spPr>
         <p:txBody>
           <a:bodyPr xmlns:a="http://schemas.openxmlformats.org/drawingml/2006/main" wrap="square" lIns="0" tIns="0" rIns="0" bIns="0" anchor="ctr">
-            <a:normAutofit fontScale="100000"/>
+            <a:noAutofit/>
           </a:bodyPr>
           <a:lstStyle xmlns:a="http://schemas.openxmlformats.org/drawingml/2006/main"/>
           <a:p xmlns:a="http://schemas.openxmlformats.org/drawingml/2006/main">
@@ -8866,7 +8866,7 @@
               </a:defRPr>
             </a:pPr>
             <a:r>
-              <a:rPr sz="1350" b="1">
+              <a:rPr sz="1800" b="1">
                 <a:solidFill>
                   <a:srgbClr val="00A2EB"/>
                 </a:solidFill>
@@ -8944,7 +8944,7 @@
         </p:spPr>
         <p:txBody>
           <a:bodyPr xmlns:a="http://schemas.openxmlformats.org/drawingml/2006/main" wrap="square" lIns="0" tIns="0" rIns="0" bIns="0" anchor="ctr">
-            <a:normAutofit fontScale="100000"/>
+            <a:noAutofit/>
           </a:bodyPr>
           <a:lstStyle xmlns:a="http://schemas.openxmlformats.org/drawingml/2006/main"/>
           <a:p xmlns:a="http://schemas.openxmlformats.org/drawingml/2006/main">
@@ -8963,7 +8963,7 @@
               </a:defRPr>
             </a:pPr>
             <a:r>
-              <a:rPr sz="1275" b="1">
+              <a:rPr sz="1800" b="1">
                 <a:solidFill>
                   <a:srgbClr val="FFFFFF"/>
                 </a:solidFill>
@@ -9041,7 +9041,7 @@
         </p:spPr>
         <p:txBody>
           <a:bodyPr xmlns:a="http://schemas.openxmlformats.org/drawingml/2006/main" wrap="square" lIns="0" tIns="0" rIns="0" bIns="0" anchor="ctr">
-            <a:normAutofit fontScale="100000"/>
+            <a:noAutofit/>
           </a:bodyPr>
           <a:lstStyle xmlns:a="http://schemas.openxmlformats.org/drawingml/2006/main"/>
           <a:p xmlns:a="http://schemas.openxmlformats.org/drawingml/2006/main">
@@ -9060,7 +9060,7 @@
               </a:defRPr>
             </a:pPr>
             <a:r>
-              <a:rPr sz="1275" b="1">
+              <a:rPr sz="1800" b="1">
                 <a:solidFill>
                   <a:srgbClr val="FFFFFF"/>
                 </a:solidFill>
@@ -9138,7 +9138,7 @@
         </p:spPr>
         <p:txBody>
           <a:bodyPr xmlns:a="http://schemas.openxmlformats.org/drawingml/2006/main" wrap="square" lIns="0" tIns="0" rIns="0" bIns="0" anchor="ctr">
-            <a:normAutofit fontScale="100000"/>
+            <a:noAutofit/>
           </a:bodyPr>
           <a:lstStyle xmlns:a="http://schemas.openxmlformats.org/drawingml/2006/main"/>
           <a:p xmlns:a="http://schemas.openxmlformats.org/drawingml/2006/main">
@@ -9157,7 +9157,7 @@
               </a:defRPr>
             </a:pPr>
             <a:r>
-              <a:rPr sz="1275" b="1">
+              <a:rPr sz="1800" b="1">
                 <a:solidFill>
                   <a:srgbClr val="FFFFFF"/>
                 </a:solidFill>
@@ -9200,7 +9200,7 @@
         </p:spPr>
         <p:txBody>
           <a:bodyPr xmlns:a="http://schemas.openxmlformats.org/drawingml/2006/main" wrap="square" lIns="0" tIns="0" rIns="0" bIns="0" anchor="ctr">
-            <a:normAutofit fontScale="100000"/>
+            <a:noAutofit/>
           </a:bodyPr>
           <a:lstStyle xmlns:a="http://schemas.openxmlformats.org/drawingml/2006/main"/>
           <a:p xmlns:a="http://schemas.openxmlformats.org/drawingml/2006/main">
@@ -9219,7 +9219,7 @@
               </a:defRPr>
             </a:pPr>
             <a:r>
-              <a:rPr sz="1350" b="1">
+              <a:rPr sz="1800" b="1">
                 <a:solidFill>
                   <a:srgbClr val="00A2EB"/>
                 </a:solidFill>
@@ -9227,7 +9227,7 @@
                 <a:ea typeface="Calibri"/>
                 <a:cs typeface="Calibri"/>
               </a:rPr>
-              <a:t>semantic order</a:t>
+              <a:t>A = .03227</a:t>
             </a:r>
           </a:p>
         </p:txBody>
@@ -9262,7 +9262,7 @@
         </p:spPr>
         <p:txBody>
           <a:bodyPr xmlns:a="http://schemas.openxmlformats.org/drawingml/2006/main" wrap="square" lIns="0" tIns="0" rIns="0" bIns="0" anchor="ctr">
-            <a:normAutofit fontScale="100000"/>
+            <a:noAutofit/>
           </a:bodyPr>
           <a:lstStyle xmlns:a="http://schemas.openxmlformats.org/drawingml/2006/main"/>
           <a:p xmlns:a="http://schemas.openxmlformats.org/drawingml/2006/main">
@@ -9281,7 +9281,7 @@
               </a:defRPr>
             </a:pPr>
             <a:r>
-              <a:rPr sz="1350" b="1">
+              <a:rPr sz="1800" b="1">
                 <a:solidFill>
                   <a:srgbClr val="2E8B57"/>
                 </a:solidFill>
@@ -9359,7 +9359,7 @@
         </p:spPr>
         <p:txBody>
           <a:bodyPr xmlns:a="http://schemas.openxmlformats.org/drawingml/2006/main" wrap="square" lIns="0" tIns="0" rIns="0" bIns="0" anchor="ctr">
-            <a:normAutofit fontScale="100000"/>
+            <a:noAutofit/>
           </a:bodyPr>
           <a:lstStyle xmlns:a="http://schemas.openxmlformats.org/drawingml/2006/main"/>
           <a:p xmlns:a="http://schemas.openxmlformats.org/drawingml/2006/main">
@@ -9378,7 +9378,7 @@
               </a:defRPr>
             </a:pPr>
             <a:r>
-              <a:rPr sz="1275" b="1">
+              <a:rPr sz="1800" b="1">
                 <a:solidFill>
                   <a:srgbClr val="FFFFFF"/>
                 </a:solidFill>
@@ -9456,7 +9456,7 @@
         </p:spPr>
         <p:txBody>
           <a:bodyPr xmlns:a="http://schemas.openxmlformats.org/drawingml/2006/main" wrap="square" lIns="0" tIns="0" rIns="0" bIns="0" anchor="ctr">
-            <a:normAutofit fontScale="100000"/>
+            <a:noAutofit/>
           </a:bodyPr>
           <a:lstStyle xmlns:a="http://schemas.openxmlformats.org/drawingml/2006/main"/>
           <a:p xmlns:a="http://schemas.openxmlformats.org/drawingml/2006/main">
@@ -9475,7 +9475,7 @@
               </a:defRPr>
             </a:pPr>
             <a:r>
-              <a:rPr sz="1275" b="1">
+              <a:rPr sz="1800" b="1">
                 <a:solidFill>
                   <a:srgbClr val="FFFFFF"/>
                 </a:solidFill>
@@ -9518,7 +9518,7 @@
         </p:spPr>
         <p:txBody>
           <a:bodyPr xmlns:a="http://schemas.openxmlformats.org/drawingml/2006/main" wrap="square" lIns="0" tIns="0" rIns="0" bIns="0" anchor="ctr">
-            <a:normAutofit fontScale="100000"/>
+            <a:noAutofit/>
           </a:bodyPr>
           <a:lstStyle xmlns:a="http://schemas.openxmlformats.org/drawingml/2006/main"/>
           <a:p xmlns:a="http://schemas.openxmlformats.org/drawingml/2006/main">
@@ -9537,7 +9537,7 @@
               </a:defRPr>
             </a:pPr>
             <a:r>
-              <a:rPr sz="1350" b="1">
+              <a:rPr sz="1800" b="1">
                 <a:solidFill>
                   <a:srgbClr val="2E8B57"/>
                 </a:solidFill>
@@ -9991,7 +9991,7 @@
         </p:spPr>
         <p:txBody>
           <a:bodyPr xmlns:a="http://schemas.openxmlformats.org/drawingml/2006/main" wrap="square" lIns="0" tIns="0" rIns="0" bIns="0" anchor="ctr">
-            <a:normAutofit fontScale="100000"/>
+            <a:noAutofit/>
           </a:bodyPr>
           <a:lstStyle xmlns:a="http://schemas.openxmlformats.org/drawingml/2006/main"/>
           <a:p xmlns:a="http://schemas.openxmlformats.org/drawingml/2006/main">
@@ -10010,7 +10010,7 @@
               </a:defRPr>
             </a:pPr>
             <a:r>
-              <a:rPr sz="1425" b="1">
+              <a:rPr sz="1800" b="1">
                 <a:solidFill>
                   <a:srgbClr val="1F40CB"/>
                 </a:solidFill>
@@ -10150,7 +10150,7 @@
         </p:spPr>
         <p:txBody>
           <a:bodyPr xmlns:a="http://schemas.openxmlformats.org/drawingml/2006/main" wrap="square" lIns="0" tIns="0" rIns="0" bIns="0" anchor="ctr">
-            <a:normAutofit fontScale="100000"/>
+            <a:noAutofit/>
           </a:bodyPr>
           <a:lstStyle xmlns:a="http://schemas.openxmlformats.org/drawingml/2006/main"/>
           <a:p xmlns:a="http://schemas.openxmlformats.org/drawingml/2006/main">
@@ -10169,7 +10169,7 @@
               </a:defRPr>
             </a:pPr>
             <a:r>
-              <a:rPr sz="1350" b="1">
+              <a:rPr sz="1800" b="1">
                 <a:solidFill>
                   <a:srgbClr val="1F40CB"/>
                 </a:solidFill>
@@ -10177,7 +10177,7 @@
                 <a:ea typeface="Calibri"/>
                 <a:cs typeface="Calibri"/>
               </a:rPr>
-              <a:t>FUSED CANDIDATES</a:t>
+              <a:t>FUSED SET</a:t>
             </a:r>
           </a:p>
         </p:txBody>
@@ -10239,7 +10239,7 @@
                 <a:ea typeface="Calibri"/>
                 <a:cs typeface="Calibri"/>
               </a:rPr>
-              <a:t>candidate_k = 8</a:t>
+              <a:t>candidate_k = 4</a:t>
             </a:r>
           </a:p>
           <a:p xmlns:a="http://schemas.openxmlformats.org/drawingml/2006/main">
@@ -10322,8 +10322,8 @@
         </p:nvSpPr>
         <p:spPr>
           <a:xfrm xmlns:a="http://schemas.openxmlformats.org/drawingml/2006/main">
-            <a:off x="5467350" y="3067050"/>
-            <a:ext cx="2647950" cy="285750"/>
+            <a:off x="5467350" y="2914650"/>
+            <a:ext cx="2647950" cy="476250"/>
           </a:xfrm>
           <a:prstGeom xmlns:a="http://schemas.openxmlformats.org/drawingml/2006/main" prst="rect">
             <a:avLst/>
@@ -10336,7 +10336,7 @@
         </p:spPr>
         <p:txBody>
           <a:bodyPr xmlns:a="http://schemas.openxmlformats.org/drawingml/2006/main" wrap="square" lIns="0" tIns="0" rIns="0" bIns="0" anchor="ctr">
-            <a:normAutofit fontScale="100000"/>
+            <a:noAutofit/>
           </a:bodyPr>
           <a:lstStyle xmlns:a="http://schemas.openxmlformats.org/drawingml/2006/main"/>
           <a:p xmlns:a="http://schemas.openxmlformats.org/drawingml/2006/main">
@@ -10355,7 +10355,7 @@
               </a:defRPr>
             </a:pPr>
             <a:r>
-              <a:rPr sz="1275" b="1">
+              <a:rPr sz="1800" b="1">
                 <a:solidFill>
                   <a:srgbClr val="00A2EB"/>
                 </a:solidFill>
@@ -10384,8 +10384,8 @@
         </p:nvSpPr>
         <p:spPr>
           <a:xfrm xmlns:a="http://schemas.openxmlformats.org/drawingml/2006/main">
-            <a:off x="5467350" y="3486150"/>
-            <a:ext cx="2647950" cy="723900"/>
+            <a:off x="5467350" y="3390900"/>
+            <a:ext cx="2647950" cy="800100"/>
           </a:xfrm>
           <a:prstGeom xmlns:a="http://schemas.openxmlformats.org/drawingml/2006/main" prst="rect">
             <a:avLst/>
@@ -10398,13 +10398,13 @@
         </p:spPr>
         <p:txBody>
           <a:bodyPr xmlns:a="http://schemas.openxmlformats.org/drawingml/2006/main" wrap="square" lIns="0" tIns="0" rIns="0" bIns="0" anchor="ctr">
-            <a:normAutofit fontScale="100000"/>
+            <a:noAutofit/>
           </a:bodyPr>
           <a:lstStyle xmlns:a="http://schemas.openxmlformats.org/drawingml/2006/main"/>
           <a:p xmlns:a="http://schemas.openxmlformats.org/drawingml/2006/main">
             <a:pPr algn="ctr">
               <a:lnSpc>
-                <a:spcPct val="100000"/>
+                <a:spcPct val="80000"/>
               </a:lnSpc>
               <a:buNone/>
               <a:defRPr sz="2175" b="1">
@@ -10417,7 +10417,7 @@
               </a:defRPr>
             </a:pPr>
             <a:r>
-              <a:rPr sz="2175" b="1">
+              <a:rPr sz="1800" b="1">
                 <a:solidFill>
                   <a:srgbClr val="051C2A"/>
                 </a:solidFill>
@@ -10425,13 +10425,13 @@
                 <a:ea typeface="Calibri"/>
                 <a:cs typeface="Calibri"/>
               </a:rPr>
-              <a:t>Five normalized</a:t>
+              <a:t>lexical coverage=.25</a:t>
             </a:r>
           </a:p>
           <a:p xmlns:a="http://schemas.openxmlformats.org/drawingml/2006/main">
             <a:pPr algn="ctr">
               <a:lnSpc>
-                <a:spcPct val="100000"/>
+                <a:spcPct val="80000"/>
               </a:lnSpc>
               <a:buNone/>
               <a:defRPr sz="2175" b="1">
@@ -10444,7 +10444,7 @@
               </a:defRPr>
             </a:pPr>
             <a:r>
-              <a:rPr sz="2175" b="1">
+              <a:rPr sz="1800" b="1">
                 <a:solidFill>
                   <a:srgbClr val="051C2A"/>
                 </a:solidFill>
@@ -10452,7 +10452,34 @@
                 <a:ea typeface="Calibri"/>
                 <a:cs typeface="Calibri"/>
               </a:rPr>
-              <a:t>features</a:t>
+              <a:t>numeric coverage=.45</a:t>
+            </a:r>
+          </a:p>
+          <a:p xmlns:a="http://schemas.openxmlformats.org/drawingml/2006/main">
+            <a:pPr algn="ctr">
+              <a:lnSpc>
+                <a:spcPct val="80000"/>
+              </a:lnSpc>
+              <a:buNone/>
+              <a:defRPr sz="2175" b="1">
+                <a:solidFill>
+                  <a:srgbClr val="051C2A"/>
+                </a:solidFill>
+                <a:latin typeface="Calibri"/>
+                <a:ea typeface="Calibri"/>
+                <a:cs typeface="Calibri"/>
+              </a:defRPr>
+            </a:pPr>
+            <a:r>
+              <a:rPr sz="1800" b="1">
+                <a:solidFill>
+                  <a:srgbClr val="051C2A"/>
+                </a:solidFill>
+                <a:latin typeface="Calibri"/>
+                <a:ea typeface="Calibri"/>
+                <a:cs typeface="Calibri"/>
+              </a:rPr>
+              <a:t>section overlap=.10</a:t>
             </a:r>
           </a:p>
         </p:txBody>
@@ -10473,8 +10500,8 @@
         </p:nvSpPr>
         <p:spPr>
           <a:xfrm xmlns:a="http://schemas.openxmlformats.org/drawingml/2006/main">
-            <a:off x="5467350" y="4267200"/>
-            <a:ext cx="2647950" cy="266700"/>
+            <a:off x="5467350" y="4191000"/>
+            <a:ext cx="2647950" cy="476250"/>
           </a:xfrm>
           <a:prstGeom xmlns:a="http://schemas.openxmlformats.org/drawingml/2006/main" prst="rect">
             <a:avLst/>
@@ -10487,13 +10514,13 @@
         </p:spPr>
         <p:txBody>
           <a:bodyPr xmlns:a="http://schemas.openxmlformats.org/drawingml/2006/main" wrap="square" lIns="0" tIns="0" rIns="0" bIns="0" anchor="ctr">
-            <a:normAutofit fontScale="100000"/>
+            <a:noAutofit/>
           </a:bodyPr>
           <a:lstStyle xmlns:a="http://schemas.openxmlformats.org/drawingml/2006/main"/>
           <a:p xmlns:a="http://schemas.openxmlformats.org/drawingml/2006/main">
             <a:pPr algn="ctr">
               <a:lnSpc>
-                <a:spcPct val="100000"/>
+                <a:spcPct val="70000"/>
               </a:lnSpc>
               <a:buNone/>
               <a:defRPr sz="1275" b="0">
@@ -10506,7 +10533,7 @@
               </a:defRPr>
             </a:pPr>
             <a:r>
-              <a:rPr sz="1275" b="0">
+              <a:rPr sz="1800" b="0">
                 <a:solidFill>
                   <a:srgbClr val="1F40CB"/>
                 </a:solidFill>
@@ -10514,7 +10541,34 @@
                 <a:ea typeface="Calibri"/>
                 <a:cs typeface="Calibri"/>
               </a:rPr>
-              <a:t>0.25 · 0.45 · 0.10 · 0.10 · 0.10</a:t>
+              <a:t>metadata eligibility=.10</a:t>
+            </a:r>
+          </a:p>
+          <a:p xmlns:a="http://schemas.openxmlformats.org/drawingml/2006/main">
+            <a:pPr algn="ctr">
+              <a:lnSpc>
+                <a:spcPct val="70000"/>
+              </a:lnSpc>
+              <a:buNone/>
+              <a:defRPr sz="1275" b="0">
+                <a:solidFill>
+                  <a:srgbClr val="1F40CB"/>
+                </a:solidFill>
+                <a:latin typeface="Calibri"/>
+                <a:ea typeface="Calibri"/>
+                <a:cs typeface="Calibri"/>
+              </a:defRPr>
+            </a:pPr>
+            <a:r>
+              <a:rPr sz="1800" b="0">
+                <a:solidFill>
+                  <a:srgbClr val="1F40CB"/>
+                </a:solidFill>
+                <a:latin typeface="Calibri"/>
+                <a:ea typeface="Calibri"/>
+                <a:cs typeface="Calibri"/>
+              </a:rPr>
+              <a:t>fusion signal=.10</a:t>
             </a:r>
           </a:p>
         </p:txBody>
@@ -10584,7 +10638,7 @@
         </p:spPr>
         <p:txBody>
           <a:bodyPr xmlns:a="http://schemas.openxmlformats.org/drawingml/2006/main" wrap="square" lIns="0" tIns="0" rIns="0" bIns="0" anchor="ctr">
-            <a:normAutofit fontScale="100000"/>
+            <a:noAutofit/>
           </a:bodyPr>
           <a:lstStyle xmlns:a="http://schemas.openxmlformats.org/drawingml/2006/main"/>
           <a:p xmlns:a="http://schemas.openxmlformats.org/drawingml/2006/main">
@@ -10603,7 +10657,7 @@
               </a:defRPr>
             </a:pPr>
             <a:r>
-              <a:rPr sz="1350" b="1">
+              <a:rPr sz="1800" b="1">
                 <a:solidFill>
                   <a:srgbClr val="00A2EB"/>
                 </a:solidFill>
@@ -10673,7 +10727,7 @@
                 <a:ea typeface="Calibri"/>
                 <a:cs typeface="Calibri"/>
               </a:rPr>
-              <a:t>final_k = 3</a:t>
+              <a:t>final_k = 2</a:t>
             </a:r>
           </a:p>
           <a:p xmlns:a="http://schemas.openxmlformats.org/drawingml/2006/main">
@@ -10707,7 +10761,7 @@
       </p:sp>
       <p:cxnSp>
         <p:nvCxnSpPr>
-          <p:cNvPr id="68" name=""/>
+          <p:cNvPr id="138" name=""/>
           <p:cNvCxnSpPr>
             <a:stCxn xmlns:a="http://schemas.openxmlformats.org/drawingml/2006/main" id="3" idx="3"/>
             <a:endCxn xmlns:a="http://schemas.openxmlformats.org/drawingml/2006/main" id="6" idx="1"/>
@@ -10733,7 +10787,7 @@
       </p:cxnSp>
       <p:cxnSp>
         <p:nvCxnSpPr>
-          <p:cNvPr id="69" name=""/>
+          <p:cNvPr id="139" name=""/>
           <p:cNvCxnSpPr>
             <a:stCxn xmlns:a="http://schemas.openxmlformats.org/drawingml/2006/main" id="6" idx="3"/>
             <a:endCxn xmlns:a="http://schemas.openxmlformats.org/drawingml/2006/main" id="10" idx="1"/>
@@ -10741,7 +10795,7 @@
           <p:nvPr/>
         </p:nvCxnSpPr>
         <p:spPr>
-          <a:xfrm xmlns:a="http://schemas.openxmlformats.org/drawingml/2006/main">
+          <a:xfrm xmlns:a="http://schemas.openxmlformats.org/drawingml/2006/main" flipV="0">
             <a:off x="8420100" y="3771900"/>
             <a:ext cx="1409700" cy="0"/>
           </a:xfrm>
@@ -10822,7 +10876,7 @@
         </p:spPr>
         <p:txBody>
           <a:bodyPr xmlns:a="http://schemas.openxmlformats.org/drawingml/2006/main" wrap="square" lIns="0" tIns="0" rIns="0" bIns="0" anchor="ctr">
-            <a:normAutofit fontScale="100000"/>
+            <a:noAutofit/>
           </a:bodyPr>
           <a:lstStyle xmlns:a="http://schemas.openxmlformats.org/drawingml/2006/main"/>
           <a:p xmlns:a="http://schemas.openxmlformats.org/drawingml/2006/main">
@@ -10841,7 +10895,7 @@
               </a:defRPr>
             </a:pPr>
             <a:r>
-              <a:rPr sz="1275" b="1">
+              <a:rPr sz="1800" b="1">
                 <a:solidFill>
                   <a:srgbClr val="F07D00"/>
                 </a:solidFill>
@@ -10979,7 +11033,7 @@
         </p:spPr>
         <p:txBody>
           <a:bodyPr xmlns:a="http://schemas.openxmlformats.org/drawingml/2006/main" wrap="square" lIns="0" tIns="0" rIns="0" bIns="0" anchor="ctr">
-            <a:normAutofit fontScale="100000"/>
+            <a:noAutofit/>
           </a:bodyPr>
           <a:lstStyle xmlns:a="http://schemas.openxmlformats.org/drawingml/2006/main"/>
           <a:p xmlns:a="http://schemas.openxmlformats.org/drawingml/2006/main">
@@ -10998,7 +11052,7 @@
               </a:defRPr>
             </a:pPr>
             <a:r>
-              <a:rPr sz="1275" b="1">
+              <a:rPr sz="1800" b="1">
                 <a:solidFill>
                   <a:srgbClr val="00A2EB"/>
                 </a:solidFill>
@@ -11103,7 +11157,7 @@
         </p:spPr>
         <p:txBody>
           <a:bodyPr xmlns:a="http://schemas.openxmlformats.org/drawingml/2006/main" wrap="square" lIns="0" tIns="0" rIns="0" bIns="0" anchor="ctr">
-            <a:normAutofit fontScale="100000"/>
+            <a:noAutofit/>
           </a:bodyPr>
           <a:lstStyle xmlns:a="http://schemas.openxmlformats.org/drawingml/2006/main"/>
           <a:p xmlns:a="http://schemas.openxmlformats.org/drawingml/2006/main">
@@ -11122,7 +11176,7 @@
               </a:defRPr>
             </a:pPr>
             <a:r>
-              <a:rPr sz="1350" b="1">
+              <a:rPr sz="1800" b="1">
                 <a:solidFill>
                   <a:srgbClr val="F07D00"/>
                 </a:solidFill>
@@ -11130,7 +11184,7 @@
                 <a:ea typeface="Calibri"/>
                 <a:cs typeface="Calibri"/>
               </a:rPr>
-              <a:t>DECISION RULE</a:t>
+              <a:t>DECISION</a:t>
             </a:r>
           </a:p>
         </p:txBody>
@@ -11508,7 +11562,7 @@
         </p:spPr>
         <p:txBody>
           <a:bodyPr xmlns:a="http://schemas.openxmlformats.org/drawingml/2006/main" wrap="square" lIns="0" tIns="0" rIns="0" bIns="0" anchor="ctr">
-            <a:normAutofit fontScale="100000"/>
+            <a:noAutofit/>
           </a:bodyPr>
           <a:lstStyle xmlns:a="http://schemas.openxmlformats.org/drawingml/2006/main"/>
           <a:p xmlns:a="http://schemas.openxmlformats.org/drawingml/2006/main">
@@ -11527,7 +11581,7 @@
               </a:defRPr>
             </a:pPr>
             <a:r>
-              <a:rPr sz="1425" b="1">
+              <a:rPr sz="1800" b="1">
                 <a:solidFill>
                   <a:srgbClr val="1F40CB"/>
                 </a:solidFill>
@@ -11667,7 +11721,7 @@
         </p:spPr>
         <p:txBody>
           <a:bodyPr xmlns:a="http://schemas.openxmlformats.org/drawingml/2006/main" wrap="square" lIns="0" tIns="0" rIns="0" bIns="0" anchor="ctr">
-            <a:normAutofit fontScale="100000"/>
+            <a:noAutofit/>
           </a:bodyPr>
           <a:lstStyle xmlns:a="http://schemas.openxmlformats.org/drawingml/2006/main"/>
           <a:p xmlns:a="http://schemas.openxmlformats.org/drawingml/2006/main">
@@ -11686,7 +11740,7 @@
               </a:defRPr>
             </a:pPr>
             <a:r>
-              <a:rPr sz="1350" b="1">
+              <a:rPr sz="1800" b="1">
                 <a:solidFill>
                   <a:srgbClr val="00A2EB"/>
                 </a:solidFill>
@@ -11888,7 +11942,7 @@
         </p:spPr>
         <p:txBody>
           <a:bodyPr xmlns:a="http://schemas.openxmlformats.org/drawingml/2006/main" wrap="square" lIns="0" tIns="0" rIns="0" bIns="0" anchor="ctr">
-            <a:normAutofit fontScale="100000"/>
+            <a:noAutofit/>
           </a:bodyPr>
           <a:lstStyle xmlns:a="http://schemas.openxmlformats.org/drawingml/2006/main"/>
           <a:p xmlns:a="http://schemas.openxmlformats.org/drawingml/2006/main">
@@ -11907,7 +11961,7 @@
               </a:defRPr>
             </a:pPr>
             <a:r>
-              <a:rPr sz="1350" b="1">
+              <a:rPr sz="1800" b="1">
                 <a:solidFill>
                   <a:srgbClr val="00A2EB"/>
                 </a:solidFill>
@@ -12109,7 +12163,7 @@
         </p:spPr>
         <p:txBody>
           <a:bodyPr xmlns:a="http://schemas.openxmlformats.org/drawingml/2006/main" wrap="square" lIns="0" tIns="0" rIns="0" bIns="0" anchor="ctr">
-            <a:normAutofit fontScale="100000"/>
+            <a:noAutofit/>
           </a:bodyPr>
           <a:lstStyle xmlns:a="http://schemas.openxmlformats.org/drawingml/2006/main"/>
           <a:p xmlns:a="http://schemas.openxmlformats.org/drawingml/2006/main">
@@ -12128,7 +12182,7 @@
               </a:defRPr>
             </a:pPr>
             <a:r>
-              <a:rPr sz="1350" b="1">
+              <a:rPr sz="1800" b="1">
                 <a:solidFill>
                   <a:srgbClr val="00A2EB"/>
                 </a:solidFill>
@@ -12171,7 +12225,7 @@
         </p:spPr>
         <p:txBody>
           <a:bodyPr xmlns:a="http://schemas.openxmlformats.org/drawingml/2006/main" wrap="square" lIns="0" tIns="0" rIns="0" bIns="0" anchor="ctr">
-            <a:normAutofit fontScale="100000"/>
+            <a:noAutofit/>
           </a:bodyPr>
           <a:lstStyle xmlns:a="http://schemas.openxmlformats.org/drawingml/2006/main"/>
           <a:p xmlns:a="http://schemas.openxmlformats.org/drawingml/2006/main">
@@ -12190,7 +12244,7 @@
               </a:defRPr>
             </a:pPr>
             <a:r>
-              <a:rPr sz="1650" b="1">
+              <a:rPr sz="1800" b="1">
                 <a:solidFill>
                   <a:srgbClr val="FFFFFF"/>
                 </a:solidFill>
@@ -12330,7 +12384,7 @@
         </p:spPr>
         <p:txBody>
           <a:bodyPr xmlns:a="http://schemas.openxmlformats.org/drawingml/2006/main" wrap="square" lIns="0" tIns="0" rIns="0" bIns="0" anchor="ctr">
-            <a:normAutofit fontScale="100000"/>
+            <a:noAutofit/>
           </a:bodyPr>
           <a:lstStyle xmlns:a="http://schemas.openxmlformats.org/drawingml/2006/main"/>
           <a:p xmlns:a="http://schemas.openxmlformats.org/drawingml/2006/main">
@@ -12349,7 +12403,7 @@
               </a:defRPr>
             </a:pPr>
             <a:r>
-              <a:rPr sz="1350" b="1">
+              <a:rPr sz="1800" b="1">
                 <a:solidFill>
                   <a:srgbClr val="00A2EB"/>
                 </a:solidFill>
@@ -12551,7 +12605,7 @@
         </p:spPr>
         <p:txBody>
           <a:bodyPr xmlns:a="http://schemas.openxmlformats.org/drawingml/2006/main" wrap="square" lIns="0" tIns="0" rIns="0" bIns="0" anchor="ctr">
-            <a:normAutofit fontScale="100000"/>
+            <a:noAutofit/>
           </a:bodyPr>
           <a:lstStyle xmlns:a="http://schemas.openxmlformats.org/drawingml/2006/main"/>
           <a:p xmlns:a="http://schemas.openxmlformats.org/drawingml/2006/main">
@@ -12570,7 +12624,7 @@
               </a:defRPr>
             </a:pPr>
             <a:r>
-              <a:rPr sz="1350" b="1">
+              <a:rPr sz="1800" b="1">
                 <a:solidFill>
                   <a:srgbClr val="00A2EB"/>
                 </a:solidFill>
@@ -12709,7 +12763,7 @@
       </p:sp>
       <p:cxnSp>
         <p:nvCxnSpPr>
-          <p:cNvPr id="109" name=""/>
+          <p:cNvPr id="239" name=""/>
           <p:cNvCxnSpPr>
             <a:stCxn xmlns:a="http://schemas.openxmlformats.org/drawingml/2006/main" id="3" idx="3"/>
             <a:endCxn xmlns:a="http://schemas.openxmlformats.org/drawingml/2006/main" id="7" idx="1"/>
@@ -12735,7 +12789,7 @@
       </p:cxnSp>
       <p:cxnSp>
         <p:nvCxnSpPr>
-          <p:cNvPr id="110" name=""/>
+          <p:cNvPr id="240" name=""/>
           <p:cNvCxnSpPr>
             <a:stCxn xmlns:a="http://schemas.openxmlformats.org/drawingml/2006/main" id="7" idx="3"/>
             <a:endCxn xmlns:a="http://schemas.openxmlformats.org/drawingml/2006/main" id="11" idx="1"/>
@@ -12761,7 +12815,7 @@
       </p:cxnSp>
       <p:cxnSp>
         <p:nvCxnSpPr>
-          <p:cNvPr id="111" name=""/>
+          <p:cNvPr id="241" name=""/>
           <p:cNvCxnSpPr>
             <a:stCxn xmlns:a="http://schemas.openxmlformats.org/drawingml/2006/main" id="11" idx="3"/>
             <a:endCxn xmlns:a="http://schemas.openxmlformats.org/drawingml/2006/main" id="15" idx="1"/>
@@ -12787,7 +12841,7 @@
       </p:cxnSp>
       <p:cxnSp>
         <p:nvCxnSpPr>
-          <p:cNvPr id="112" name=""/>
+          <p:cNvPr id="242" name=""/>
           <p:cNvCxnSpPr>
             <a:stCxn xmlns:a="http://schemas.openxmlformats.org/drawingml/2006/main" id="15" idx="3"/>
             <a:endCxn xmlns:a="http://schemas.openxmlformats.org/drawingml/2006/main" id="19" idx="1"/>

</xml_diff>

<commit_message>
fix: align lesson 06 acceptance contracts
</commit_message>
<xml_diff>
--- a/decks/06-hybrid-retrieval.pptx
+++ b/decks/06-hybrid-retrieval.pptx
@@ -2,19 +2,19 @@
 <file path=ppt/presentation.xml><?xml version="1.0" encoding="utf-8"?>
 <p:presentation xmlns:p="http://schemas.openxmlformats.org/presentationml/2006/main">
   <p:sldMasterIdLst>
-    <p:sldMasterId xmlns:r="http://schemas.openxmlformats.org/officeDocument/2006/relationships" id="2147483648" r:id="Rff2a6bd326ba4500"/>
+    <p:sldMasterId xmlns:r="http://schemas.openxmlformats.org/officeDocument/2006/relationships" id="2147483648" r:id="R320efd7718684912"/>
   </p:sldMasterIdLst>
   <p:notesMasterIdLst>
-    <p:notesMasterId xmlns:r="http://schemas.openxmlformats.org/officeDocument/2006/relationships" r:id="R2d124c29d7c847f7"/>
+    <p:notesMasterId xmlns:r="http://schemas.openxmlformats.org/officeDocument/2006/relationships" r:id="R6093a144a2564219"/>
   </p:notesMasterIdLst>
   <p:sldIdLst>
-    <p:sldId xmlns:r="http://schemas.openxmlformats.org/officeDocument/2006/relationships" id="256" r:id="Rb89dd0c19e57470d"/>
-    <p:sldId xmlns:r="http://schemas.openxmlformats.org/officeDocument/2006/relationships" id="257" r:id="R2136b62ef76d4267"/>
-    <p:sldId xmlns:r="http://schemas.openxmlformats.org/officeDocument/2006/relationships" id="258" r:id="Rc088ebefff85449b"/>
-    <p:sldId xmlns:r="http://schemas.openxmlformats.org/officeDocument/2006/relationships" id="259" r:id="R220e4196087a4e81"/>
-    <p:sldId xmlns:r="http://schemas.openxmlformats.org/officeDocument/2006/relationships" id="260" r:id="R04b7aede4f354d2c"/>
-    <p:sldId xmlns:r="http://schemas.openxmlformats.org/officeDocument/2006/relationships" id="261" r:id="Re353eb7811e940c2"/>
-    <p:sldId xmlns:r="http://schemas.openxmlformats.org/officeDocument/2006/relationships" id="262" r:id="Rd10b2f14c8ff49e9"/>
+    <p:sldId xmlns:r="http://schemas.openxmlformats.org/officeDocument/2006/relationships" id="256" r:id="Rf430708f3f0c4e70"/>
+    <p:sldId xmlns:r="http://schemas.openxmlformats.org/officeDocument/2006/relationships" id="257" r:id="R08cc39a7479b4f63"/>
+    <p:sldId xmlns:r="http://schemas.openxmlformats.org/officeDocument/2006/relationships" id="258" r:id="Rf57b274e2c854a57"/>
+    <p:sldId xmlns:r="http://schemas.openxmlformats.org/officeDocument/2006/relationships" id="259" r:id="Rdec7b3af8b3f4432"/>
+    <p:sldId xmlns:r="http://schemas.openxmlformats.org/officeDocument/2006/relationships" id="260" r:id="R66f52d64c23746c8"/>
+    <p:sldId xmlns:r="http://schemas.openxmlformats.org/officeDocument/2006/relationships" id="261" r:id="R07e81728b69244ea"/>
+    <p:sldId xmlns:r="http://schemas.openxmlformats.org/officeDocument/2006/relationships" id="262" r:id="R87e60cf488d741ff"/>
   </p:sldIdLst>
   <p:sldSz cx="15240000" cy="8572500"/>
   <p:notesSz cx="6858000" cy="9144000"/>
@@ -628,12 +628,27 @@
           <a:lstStyle xmlns:a="http://schemas.openxmlformats.org/drawingml/2006/main"/>
           <a:p xmlns:a="http://schemas.openxmlformats.org/drawingml/2006/main">
             <a:r>
-              <a:t>Keyword retrieval protects exact numbers, tickers, and accounting labels. Dense retrieval protects conceptual matches with limited literal overlap.</a:t>
-            </a:r>
-          </a:p>
-          <a:p xmlns:a="http://schemas.openxmlformats.org/drawingml/2006/main">
-            <a:r>
-              <a:t>Do not compare TF-IDF cosine and embedding cosine as if they were one calibrated score scale.</a:t>
+              <a:t>Maintained query: Which NVIDIA business generated $193.7 billion?</a:t>
+            </a:r>
+          </a:p>
+          <a:p xmlns:a="http://schemas.openxmlformats.org/drawingml/2006/main">
+            <a:r>
+              <a:t>Filter: company=NVIDIA and period=FY2026. Values below are from the deterministic offline execution of notebooks/06_hybrid_retrieval.ipynb.</a:t>
+            </a:r>
+          </a:p>
+          <a:p xmlns:a="http://schemas.openxmlformats.org/drawingml/2006/main">
+            <a:r>
+              <a:t>Keyword rank 1: NVDA-2026-10K-EXCERPT-CONTEXTUAL-003 (TF-IDF cosine 0.591); rank 2: NVDA-2026-10K-EXCERPT-CONTEXTUAL-001 (0.357); rank 3: NVDA-2026-10K-EXCERPT-CONTEXTUAL-002 (0.209); rank 4: NVDA-2026-10K-EXCERPT-CONTEXTUAL-004 (0.118).</a:t>
+            </a:r>
+          </a:p>
+          <a:p xmlns:a="http://schemas.openxmlformats.org/drawingml/2006/main">
+            <a:r>
+              <a:t>Dense rank 1: NVDA-2026-10K-EXCERPT-CONTEXTUAL-001 (raw cosine 0.577); rank 2: NVDA-2026-10K-EXCERPT-CONTEXTUAL-002 (0.577); rank 3: NVDA-2026-10K-EXCERPT-CONTEXTUAL-004 (0.447); dense rank 4: NVDA-2026-10K-EXCERPT-CONTEXTUAL-003 (0.408).</a:t>
+            </a:r>
+          </a:p>
+          <a:p xmlns:a="http://schemas.openxmlformats.org/drawingml/2006/main">
+            <a:r>
+              <a:t>Visible IDs use the collision-safe NVDA…NNN abbreviation; the full stable manifest IDs appear above. Raw embedding cosine is a ranking signal, not confidence.</a:t>
             </a:r>
           </a:p>
           <a:p xmlns:a="http://schemas.openxmlformats.org/drawingml/2006/main">
@@ -643,17 +658,17 @@
           </a:p>
           <a:p xmlns:a="http://schemas.openxmlformats.org/drawingml/2006/main">
             <a:r>
-              <a:t>- Executable comparison: notebooks/06_hybrid_retrieval.ipynb</a:t>
+              <a:t>- Executable maintained run: notebooks/06_hybrid_retrieval.ipynb</a:t>
+            </a:r>
+          </a:p>
+          <a:p xmlns:a="http://schemas.openxmlformats.org/drawingml/2006/main">
+            <a:r>
+              <a:t>- Course explanation and score contracts: chapters/06-hybrid-retrieval.md</a:t>
             </a:r>
           </a:p>
           <a:p xmlns:a="http://schemas.openxmlformats.org/drawingml/2006/main">
             <a:r>
               <a:t>- NVIDIA fiscal 2026 Form 10-K: https://www.sec.gov/Archives/edgar/data/1045810/000104581026000021/nvda-20260125.htm</a:t>
-            </a:r>
-          </a:p>
-          <a:p xmlns:a="http://schemas.openxmlformats.org/drawingml/2006/main">
-            <a:r>
-              <a:t>- Schneider Electric FY2025 results: https://www.se.com/ww/en/assets/564/document/528237/release-fy-results-2025.pdf</a:t>
             </a:r>
           </a:p>
         </p:txBody>
@@ -1091,7 +1106,7 @@
   </p:cSld>
   <p:clrMap bg1="lt1" tx1="dk1" bg2="lt2" tx2="dk2" accent1="accent1" accent2="accent2" accent3="accent3" accent4="accent4" accent5="accent5" accent6="accent6" hlink="hlink" folHlink="folHlink"/>
   <p:sldLayoutIdLst>
-    <p:sldLayoutId xmlns:r="http://schemas.openxmlformats.org/officeDocument/2006/relationships" id="2147483649" r:id="R48334c3f187d4adf"/>
+    <p:sldLayoutId xmlns:r="http://schemas.openxmlformats.org/officeDocument/2006/relationships" id="2147483649" r:id="R82517f2991814dd5"/>
   </p:sldLayoutIdLst>
   <p:txStyles>
     <p:titleStyle>
@@ -2973,7 +2988,7 @@
       </p:sp>
       <p:cxnSp>
         <p:nvCxnSpPr>
-          <p:cNvPr id="230" name=""/>
+          <p:cNvPr id="254" name=""/>
           <p:cNvCxnSpPr>
             <a:stCxn xmlns:a="http://schemas.openxmlformats.org/drawingml/2006/main" id="14" idx="2"/>
             <a:endCxn xmlns:a="http://schemas.openxmlformats.org/drawingml/2006/main" id="16" idx="0"/>
@@ -2999,7 +3014,7 @@
       </p:cxnSp>
       <p:cxnSp>
         <p:nvCxnSpPr>
-          <p:cNvPr id="231" name=""/>
+          <p:cNvPr id="255" name=""/>
           <p:cNvCxnSpPr>
             <a:stCxn xmlns:a="http://schemas.openxmlformats.org/drawingml/2006/main" id="14" idx="2"/>
             <a:endCxn xmlns:a="http://schemas.openxmlformats.org/drawingml/2006/main" id="18" idx="0"/>
@@ -3025,7 +3040,7 @@
       </p:cxnSp>
       <p:cxnSp>
         <p:nvCxnSpPr>
-          <p:cNvPr id="232" name=""/>
+          <p:cNvPr id="256" name=""/>
           <p:cNvCxnSpPr>
             <a:stCxn xmlns:a="http://schemas.openxmlformats.org/drawingml/2006/main" id="14" idx="2"/>
             <a:endCxn xmlns:a="http://schemas.openxmlformats.org/drawingml/2006/main" id="20" idx="0"/>
@@ -4015,7 +4030,7 @@
                 <a:ea typeface="Calibri"/>
                 <a:cs typeface="Calibri"/>
               </a:rPr>
-              <a:t>COMPLEMENTARY CHANNELS</a:t>
+              <a:t>MAINTAINED QUERY · OFFLINE</a:t>
             </a:r>
           </a:p>
         </p:txBody>
@@ -4077,7 +4092,7 @@
                 <a:ea typeface="Calibri"/>
                 <a:cs typeface="Calibri"/>
               </a:rPr>
-              <a:t>Keyword and dense lists fail differently—and together</a:t>
+              <a:t>Which NVIDIA business generated $193.7 billion?</a:t>
             </a:r>
           </a:p>
         </p:txBody>
@@ -4139,7 +4154,7 @@
                 <a:ea typeface="Calibri"/>
                 <a:cs typeface="Calibri"/>
               </a:rPr>
-              <a:t>KEYWORD · EXACT</a:t>
+              <a:t>KEYWORD · TF-IDF</a:t>
             </a:r>
           </a:p>
         </p:txBody>
@@ -4236,7 +4251,7 @@
                 <a:ea typeface="Courier New"/>
                 <a:cs typeface="Courier New"/>
               </a:rPr>
-              <a:t>R1  SU-TABLE  18.7%</a:t>
+              <a:t>R1  NVDA…003  .591</a:t>
             </a:r>
           </a:p>
           <a:p xmlns:a="http://schemas.openxmlformats.org/drawingml/2006/main">
@@ -4263,7 +4278,7 @@
                 <a:ea typeface="Courier New"/>
                 <a:cs typeface="Courier New"/>
               </a:rPr>
-              <a:t>exact literal</a:t>
+              <a:t>$193.7bn exact match</a:t>
             </a:r>
           </a:p>
         </p:txBody>
@@ -4333,7 +4348,7 @@
         </p:spPr>
         <p:txBody>
           <a:bodyPr xmlns:a="http://schemas.openxmlformats.org/drawingml/2006/main" wrap="square" lIns="0" tIns="0" rIns="0" bIns="0" anchor="ctr">
-            <a:normAutofit fontScale="95833"/>
+            <a:normAutofit fontScale="100000"/>
           </a:bodyPr>
           <a:lstStyle xmlns:a="http://schemas.openxmlformats.org/drawingml/2006/main"/>
           <a:p xmlns:a="http://schemas.openxmlformats.org/drawingml/2006/main">
@@ -4360,7 +4375,7 @@
                 <a:ea typeface="Courier New"/>
                 <a:cs typeface="Courier New"/>
               </a:rPr>
-              <a:t>R2  NVDA-TABLE  $193.7bn</a:t>
+              <a:t>R2  NVDA…001  .357</a:t>
             </a:r>
           </a:p>
         </p:txBody>
@@ -4422,7 +4437,7 @@
                 <a:ea typeface="Calibri"/>
                 <a:cs typeface="Calibri"/>
               </a:rPr>
-              <a:t>TF-IDF cosine score</a:t>
+              <a:t>Filter · NVIDIA · FY2026</a:t>
             </a:r>
           </a:p>
         </p:txBody>
@@ -4484,7 +4499,7 @@
                 <a:ea typeface="Calibri"/>
                 <a:cs typeface="Calibri"/>
               </a:rPr>
-              <a:t>DENSE · CONCEPTS</a:t>
+              <a:t>DENSE · OFFLINE</a:t>
             </a:r>
           </a:p>
         </p:txBody>
@@ -4942,7 +4957,7 @@
         </p:spPr>
         <p:txBody>
           <a:bodyPr xmlns:a="http://schemas.openxmlformats.org/drawingml/2006/main" wrap="square" lIns="0" tIns="0" rIns="0" bIns="0" anchor="ctr">
-            <a:normAutofit fontScale="96491"/>
+            <a:normAutofit fontScale="100000"/>
           </a:bodyPr>
           <a:lstStyle xmlns:a="http://schemas.openxmlformats.org/drawingml/2006/main"/>
           <a:p xmlns:a="http://schemas.openxmlformats.org/drawingml/2006/main">
@@ -4969,34 +4984,7 @@
                 <a:ea typeface="Calibri"/>
                 <a:cs typeface="Calibri"/>
               </a:rPr>
-              <a:t>NVDA-</a:t>
-            </a:r>
-          </a:p>
-          <a:p xmlns:a="http://schemas.openxmlformats.org/drawingml/2006/main">
-            <a:pPr algn="l">
-              <a:lnSpc>
-                <a:spcPct val="100000"/>
-              </a:lnSpc>
-              <a:buNone/>
-              <a:defRPr sz="1425" b="0">
-                <a:solidFill>
-                  <a:srgbClr val="051C2A"/>
-                </a:solidFill>
-                <a:latin typeface="Calibri"/>
-                <a:ea typeface="Calibri"/>
-                <a:cs typeface="Calibri"/>
-              </a:defRPr>
-            </a:pPr>
-            <a:r>
-              <a:rPr sz="1425" b="0">
-                <a:solidFill>
-                  <a:srgbClr val="051C2A"/>
-                </a:solidFill>
-                <a:latin typeface="Calibri"/>
-                <a:ea typeface="Calibri"/>
-                <a:cs typeface="Calibri"/>
-              </a:rPr>
-              <a:t>CONCENTRATION</a:t>
+              <a:t>NVDA…001</a:t>
             </a:r>
           </a:p>
         </p:txBody>
@@ -5093,7 +5081,7 @@
                 <a:ea typeface="Calibri"/>
                 <a:cs typeface="Calibri"/>
               </a:rPr>
-              <a:t>concept alignment</a:t>
+              <a:t>raw cosine .577</a:t>
             </a:r>
           </a:p>
         </p:txBody>
@@ -5287,7 +5275,7 @@
                 <a:ea typeface="Calibri"/>
                 <a:cs typeface="Calibri"/>
               </a:rPr>
-              <a:t>NVDA-TABLE</a:t>
+              <a:t>NVDA…002</a:t>
             </a:r>
           </a:p>
         </p:txBody>
@@ -5384,7 +5372,7 @@
                 <a:ea typeface="Calibri"/>
                 <a:cs typeface="Calibri"/>
               </a:rPr>
-              <a:t>business semantics</a:t>
+              <a:t>raw cosine .577</a:t>
             </a:r>
           </a:p>
         </p:txBody>
@@ -5446,7 +5434,7 @@
                 <a:ea typeface="Calibri"/>
                 <a:cs typeface="Calibri"/>
               </a:rPr>
-              <a:t>Raw embedding cosine similarity</a:t>
+              <a:t>Evidence at dense R4 · NVDA…003 · raw cosine .408</a:t>
             </a:r>
           </a:p>
         </p:txBody>
@@ -6037,7 +6025,7 @@
                 <a:ea typeface="Calibri"/>
                 <a:cs typeface="Calibri"/>
               </a:rPr>
-              <a:t>passage ID</a:t>
+              <a:t>manifest ID</a:t>
             </a:r>
           </a:p>
         </p:txBody>
@@ -7684,7 +7672,7 @@
       </p:sp>
       <p:cxnSp>
         <p:nvCxnSpPr>
-          <p:cNvPr id="280" name=""/>
+          <p:cNvPr id="311" name=""/>
           <p:cNvCxnSpPr>
             <a:stCxn xmlns:a="http://schemas.openxmlformats.org/drawingml/2006/main" id="8" idx="3"/>
             <a:endCxn xmlns:a="http://schemas.openxmlformats.org/drawingml/2006/main" id="3" idx="1"/>
@@ -7710,7 +7698,7 @@
       </p:cxnSp>
       <p:cxnSp>
         <p:nvCxnSpPr>
-          <p:cNvPr id="281" name=""/>
+          <p:cNvPr id="312" name=""/>
           <p:cNvCxnSpPr>
             <a:stCxn xmlns:a="http://schemas.openxmlformats.org/drawingml/2006/main" id="11" idx="3"/>
             <a:endCxn xmlns:a="http://schemas.openxmlformats.org/drawingml/2006/main" id="3" idx="1"/>
@@ -7736,7 +7724,7 @@
       </p:cxnSp>
       <p:cxnSp>
         <p:nvCxnSpPr>
-          <p:cNvPr id="282" name=""/>
+          <p:cNvPr id="313" name=""/>
           <p:cNvCxnSpPr>
             <a:stCxn xmlns:a="http://schemas.openxmlformats.org/drawingml/2006/main" id="14" idx="3"/>
             <a:endCxn xmlns:a="http://schemas.openxmlformats.org/drawingml/2006/main" id="3" idx="1"/>
@@ -7762,7 +7750,7 @@
       </p:cxnSp>
       <p:cxnSp>
         <p:nvCxnSpPr>
-          <p:cNvPr id="283" name=""/>
+          <p:cNvPr id="314" name=""/>
           <p:cNvCxnSpPr>
             <a:stCxn xmlns:a="http://schemas.openxmlformats.org/drawingml/2006/main" id="3" idx="3"/>
             <a:endCxn xmlns:a="http://schemas.openxmlformats.org/drawingml/2006/main" id="17" idx="1"/>
@@ -7788,7 +7776,7 @@
       </p:cxnSp>
       <p:cxnSp>
         <p:nvCxnSpPr>
-          <p:cNvPr id="284" name=""/>
+          <p:cNvPr id="315" name=""/>
           <p:cNvCxnSpPr>
             <a:stCxn xmlns:a="http://schemas.openxmlformats.org/drawingml/2006/main" id="3" idx="3"/>
             <a:endCxn xmlns:a="http://schemas.openxmlformats.org/drawingml/2006/main" id="20" idx="1"/>
@@ -7814,7 +7802,7 @@
       </p:cxnSp>
       <p:cxnSp>
         <p:nvCxnSpPr>
-          <p:cNvPr id="285" name=""/>
+          <p:cNvPr id="316" name=""/>
           <p:cNvCxnSpPr>
             <a:stCxn xmlns:a="http://schemas.openxmlformats.org/drawingml/2006/main" id="3" idx="3"/>
             <a:endCxn xmlns:a="http://schemas.openxmlformats.org/drawingml/2006/main" id="23" idx="1"/>
@@ -10761,7 +10749,7 @@
       </p:sp>
       <p:cxnSp>
         <p:nvCxnSpPr>
-          <p:cNvPr id="138" name=""/>
+          <p:cNvPr id="152" name=""/>
           <p:cNvCxnSpPr>
             <a:stCxn xmlns:a="http://schemas.openxmlformats.org/drawingml/2006/main" id="3" idx="3"/>
             <a:endCxn xmlns:a="http://schemas.openxmlformats.org/drawingml/2006/main" id="6" idx="1"/>
@@ -10787,7 +10775,7 @@
       </p:cxnSp>
       <p:cxnSp>
         <p:nvCxnSpPr>
-          <p:cNvPr id="139" name=""/>
+          <p:cNvPr id="153" name=""/>
           <p:cNvCxnSpPr>
             <a:stCxn xmlns:a="http://schemas.openxmlformats.org/drawingml/2006/main" id="6" idx="3"/>
             <a:endCxn xmlns:a="http://schemas.openxmlformats.org/drawingml/2006/main" id="10" idx="1"/>
@@ -12763,7 +12751,7 @@
       </p:sp>
       <p:cxnSp>
         <p:nvCxnSpPr>
-          <p:cNvPr id="239" name=""/>
+          <p:cNvPr id="265" name=""/>
           <p:cNvCxnSpPr>
             <a:stCxn xmlns:a="http://schemas.openxmlformats.org/drawingml/2006/main" id="3" idx="3"/>
             <a:endCxn xmlns:a="http://schemas.openxmlformats.org/drawingml/2006/main" id="7" idx="1"/>
@@ -12789,7 +12777,7 @@
       </p:cxnSp>
       <p:cxnSp>
         <p:nvCxnSpPr>
-          <p:cNvPr id="240" name=""/>
+          <p:cNvPr id="266" name=""/>
           <p:cNvCxnSpPr>
             <a:stCxn xmlns:a="http://schemas.openxmlformats.org/drawingml/2006/main" id="7" idx="3"/>
             <a:endCxn xmlns:a="http://schemas.openxmlformats.org/drawingml/2006/main" id="11" idx="1"/>
@@ -12815,7 +12803,7 @@
       </p:cxnSp>
       <p:cxnSp>
         <p:nvCxnSpPr>
-          <p:cNvPr id="241" name=""/>
+          <p:cNvPr id="267" name=""/>
           <p:cNvCxnSpPr>
             <a:stCxn xmlns:a="http://schemas.openxmlformats.org/drawingml/2006/main" id="11" idx="3"/>
             <a:endCxn xmlns:a="http://schemas.openxmlformats.org/drawingml/2006/main" id="15" idx="1"/>
@@ -12841,7 +12829,7 @@
       </p:cxnSp>
       <p:cxnSp>
         <p:nvCxnSpPr>
-          <p:cNvPr id="242" name=""/>
+          <p:cNvPr id="268" name=""/>
           <p:cNvCxnSpPr>
             <a:stCxn xmlns:a="http://schemas.openxmlformats.org/drawingml/2006/main" id="15" idx="3"/>
             <a:endCxn xmlns:a="http://schemas.openxmlformats.org/drawingml/2006/main" id="19" idx="1"/>

</xml_diff>

<commit_message>
lesson: prepare hybrid retrieval for tracing
</commit_message>
<xml_diff>
--- a/decks/06-hybrid-retrieval.pptx
+++ b/decks/06-hybrid-retrieval.pptx
@@ -2,19 +2,21 @@
 <file path=ppt/presentation.xml><?xml version="1.0" encoding="utf-8"?>
 <p:presentation xmlns:p="http://schemas.openxmlformats.org/presentationml/2006/main">
   <p:sldMasterIdLst>
-    <p:sldMasterId xmlns:r="http://schemas.openxmlformats.org/officeDocument/2006/relationships" id="2147483648" r:id="R320efd7718684912"/>
+    <p:sldMasterId xmlns:r="http://schemas.openxmlformats.org/officeDocument/2006/relationships" id="2147483648" r:id="R76ffad91c86941ed"/>
   </p:sldMasterIdLst>
   <p:notesMasterIdLst>
-    <p:notesMasterId xmlns:r="http://schemas.openxmlformats.org/officeDocument/2006/relationships" r:id="R6093a144a2564219"/>
+    <p:notesMasterId xmlns:r="http://schemas.openxmlformats.org/officeDocument/2006/relationships" r:id="Rda639c644672469f"/>
   </p:notesMasterIdLst>
   <p:sldIdLst>
-    <p:sldId xmlns:r="http://schemas.openxmlformats.org/officeDocument/2006/relationships" id="256" r:id="Rf430708f3f0c4e70"/>
-    <p:sldId xmlns:r="http://schemas.openxmlformats.org/officeDocument/2006/relationships" id="257" r:id="R08cc39a7479b4f63"/>
-    <p:sldId xmlns:r="http://schemas.openxmlformats.org/officeDocument/2006/relationships" id="258" r:id="Rf57b274e2c854a57"/>
-    <p:sldId xmlns:r="http://schemas.openxmlformats.org/officeDocument/2006/relationships" id="259" r:id="Rdec7b3af8b3f4432"/>
-    <p:sldId xmlns:r="http://schemas.openxmlformats.org/officeDocument/2006/relationships" id="260" r:id="R66f52d64c23746c8"/>
-    <p:sldId xmlns:r="http://schemas.openxmlformats.org/officeDocument/2006/relationships" id="261" r:id="R07e81728b69244ea"/>
-    <p:sldId xmlns:r="http://schemas.openxmlformats.org/officeDocument/2006/relationships" id="262" r:id="R87e60cf488d741ff"/>
+    <p:sldId xmlns:r="http://schemas.openxmlformats.org/officeDocument/2006/relationships" id="256" r:id="R44300816dc0b40e0"/>
+    <p:sldId xmlns:r="http://schemas.openxmlformats.org/officeDocument/2006/relationships" id="257" r:id="Raf41ec16d827427c"/>
+    <p:sldId xmlns:r="http://schemas.openxmlformats.org/officeDocument/2006/relationships" id="258" r:id="R106309892fed41b3"/>
+    <p:sldId xmlns:r="http://schemas.openxmlformats.org/officeDocument/2006/relationships" id="259" r:id="Rc93eba2f62c14934"/>
+    <p:sldId xmlns:r="http://schemas.openxmlformats.org/officeDocument/2006/relationships" id="260" r:id="R3f584037283e4f2a"/>
+    <p:sldId xmlns:r="http://schemas.openxmlformats.org/officeDocument/2006/relationships" id="261" r:id="Rf3bc47d996b84019"/>
+    <p:sldId xmlns:r="http://schemas.openxmlformats.org/officeDocument/2006/relationships" id="262" r:id="Rfb73c04c25f3404e"/>
+    <p:sldId xmlns:r="http://schemas.openxmlformats.org/officeDocument/2006/relationships" id="263" r:id="Rd759ec8ce98946d2"/>
+    <p:sldId xmlns:r="http://schemas.openxmlformats.org/officeDocument/2006/relationships" id="264" r:id="Rce7b27bfedee4598"/>
   </p:sldIdLst>
   <p:sldSz cx="15240000" cy="8572500"/>
   <p:notesSz cx="6858000" cy="9144000"/>
@@ -1068,6 +1070,196 @@
 </p:notes>
 </file>
 
+<file path=ppt/notesSlides/notesSlide8.xml><?xml version="1.0" encoding="utf-8"?>
+<p:notes xmlns:p="http://schemas.openxmlformats.org/presentationml/2006/main">
+  <p:cSld>
+    <p:spTree>
+      <p:nvGrpSpPr>
+        <p:cNvPr id="1" name=""/>
+        <p:cNvGrpSpPr/>
+        <p:nvPr/>
+      </p:nvGrpSpPr>
+      <p:grpSpPr>
+        <a:xfrm xmlns:a="http://schemas.openxmlformats.org/drawingml/2006/main"/>
+      </p:grpSpPr>
+      <p:sp>
+        <p:nvSpPr>
+          <p:cNvPr id="2" name="Slide Image Placeholder 1"/>
+          <p:cNvSpPr>
+            <a:spLocks xmlns:a="http://schemas.openxmlformats.org/drawingml/2006/main" noGrp="1"/>
+          </p:cNvSpPr>
+          <p:nvPr>
+            <p:ph type="sldImg" idx="0"/>
+          </p:nvPr>
+        </p:nvSpPr>
+        <p:spPr/>
+      </p:sp>
+      <p:sp>
+        <p:nvSpPr>
+          <p:cNvPr id="3" name="Notes Placeholder 2"/>
+          <p:cNvSpPr>
+            <a:spLocks xmlns:a="http://schemas.openxmlformats.org/drawingml/2006/main" noGrp="1"/>
+          </p:cNvSpPr>
+          <p:nvPr>
+            <p:ph type="body" idx="1"/>
+          </p:nvPr>
+        </p:nvSpPr>
+        <p:spPr/>
+        <p:txBody>
+          <a:bodyPr xmlns:a="http://schemas.openxmlformats.org/drawingml/2006/main"/>
+          <a:lstStyle xmlns:a="http://schemas.openxmlformats.org/drawingml/2006/main"/>
+          <a:p xmlns:a="http://schemas.openxmlformats.org/drawingml/2006/main">
+            <a:r>
+              <a:t>Keep documents, chunks and embeddings as explicit logical records. The teaching index uses exact local search so students can inspect every row. Production may replace only the storage/query engine with pgvector and an HNSW index while preserving stable IDs, metadata filters and evaluation contracts.</a:t>
+            </a:r>
+          </a:p>
+          <a:p xmlns:a="http://schemas.openxmlformats.org/drawingml/2006/main">
+            <a:r>
+              <a:t/>
+            </a:r>
+          </a:p>
+          <a:p xmlns:a="http://schemas.openxmlformats.org/drawingml/2006/main">
+            <a:r>
+              <a:t>[Sources]</a:t>
+            </a:r>
+          </a:p>
+          <a:p xmlns:a="http://schemas.openxmlformats.org/drawingml/2006/main">
+            <a:r>
+              <a:t>- https://github.com/pgvector/pgvector</a:t>
+            </a:r>
+          </a:p>
+          <a:p xmlns:a="http://schemas.openxmlformats.org/drawingml/2006/main">
+            <a:r>
+              <a:t>- Course Notebook 06 architecture bridge</a:t>
+            </a:r>
+          </a:p>
+          <a:p xmlns:a="http://schemas.openxmlformats.org/drawingml/2006/main">
+            <a:r>
+              <a:t>[/Sources]</a:t>
+            </a:r>
+          </a:p>
+        </p:txBody>
+      </p:sp>
+      <p:sp>
+        <p:nvSpPr>
+          <p:cNvPr id="4" name="Slide Number Placeholder 3"/>
+          <p:cNvSpPr>
+            <a:spLocks xmlns:a="http://schemas.openxmlformats.org/drawingml/2006/main" noGrp="1"/>
+          </p:cNvSpPr>
+          <p:nvPr>
+            <p:ph type="sldNum" idx="5"/>
+          </p:nvPr>
+        </p:nvSpPr>
+        <p:spPr/>
+        <p:txBody>
+          <a:bodyPr xmlns:a="http://schemas.openxmlformats.org/drawingml/2006/main"/>
+          <a:lstStyle xmlns:a="http://schemas.openxmlformats.org/drawingml/2006/main"/>
+          <a:p xmlns:a="http://schemas.openxmlformats.org/drawingml/2006/main"/>
+        </p:txBody>
+      </p:sp>
+    </p:spTree>
+  </p:cSld>
+  <p:clrMapOvr>
+    <a:masterClrMapping xmlns:a="http://schemas.openxmlformats.org/drawingml/2006/main"/>
+  </p:clrMapOvr>
+</p:notes>
+</file>
+
+<file path=ppt/notesSlides/notesSlide9.xml><?xml version="1.0" encoding="utf-8"?>
+<p:notes xmlns:p="http://schemas.openxmlformats.org/presentationml/2006/main">
+  <p:cSld>
+    <p:spTree>
+      <p:nvGrpSpPr>
+        <p:cNvPr id="1" name=""/>
+        <p:cNvGrpSpPr/>
+        <p:nvPr/>
+      </p:nvGrpSpPr>
+      <p:grpSpPr>
+        <a:xfrm xmlns:a="http://schemas.openxmlformats.org/drawingml/2006/main"/>
+      </p:grpSpPr>
+      <p:sp>
+        <p:nvSpPr>
+          <p:cNvPr id="2" name="Slide Image Placeholder 1"/>
+          <p:cNvSpPr>
+            <a:spLocks xmlns:a="http://schemas.openxmlformats.org/drawingml/2006/main" noGrp="1"/>
+          </p:cNvSpPr>
+          <p:nvPr>
+            <p:ph type="sldImg" idx="0"/>
+          </p:nvPr>
+        </p:nvSpPr>
+        <p:spPr/>
+      </p:sp>
+      <p:sp>
+        <p:nvSpPr>
+          <p:cNvPr id="3" name="Notes Placeholder 2"/>
+          <p:cNvSpPr>
+            <a:spLocks xmlns:a="http://schemas.openxmlformats.org/drawingml/2006/main" noGrp="1"/>
+          </p:cNvSpPr>
+          <p:nvPr>
+            <p:ph type="body" idx="1"/>
+          </p:nvPr>
+        </p:nvSpPr>
+        <p:spPr/>
+        <p:txBody>
+          <a:bodyPr xmlns:a="http://schemas.openxmlformats.org/drawingml/2006/main"/>
+          <a:lstStyle xmlns:a="http://schemas.openxmlformats.org/drawingml/2006/main"/>
+          <a:p xmlns:a="http://schemas.openxmlformats.org/drawingml/2006/main">
+            <a:r>
+              <a:t>These values are one deterministic offline execution on the instructor machine: eligibility 0.00 ms, keyword 1.04 ms, dense 0.03 ms, fusion 0.01 ms and rerank 0.06 ms. Hardware-dependent timings are observations, not correctness thresholds. Lesson 07 wraps the same stage boundaries as MLflow spans.</a:t>
+            </a:r>
+          </a:p>
+          <a:p xmlns:a="http://schemas.openxmlformats.org/drawingml/2006/main">
+            <a:r>
+              <a:t/>
+            </a:r>
+          </a:p>
+          <a:p xmlns:a="http://schemas.openxmlformats.org/drawingml/2006/main">
+            <a:r>
+              <a:t>[Sources]</a:t>
+            </a:r>
+          </a:p>
+          <a:p xmlns:a="http://schemas.openxmlformats.org/drawingml/2006/main">
+            <a:r>
+              <a:t>- Course Notebook 06 offline execution, Figure 5</a:t>
+            </a:r>
+          </a:p>
+          <a:p xmlns:a="http://schemas.openxmlformats.org/drawingml/2006/main">
+            <a:r>
+              <a:t>- https://mlflow.org/docs/latest/genai/tracing/</a:t>
+            </a:r>
+          </a:p>
+          <a:p xmlns:a="http://schemas.openxmlformats.org/drawingml/2006/main">
+            <a:r>
+              <a:t>[/Sources]</a:t>
+            </a:r>
+          </a:p>
+        </p:txBody>
+      </p:sp>
+      <p:sp>
+        <p:nvSpPr>
+          <p:cNvPr id="4" name="Slide Number Placeholder 3"/>
+          <p:cNvSpPr>
+            <a:spLocks xmlns:a="http://schemas.openxmlformats.org/drawingml/2006/main" noGrp="1"/>
+          </p:cNvSpPr>
+          <p:nvPr>
+            <p:ph type="sldNum" idx="5"/>
+          </p:nvPr>
+        </p:nvSpPr>
+        <p:spPr/>
+        <p:txBody>
+          <a:bodyPr xmlns:a="http://schemas.openxmlformats.org/drawingml/2006/main"/>
+          <a:lstStyle xmlns:a="http://schemas.openxmlformats.org/drawingml/2006/main"/>
+          <a:p xmlns:a="http://schemas.openxmlformats.org/drawingml/2006/main"/>
+        </p:txBody>
+      </p:sp>
+    </p:spTree>
+  </p:cSld>
+  <p:clrMapOvr>
+    <a:masterClrMapping xmlns:a="http://schemas.openxmlformats.org/drawingml/2006/main"/>
+  </p:clrMapOvr>
+</p:notes>
+</file>
+
 <file path=ppt/slideLayouts/slideLayout1.xml><?xml version="1.0" encoding="utf-8"?>
 <p:sldLayout xmlns:p="http://schemas.openxmlformats.org/presentationml/2006/main" type="title">
   <p:cSld name="Title Slide">
@@ -1106,7 +1298,7 @@
   </p:cSld>
   <p:clrMap bg1="lt1" tx1="dk1" bg2="lt2" tx2="dk2" accent1="accent1" accent2="accent2" accent3="accent3" accent4="accent4" accent5="accent5" accent6="accent6" hlink="hlink" folHlink="folHlink"/>
   <p:sldLayoutIdLst>
-    <p:sldLayoutId xmlns:r="http://schemas.openxmlformats.org/officeDocument/2006/relationships" id="2147483649" r:id="R82517f2991814dd5"/>
+    <p:sldLayoutId xmlns:r="http://schemas.openxmlformats.org/officeDocument/2006/relationships" id="2147483649" r:id="Rbbba126d082d454c"/>
   </p:sldLayoutIdLst>
   <p:txStyles>
     <p:titleStyle>
@@ -2988,7 +3180,7 @@
       </p:sp>
       <p:cxnSp>
         <p:nvCxnSpPr>
-          <p:cNvPr id="254" name=""/>
+          <p:cNvPr id="302" name=""/>
           <p:cNvCxnSpPr>
             <a:stCxn xmlns:a="http://schemas.openxmlformats.org/drawingml/2006/main" id="14" idx="2"/>
             <a:endCxn xmlns:a="http://schemas.openxmlformats.org/drawingml/2006/main" id="16" idx="0"/>
@@ -3014,7 +3206,7 @@
       </p:cxnSp>
       <p:cxnSp>
         <p:nvCxnSpPr>
-          <p:cNvPr id="255" name=""/>
+          <p:cNvPr id="303" name=""/>
           <p:cNvCxnSpPr>
             <a:stCxn xmlns:a="http://schemas.openxmlformats.org/drawingml/2006/main" id="14" idx="2"/>
             <a:endCxn xmlns:a="http://schemas.openxmlformats.org/drawingml/2006/main" id="18" idx="0"/>
@@ -3040,7 +3232,7 @@
       </p:cxnSp>
       <p:cxnSp>
         <p:nvCxnSpPr>
-          <p:cNvPr id="256" name=""/>
+          <p:cNvPr id="304" name=""/>
           <p:cNvCxnSpPr>
             <a:stCxn xmlns:a="http://schemas.openxmlformats.org/drawingml/2006/main" id="14" idx="2"/>
             <a:endCxn xmlns:a="http://schemas.openxmlformats.org/drawingml/2006/main" id="20" idx="0"/>
@@ -7672,7 +7864,7 @@
       </p:sp>
       <p:cxnSp>
         <p:nvCxnSpPr>
-          <p:cNvPr id="311" name=""/>
+          <p:cNvPr id="373" name=""/>
           <p:cNvCxnSpPr>
             <a:stCxn xmlns:a="http://schemas.openxmlformats.org/drawingml/2006/main" id="8" idx="3"/>
             <a:endCxn xmlns:a="http://schemas.openxmlformats.org/drawingml/2006/main" id="3" idx="1"/>
@@ -7698,7 +7890,7 @@
       </p:cxnSp>
       <p:cxnSp>
         <p:nvCxnSpPr>
-          <p:cNvPr id="312" name=""/>
+          <p:cNvPr id="374" name=""/>
           <p:cNvCxnSpPr>
             <a:stCxn xmlns:a="http://schemas.openxmlformats.org/drawingml/2006/main" id="11" idx="3"/>
             <a:endCxn xmlns:a="http://schemas.openxmlformats.org/drawingml/2006/main" id="3" idx="1"/>
@@ -7724,7 +7916,7 @@
       </p:cxnSp>
       <p:cxnSp>
         <p:nvCxnSpPr>
-          <p:cNvPr id="313" name=""/>
+          <p:cNvPr id="375" name=""/>
           <p:cNvCxnSpPr>
             <a:stCxn xmlns:a="http://schemas.openxmlformats.org/drawingml/2006/main" id="14" idx="3"/>
             <a:endCxn xmlns:a="http://schemas.openxmlformats.org/drawingml/2006/main" id="3" idx="1"/>
@@ -7750,7 +7942,7 @@
       </p:cxnSp>
       <p:cxnSp>
         <p:nvCxnSpPr>
-          <p:cNvPr id="314" name=""/>
+          <p:cNvPr id="376" name=""/>
           <p:cNvCxnSpPr>
             <a:stCxn xmlns:a="http://schemas.openxmlformats.org/drawingml/2006/main" id="3" idx="3"/>
             <a:endCxn xmlns:a="http://schemas.openxmlformats.org/drawingml/2006/main" id="17" idx="1"/>
@@ -7776,7 +7968,7 @@
       </p:cxnSp>
       <p:cxnSp>
         <p:nvCxnSpPr>
-          <p:cNvPr id="315" name=""/>
+          <p:cNvPr id="377" name=""/>
           <p:cNvCxnSpPr>
             <a:stCxn xmlns:a="http://schemas.openxmlformats.org/drawingml/2006/main" id="3" idx="3"/>
             <a:endCxn xmlns:a="http://schemas.openxmlformats.org/drawingml/2006/main" id="20" idx="1"/>
@@ -7802,7 +7994,7 @@
       </p:cxnSp>
       <p:cxnSp>
         <p:nvCxnSpPr>
-          <p:cNvPr id="316" name=""/>
+          <p:cNvPr id="378" name=""/>
           <p:cNvCxnSpPr>
             <a:stCxn xmlns:a="http://schemas.openxmlformats.org/drawingml/2006/main" id="3" idx="3"/>
             <a:endCxn xmlns:a="http://schemas.openxmlformats.org/drawingml/2006/main" id="23" idx="1"/>
@@ -10749,7 +10941,7 @@
       </p:sp>
       <p:cxnSp>
         <p:nvCxnSpPr>
-          <p:cNvPr id="152" name=""/>
+          <p:cNvPr id="180" name=""/>
           <p:cNvCxnSpPr>
             <a:stCxn xmlns:a="http://schemas.openxmlformats.org/drawingml/2006/main" id="3" idx="3"/>
             <a:endCxn xmlns:a="http://schemas.openxmlformats.org/drawingml/2006/main" id="6" idx="1"/>
@@ -10775,7 +10967,7 @@
       </p:cxnSp>
       <p:cxnSp>
         <p:nvCxnSpPr>
-          <p:cNvPr id="153" name=""/>
+          <p:cNvPr id="181" name=""/>
           <p:cNvCxnSpPr>
             <a:stCxn xmlns:a="http://schemas.openxmlformats.org/drawingml/2006/main" id="6" idx="3"/>
             <a:endCxn xmlns:a="http://schemas.openxmlformats.org/drawingml/2006/main" id="10" idx="1"/>
@@ -12751,7 +12943,7 @@
       </p:sp>
       <p:cxnSp>
         <p:nvCxnSpPr>
-          <p:cNvPr id="265" name=""/>
+          <p:cNvPr id="317" name=""/>
           <p:cNvCxnSpPr>
             <a:stCxn xmlns:a="http://schemas.openxmlformats.org/drawingml/2006/main" id="3" idx="3"/>
             <a:endCxn xmlns:a="http://schemas.openxmlformats.org/drawingml/2006/main" id="7" idx="1"/>
@@ -12777,7 +12969,7 @@
       </p:cxnSp>
       <p:cxnSp>
         <p:nvCxnSpPr>
-          <p:cNvPr id="266" name=""/>
+          <p:cNvPr id="318" name=""/>
           <p:cNvCxnSpPr>
             <a:stCxn xmlns:a="http://schemas.openxmlformats.org/drawingml/2006/main" id="7" idx="3"/>
             <a:endCxn xmlns:a="http://schemas.openxmlformats.org/drawingml/2006/main" id="11" idx="1"/>
@@ -12803,7 +12995,7 @@
       </p:cxnSp>
       <p:cxnSp>
         <p:nvCxnSpPr>
-          <p:cNvPr id="267" name=""/>
+          <p:cNvPr id="319" name=""/>
           <p:cNvCxnSpPr>
             <a:stCxn xmlns:a="http://schemas.openxmlformats.org/drawingml/2006/main" id="11" idx="3"/>
             <a:endCxn xmlns:a="http://schemas.openxmlformats.org/drawingml/2006/main" id="15" idx="1"/>
@@ -12829,7 +13021,7 @@
       </p:cxnSp>
       <p:cxnSp>
         <p:nvCxnSpPr>
-          <p:cNvPr id="268" name=""/>
+          <p:cNvPr id="320" name=""/>
           <p:cNvCxnSpPr>
             <a:stCxn xmlns:a="http://schemas.openxmlformats.org/drawingml/2006/main" id="15" idx="3"/>
             <a:endCxn xmlns:a="http://schemas.openxmlformats.org/drawingml/2006/main" id="19" idx="1"/>
@@ -13287,6 +13479,3606 @@
                 <a:cs typeface="Calibri"/>
               </a:rPr>
               <a:t>07</a:t>
+            </a:r>
+          </a:p>
+        </p:txBody>
+      </p:sp>
+    </p:spTree>
+    <p:extLst>
+      <p:ext uri="{BB962C8B-B14F-4D97-AF65-F5344CB8AC3E}">
+        <p14:creationId xmlns:p14="http://schemas.microsoft.com/office/powerpoint/2010/main" val="1169510731"/>
+      </p:ext>
+    </p:extLst>
+  </p:cSld>
+</p:sld>
+</file>
+
+<file path=ppt/slides/slide8.xml><?xml version="1.0" encoding="utf-8"?>
+<p:sld xmlns:p="http://schemas.openxmlformats.org/presentationml/2006/main">
+  <p:cSld>
+    <p:bg>
+      <p:bgPr>
+        <a:solidFill xmlns:a="http://schemas.openxmlformats.org/drawingml/2006/main">
+          <a:srgbClr val="F5F5F5"/>
+        </a:solidFill>
+      </p:bgPr>
+    </p:bg>
+    <p:spTree>
+      <p:nvGrpSpPr>
+        <p:cNvPr id="1" name=""/>
+        <p:cNvGrpSpPr/>
+        <p:nvPr/>
+      </p:nvGrpSpPr>
+      <p:grpSpPr>
+        <a:xfrm xmlns:a="http://schemas.openxmlformats.org/drawingml/2006/main"/>
+      </p:grpSpPr>
+      <p:sp>
+        <p:nvSpPr>
+          <p:cNvPr id="35" name="">
+            <a:extLst xmlns:a="http://schemas.openxmlformats.org/drawingml/2006/main">
+              <a:ext uri="{FF2B5EF4-FFF2-40B4-BE49-F238E27FC236}">
+                <a16:creationId xmlns:a16="http://schemas.microsoft.com/office/drawing/2014/main" id="{45EAFBC5-0120-406B-9113-A189734D7D27}"/>
+              </a:ext>
+            </a:extLst>
+          </p:cNvPr>
+          <p:cNvSpPr>
+            <a:spLocks xmlns:a="http://schemas.openxmlformats.org/drawingml/2006/main" noGrp="1"/>
+          </p:cNvSpPr>
+          <p:nvPr/>
+        </p:nvSpPr>
+        <p:spPr>
+          <a:xfrm xmlns:a="http://schemas.openxmlformats.org/drawingml/2006/main">
+            <a:off x="971550" y="666750"/>
+            <a:ext cx="4762500" cy="342900"/>
+          </a:xfrm>
+          <a:prstGeom xmlns:a="http://schemas.openxmlformats.org/drawingml/2006/main" prst="rect">
+            <a:avLst/>
+          </a:prstGeom>
+          <a:noFill xmlns:a="http://schemas.openxmlformats.org/drawingml/2006/main"/>
+          <a:ln xmlns:a="http://schemas.openxmlformats.org/drawingml/2006/main" w="0">
+            <a:noFill/>
+            <a:prstDash val="solid"/>
+          </a:ln>
+        </p:spPr>
+        <p:txBody>
+          <a:bodyPr xmlns:a="http://schemas.openxmlformats.org/drawingml/2006/main" wrap="square" lIns="0" tIns="0" rIns="0" bIns="0" anchor="ctr">
+            <a:noAutofit/>
+          </a:bodyPr>
+          <a:lstStyle xmlns:a="http://schemas.openxmlformats.org/drawingml/2006/main"/>
+          <a:p xmlns:a="http://schemas.openxmlformats.org/drawingml/2006/main">
+            <a:pPr algn="l">
+              <a:lnSpc>
+                <a:spcPct val="100000"/>
+              </a:lnSpc>
+              <a:buNone/>
+              <a:defRPr sz="1425" b="1">
+                <a:solidFill>
+                  <a:srgbClr val="1F40CB"/>
+                </a:solidFill>
+                <a:latin typeface="Calibri"/>
+                <a:ea typeface="Calibri"/>
+                <a:cs typeface="Calibri"/>
+              </a:defRPr>
+            </a:pPr>
+            <a:r>
+              <a:rPr sz="1800" b="1">
+                <a:solidFill>
+                  <a:srgbClr val="1F40CB"/>
+                </a:solidFill>
+                <a:latin typeface="Calibri"/>
+                <a:ea typeface="Calibri"/>
+                <a:cs typeface="Calibri"/>
+              </a:rPr>
+              <a:t>STORAGE CONTRACT</a:t>
+            </a:r>
+          </a:p>
+        </p:txBody>
+      </p:sp>
+      <p:sp>
+        <p:nvSpPr>
+          <p:cNvPr id="2" name="">
+            <a:extLst xmlns:a="http://schemas.openxmlformats.org/drawingml/2006/main">
+              <a:ext uri="{FF2B5EF4-FFF2-40B4-BE49-F238E27FC236}">
+                <a16:creationId xmlns:a16="http://schemas.microsoft.com/office/drawing/2014/main" id="{E788E1BA-062C-4D13-89C4-9762E55DD5F6}"/>
+              </a:ext>
+            </a:extLst>
+          </p:cNvPr>
+          <p:cNvSpPr>
+            <a:spLocks xmlns:a="http://schemas.openxmlformats.org/drawingml/2006/main" noGrp="1"/>
+          </p:cNvSpPr>
+          <p:nvPr/>
+        </p:nvSpPr>
+        <p:spPr>
+          <a:xfrm xmlns:a="http://schemas.openxmlformats.org/drawingml/2006/main">
+            <a:off x="971550" y="1181100"/>
+            <a:ext cx="13296900" cy="781050"/>
+          </a:xfrm>
+          <a:prstGeom xmlns:a="http://schemas.openxmlformats.org/drawingml/2006/main" prst="rect">
+            <a:avLst/>
+          </a:prstGeom>
+          <a:noFill xmlns:a="http://schemas.openxmlformats.org/drawingml/2006/main"/>
+          <a:ln xmlns:a="http://schemas.openxmlformats.org/drawingml/2006/main" w="0">
+            <a:noFill/>
+            <a:prstDash val="solid"/>
+          </a:ln>
+        </p:spPr>
+        <p:txBody>
+          <a:bodyPr xmlns:a="http://schemas.openxmlformats.org/drawingml/2006/main" wrap="none" lIns="0" tIns="0" rIns="0" bIns="0" anchor="ctr">
+            <a:normAutofit fontScale="100000"/>
+          </a:bodyPr>
+          <a:lstStyle xmlns:a="http://schemas.openxmlformats.org/drawingml/2006/main"/>
+          <a:p xmlns:a="http://schemas.openxmlformats.org/drawingml/2006/main">
+            <a:pPr algn="l">
+              <a:lnSpc>
+                <a:spcPct val="100000"/>
+              </a:lnSpc>
+              <a:buNone/>
+              <a:defRPr sz="3600" b="1">
+                <a:solidFill>
+                  <a:srgbClr val="051C2A"/>
+                </a:solidFill>
+                <a:latin typeface="Calibri"/>
+                <a:ea typeface="Calibri"/>
+                <a:cs typeface="Calibri"/>
+              </a:defRPr>
+            </a:pPr>
+            <a:r>
+              <a:rPr sz="3600" b="1">
+                <a:solidFill>
+                  <a:srgbClr val="051C2A"/>
+                </a:solidFill>
+                <a:latin typeface="Calibri"/>
+                <a:ea typeface="Calibri"/>
+                <a:cs typeface="Calibri"/>
+              </a:rPr>
+              <a:t>Keep one logical schema when the vector engine changes</a:t>
+            </a:r>
+          </a:p>
+        </p:txBody>
+      </p:sp>
+      <p:sp>
+        <p:nvSpPr>
+          <p:cNvPr id="3" name="ingestion-1">
+            <a:extLst xmlns:a="http://schemas.openxmlformats.org/drawingml/2006/main">
+              <a:ext uri="{FF2B5EF4-FFF2-40B4-BE49-F238E27FC236}">
+                <a16:creationId xmlns:a16="http://schemas.microsoft.com/office/drawing/2014/main" id="{EF5CEA91-0836-4E99-95C1-43A271A11FFF}"/>
+              </a:ext>
+            </a:extLst>
+          </p:cNvPr>
+          <p:cNvSpPr>
+            <a:spLocks xmlns:a="http://schemas.openxmlformats.org/drawingml/2006/main" noGrp="1"/>
+          </p:cNvSpPr>
+          <p:nvPr/>
+        </p:nvSpPr>
+        <p:spPr>
+          <a:xfrm xmlns:a="http://schemas.openxmlformats.org/drawingml/2006/main">
+            <a:off x="990600" y="3086100"/>
+            <a:ext cx="2247900" cy="2266950"/>
+          </a:xfrm>
+          <a:prstGeom xmlns:a="http://schemas.openxmlformats.org/drawingml/2006/main" prst="roundRect">
+            <a:avLst>
+              <a:gd name="adj" fmla="val 5085"/>
+            </a:avLst>
+          </a:prstGeom>
+          <a:solidFill xmlns:a="http://schemas.openxmlformats.org/drawingml/2006/main">
+            <a:srgbClr val="FFFFFF"/>
+          </a:solidFill>
+          <a:ln xmlns:a="http://schemas.openxmlformats.org/drawingml/2006/main" w="9525">
+            <a:solidFill>
+              <a:srgbClr val="E4E7E9"/>
+            </a:solidFill>
+            <a:prstDash val="solid"/>
+          </a:ln>
+        </p:spPr>
+      </p:sp>
+      <p:sp>
+        <p:nvSpPr>
+          <p:cNvPr id="4" name="">
+            <a:extLst xmlns:a="http://schemas.openxmlformats.org/drawingml/2006/main">
+              <a:ext uri="{FF2B5EF4-FFF2-40B4-BE49-F238E27FC236}">
+                <a16:creationId xmlns:a16="http://schemas.microsoft.com/office/drawing/2014/main" id="{4A163ADC-FDBA-49AB-AB53-62FA29104479}"/>
+              </a:ext>
+            </a:extLst>
+          </p:cNvPr>
+          <p:cNvSpPr>
+            <a:spLocks xmlns:a="http://schemas.openxmlformats.org/drawingml/2006/main" noGrp="1"/>
+          </p:cNvSpPr>
+          <p:nvPr/>
+        </p:nvSpPr>
+        <p:spPr>
+          <a:xfrm xmlns:a="http://schemas.openxmlformats.org/drawingml/2006/main">
+            <a:off x="1181100" y="3295650"/>
+            <a:ext cx="514350" cy="285750"/>
+          </a:xfrm>
+          <a:prstGeom xmlns:a="http://schemas.openxmlformats.org/drawingml/2006/main" prst="rect">
+            <a:avLst/>
+          </a:prstGeom>
+          <a:noFill xmlns:a="http://schemas.openxmlformats.org/drawingml/2006/main"/>
+          <a:ln xmlns:a="http://schemas.openxmlformats.org/drawingml/2006/main" w="0">
+            <a:noFill/>
+            <a:prstDash val="solid"/>
+          </a:ln>
+        </p:spPr>
+        <p:txBody>
+          <a:bodyPr xmlns:a="http://schemas.openxmlformats.org/drawingml/2006/main" wrap="square" lIns="0" tIns="0" rIns="0" bIns="0" anchor="ctr">
+            <a:noAutofit/>
+          </a:bodyPr>
+          <a:lstStyle xmlns:a="http://schemas.openxmlformats.org/drawingml/2006/main"/>
+          <a:p xmlns:a="http://schemas.openxmlformats.org/drawingml/2006/main">
+            <a:pPr algn="l">
+              <a:lnSpc>
+                <a:spcPct val="100000"/>
+              </a:lnSpc>
+              <a:buNone/>
+              <a:defRPr sz="1350" b="1">
+                <a:solidFill>
+                  <a:srgbClr val="00A2EB"/>
+                </a:solidFill>
+                <a:latin typeface="Calibri"/>
+                <a:ea typeface="Calibri"/>
+                <a:cs typeface="Calibri"/>
+              </a:defRPr>
+            </a:pPr>
+            <a:r>
+              <a:rPr sz="1800" b="1">
+                <a:solidFill>
+                  <a:srgbClr val="00A2EB"/>
+                </a:solidFill>
+                <a:latin typeface="Calibri"/>
+                <a:ea typeface="Calibri"/>
+                <a:cs typeface="Calibri"/>
+              </a:rPr>
+              <a:t>01</a:t>
+            </a:r>
+          </a:p>
+        </p:txBody>
+      </p:sp>
+      <p:sp>
+        <p:nvSpPr>
+          <p:cNvPr id="5" name="">
+            <a:extLst xmlns:a="http://schemas.openxmlformats.org/drawingml/2006/main">
+              <a:ext uri="{FF2B5EF4-FFF2-40B4-BE49-F238E27FC236}">
+                <a16:creationId xmlns:a16="http://schemas.microsoft.com/office/drawing/2014/main" id="{26D1AD73-F995-4369-A266-8FA41354CE3D}"/>
+              </a:ext>
+            </a:extLst>
+          </p:cNvPr>
+          <p:cNvSpPr>
+            <a:spLocks xmlns:a="http://schemas.openxmlformats.org/drawingml/2006/main" noGrp="1"/>
+          </p:cNvSpPr>
+          <p:nvPr/>
+        </p:nvSpPr>
+        <p:spPr>
+          <a:xfrm xmlns:a="http://schemas.openxmlformats.org/drawingml/2006/main">
+            <a:off x="1104900" y="3752850"/>
+            <a:ext cx="2019300" cy="685800"/>
+          </a:xfrm>
+          <a:prstGeom xmlns:a="http://schemas.openxmlformats.org/drawingml/2006/main" prst="rect">
+            <a:avLst/>
+          </a:prstGeom>
+          <a:noFill xmlns:a="http://schemas.openxmlformats.org/drawingml/2006/main"/>
+          <a:ln xmlns:a="http://schemas.openxmlformats.org/drawingml/2006/main" w="0">
+            <a:noFill/>
+            <a:prstDash val="solid"/>
+          </a:ln>
+        </p:spPr>
+        <p:txBody>
+          <a:bodyPr xmlns:a="http://schemas.openxmlformats.org/drawingml/2006/main" wrap="square" lIns="0" tIns="0" rIns="0" bIns="0" anchor="ctr">
+            <a:normAutofit fontScale="100000"/>
+          </a:bodyPr>
+          <a:lstStyle xmlns:a="http://schemas.openxmlformats.org/drawingml/2006/main"/>
+          <a:p xmlns:a="http://schemas.openxmlformats.org/drawingml/2006/main">
+            <a:pPr algn="l">
+              <a:lnSpc>
+                <a:spcPct val="100000"/>
+              </a:lnSpc>
+              <a:buNone/>
+              <a:defRPr sz="1950" b="1">
+                <a:solidFill>
+                  <a:srgbClr val="051C2A"/>
+                </a:solidFill>
+                <a:latin typeface="Calibri"/>
+                <a:ea typeface="Calibri"/>
+                <a:cs typeface="Calibri"/>
+              </a:defRPr>
+            </a:pPr>
+            <a:r>
+              <a:rPr sz="1950" b="1">
+                <a:solidFill>
+                  <a:srgbClr val="051C2A"/>
+                </a:solidFill>
+                <a:latin typeface="Calibri"/>
+                <a:ea typeface="Calibri"/>
+                <a:cs typeface="Calibri"/>
+              </a:rPr>
+              <a:t>Documents</a:t>
+            </a:r>
+          </a:p>
+        </p:txBody>
+      </p:sp>
+      <p:sp>
+        <p:nvSpPr>
+          <p:cNvPr id="6" name="">
+            <a:extLst xmlns:a="http://schemas.openxmlformats.org/drawingml/2006/main">
+              <a:ext uri="{FF2B5EF4-FFF2-40B4-BE49-F238E27FC236}">
+                <a16:creationId xmlns:a16="http://schemas.microsoft.com/office/drawing/2014/main" id="{4CA7F72B-07B6-4BF4-A3F9-5860F8AC7245}"/>
+              </a:ext>
+            </a:extLst>
+          </p:cNvPr>
+          <p:cNvSpPr>
+            <a:spLocks xmlns:a="http://schemas.openxmlformats.org/drawingml/2006/main" noGrp="1"/>
+          </p:cNvSpPr>
+          <p:nvPr/>
+        </p:nvSpPr>
+        <p:spPr>
+          <a:xfrm xmlns:a="http://schemas.openxmlformats.org/drawingml/2006/main">
+            <a:off x="1181100" y="4610100"/>
+            <a:ext cx="1866900" cy="514350"/>
+          </a:xfrm>
+          <a:prstGeom xmlns:a="http://schemas.openxmlformats.org/drawingml/2006/main" prst="rect">
+            <a:avLst/>
+          </a:prstGeom>
+          <a:noFill xmlns:a="http://schemas.openxmlformats.org/drawingml/2006/main"/>
+          <a:ln xmlns:a="http://schemas.openxmlformats.org/drawingml/2006/main" w="0">
+            <a:noFill/>
+            <a:prstDash val="solid"/>
+          </a:ln>
+        </p:spPr>
+        <p:txBody>
+          <a:bodyPr xmlns:a="http://schemas.openxmlformats.org/drawingml/2006/main" wrap="square" lIns="0" tIns="0" rIns="0" bIns="0" anchor="ctr">
+            <a:normAutofit fontScale="100000"/>
+          </a:bodyPr>
+          <a:lstStyle xmlns:a="http://schemas.openxmlformats.org/drawingml/2006/main"/>
+          <a:p xmlns:a="http://schemas.openxmlformats.org/drawingml/2006/main">
+            <a:pPr algn="l">
+              <a:lnSpc>
+                <a:spcPct val="100000"/>
+              </a:lnSpc>
+              <a:buNone/>
+              <a:defRPr sz="1200" b="0">
+                <a:solidFill>
+                  <a:srgbClr val="1F40CB"/>
+                </a:solidFill>
+                <a:latin typeface="Calibri"/>
+                <a:ea typeface="Calibri"/>
+                <a:cs typeface="Calibri"/>
+              </a:defRPr>
+            </a:pPr>
+            <a:r>
+              <a:rPr sz="1200" b="0">
+                <a:solidFill>
+                  <a:srgbClr val="1F40CB"/>
+                </a:solidFill>
+                <a:latin typeface="Calibri"/>
+                <a:ea typeface="Calibri"/>
+                <a:cs typeface="Calibri"/>
+              </a:rPr>
+              <a:t>source · company · period</a:t>
+            </a:r>
+          </a:p>
+        </p:txBody>
+      </p:sp>
+      <p:sp>
+        <p:nvSpPr>
+          <p:cNvPr id="7" name="ingestion-2">
+            <a:extLst xmlns:a="http://schemas.openxmlformats.org/drawingml/2006/main">
+              <a:ext uri="{FF2B5EF4-FFF2-40B4-BE49-F238E27FC236}">
+                <a16:creationId xmlns:a16="http://schemas.microsoft.com/office/drawing/2014/main" id="{B39DEECB-E0D1-415A-8F2A-C8075A6D97BA}"/>
+              </a:ext>
+            </a:extLst>
+          </p:cNvPr>
+          <p:cNvSpPr>
+            <a:spLocks xmlns:a="http://schemas.openxmlformats.org/drawingml/2006/main" noGrp="1"/>
+          </p:cNvSpPr>
+          <p:nvPr/>
+        </p:nvSpPr>
+        <p:spPr>
+          <a:xfrm xmlns:a="http://schemas.openxmlformats.org/drawingml/2006/main">
+            <a:off x="3810000" y="3086100"/>
+            <a:ext cx="2247900" cy="2266950"/>
+          </a:xfrm>
+          <a:prstGeom xmlns:a="http://schemas.openxmlformats.org/drawingml/2006/main" prst="roundRect">
+            <a:avLst>
+              <a:gd name="adj" fmla="val 5085"/>
+            </a:avLst>
+          </a:prstGeom>
+          <a:solidFill xmlns:a="http://schemas.openxmlformats.org/drawingml/2006/main">
+            <a:srgbClr val="FFFFFF"/>
+          </a:solidFill>
+          <a:ln xmlns:a="http://schemas.openxmlformats.org/drawingml/2006/main" w="9525">
+            <a:solidFill>
+              <a:srgbClr val="E4E7E9"/>
+            </a:solidFill>
+            <a:prstDash val="solid"/>
+          </a:ln>
+        </p:spPr>
+      </p:sp>
+      <p:sp>
+        <p:nvSpPr>
+          <p:cNvPr id="8" name="">
+            <a:extLst xmlns:a="http://schemas.openxmlformats.org/drawingml/2006/main">
+              <a:ext uri="{FF2B5EF4-FFF2-40B4-BE49-F238E27FC236}">
+                <a16:creationId xmlns:a16="http://schemas.microsoft.com/office/drawing/2014/main" id="{18679081-8A68-4B7E-9199-340CF95714DE}"/>
+              </a:ext>
+            </a:extLst>
+          </p:cNvPr>
+          <p:cNvSpPr>
+            <a:spLocks xmlns:a="http://schemas.openxmlformats.org/drawingml/2006/main" noGrp="1"/>
+          </p:cNvSpPr>
+          <p:nvPr/>
+        </p:nvSpPr>
+        <p:spPr>
+          <a:xfrm xmlns:a="http://schemas.openxmlformats.org/drawingml/2006/main">
+            <a:off x="4000500" y="3295650"/>
+            <a:ext cx="514350" cy="285750"/>
+          </a:xfrm>
+          <a:prstGeom xmlns:a="http://schemas.openxmlformats.org/drawingml/2006/main" prst="rect">
+            <a:avLst/>
+          </a:prstGeom>
+          <a:noFill xmlns:a="http://schemas.openxmlformats.org/drawingml/2006/main"/>
+          <a:ln xmlns:a="http://schemas.openxmlformats.org/drawingml/2006/main" w="0">
+            <a:noFill/>
+            <a:prstDash val="solid"/>
+          </a:ln>
+        </p:spPr>
+        <p:txBody>
+          <a:bodyPr xmlns:a="http://schemas.openxmlformats.org/drawingml/2006/main" wrap="square" lIns="0" tIns="0" rIns="0" bIns="0" anchor="ctr">
+            <a:noAutofit/>
+          </a:bodyPr>
+          <a:lstStyle xmlns:a="http://schemas.openxmlformats.org/drawingml/2006/main"/>
+          <a:p xmlns:a="http://schemas.openxmlformats.org/drawingml/2006/main">
+            <a:pPr algn="l">
+              <a:lnSpc>
+                <a:spcPct val="100000"/>
+              </a:lnSpc>
+              <a:buNone/>
+              <a:defRPr sz="1350" b="1">
+                <a:solidFill>
+                  <a:srgbClr val="00A2EB"/>
+                </a:solidFill>
+                <a:latin typeface="Calibri"/>
+                <a:ea typeface="Calibri"/>
+                <a:cs typeface="Calibri"/>
+              </a:defRPr>
+            </a:pPr>
+            <a:r>
+              <a:rPr sz="1800" b="1">
+                <a:solidFill>
+                  <a:srgbClr val="00A2EB"/>
+                </a:solidFill>
+                <a:latin typeface="Calibri"/>
+                <a:ea typeface="Calibri"/>
+                <a:cs typeface="Calibri"/>
+              </a:rPr>
+              <a:t>02</a:t>
+            </a:r>
+          </a:p>
+        </p:txBody>
+      </p:sp>
+      <p:sp>
+        <p:nvSpPr>
+          <p:cNvPr id="9" name="">
+            <a:extLst xmlns:a="http://schemas.openxmlformats.org/drawingml/2006/main">
+              <a:ext uri="{FF2B5EF4-FFF2-40B4-BE49-F238E27FC236}">
+                <a16:creationId xmlns:a16="http://schemas.microsoft.com/office/drawing/2014/main" id="{ED095E54-44DC-4092-9EB7-0C81E4B47710}"/>
+              </a:ext>
+            </a:extLst>
+          </p:cNvPr>
+          <p:cNvSpPr>
+            <a:spLocks xmlns:a="http://schemas.openxmlformats.org/drawingml/2006/main" noGrp="1"/>
+          </p:cNvSpPr>
+          <p:nvPr/>
+        </p:nvSpPr>
+        <p:spPr>
+          <a:xfrm xmlns:a="http://schemas.openxmlformats.org/drawingml/2006/main">
+            <a:off x="3924300" y="3752850"/>
+            <a:ext cx="2019300" cy="685800"/>
+          </a:xfrm>
+          <a:prstGeom xmlns:a="http://schemas.openxmlformats.org/drawingml/2006/main" prst="rect">
+            <a:avLst/>
+          </a:prstGeom>
+          <a:noFill xmlns:a="http://schemas.openxmlformats.org/drawingml/2006/main"/>
+          <a:ln xmlns:a="http://schemas.openxmlformats.org/drawingml/2006/main" w="0">
+            <a:noFill/>
+            <a:prstDash val="solid"/>
+          </a:ln>
+        </p:spPr>
+        <p:txBody>
+          <a:bodyPr xmlns:a="http://schemas.openxmlformats.org/drawingml/2006/main" wrap="square" lIns="0" tIns="0" rIns="0" bIns="0" anchor="ctr">
+            <a:normAutofit fontScale="100000"/>
+          </a:bodyPr>
+          <a:lstStyle xmlns:a="http://schemas.openxmlformats.org/drawingml/2006/main"/>
+          <a:p xmlns:a="http://schemas.openxmlformats.org/drawingml/2006/main">
+            <a:pPr algn="l">
+              <a:lnSpc>
+                <a:spcPct val="100000"/>
+              </a:lnSpc>
+              <a:buNone/>
+              <a:defRPr sz="1950" b="1">
+                <a:solidFill>
+                  <a:srgbClr val="051C2A"/>
+                </a:solidFill>
+                <a:latin typeface="Calibri"/>
+                <a:ea typeface="Calibri"/>
+                <a:cs typeface="Calibri"/>
+              </a:defRPr>
+            </a:pPr>
+            <a:r>
+              <a:rPr sz="1950" b="1">
+                <a:solidFill>
+                  <a:srgbClr val="051C2A"/>
+                </a:solidFill>
+                <a:latin typeface="Calibri"/>
+                <a:ea typeface="Calibri"/>
+                <a:cs typeface="Calibri"/>
+              </a:rPr>
+              <a:t>Chunks</a:t>
+            </a:r>
+          </a:p>
+        </p:txBody>
+      </p:sp>
+      <p:sp>
+        <p:nvSpPr>
+          <p:cNvPr id="10" name="">
+            <a:extLst xmlns:a="http://schemas.openxmlformats.org/drawingml/2006/main">
+              <a:ext uri="{FF2B5EF4-FFF2-40B4-BE49-F238E27FC236}">
+                <a16:creationId xmlns:a16="http://schemas.microsoft.com/office/drawing/2014/main" id="{4DB65E8E-6BA9-40DB-99F9-46D3397B13A3}"/>
+              </a:ext>
+            </a:extLst>
+          </p:cNvPr>
+          <p:cNvSpPr>
+            <a:spLocks xmlns:a="http://schemas.openxmlformats.org/drawingml/2006/main" noGrp="1"/>
+          </p:cNvSpPr>
+          <p:nvPr/>
+        </p:nvSpPr>
+        <p:spPr>
+          <a:xfrm xmlns:a="http://schemas.openxmlformats.org/drawingml/2006/main">
+            <a:off x="4000500" y="4610100"/>
+            <a:ext cx="1866900" cy="514350"/>
+          </a:xfrm>
+          <a:prstGeom xmlns:a="http://schemas.openxmlformats.org/drawingml/2006/main" prst="rect">
+            <a:avLst/>
+          </a:prstGeom>
+          <a:noFill xmlns:a="http://schemas.openxmlformats.org/drawingml/2006/main"/>
+          <a:ln xmlns:a="http://schemas.openxmlformats.org/drawingml/2006/main" w="0">
+            <a:noFill/>
+            <a:prstDash val="solid"/>
+          </a:ln>
+        </p:spPr>
+        <p:txBody>
+          <a:bodyPr xmlns:a="http://schemas.openxmlformats.org/drawingml/2006/main" wrap="square" lIns="0" tIns="0" rIns="0" bIns="0" anchor="ctr">
+            <a:normAutofit fontScale="100000"/>
+          </a:bodyPr>
+          <a:lstStyle xmlns:a="http://schemas.openxmlformats.org/drawingml/2006/main"/>
+          <a:p xmlns:a="http://schemas.openxmlformats.org/drawingml/2006/main">
+            <a:pPr algn="l">
+              <a:lnSpc>
+                <a:spcPct val="100000"/>
+              </a:lnSpc>
+              <a:buNone/>
+              <a:defRPr sz="1200" b="0">
+                <a:solidFill>
+                  <a:srgbClr val="1F40CB"/>
+                </a:solidFill>
+                <a:latin typeface="Calibri"/>
+                <a:ea typeface="Calibri"/>
+                <a:cs typeface="Calibri"/>
+              </a:defRPr>
+            </a:pPr>
+            <a:r>
+              <a:rPr sz="1200" b="0">
+                <a:solidFill>
+                  <a:srgbClr val="1F40CB"/>
+                </a:solidFill>
+                <a:latin typeface="Calibri"/>
+                <a:ea typeface="Calibri"/>
+                <a:cs typeface="Calibri"/>
+              </a:rPr>
+              <a:t>stable ID · page · section</a:t>
+            </a:r>
+          </a:p>
+        </p:txBody>
+      </p:sp>
+      <p:sp>
+        <p:nvSpPr>
+          <p:cNvPr id="11" name="ingestion-3">
+            <a:extLst xmlns:a="http://schemas.openxmlformats.org/drawingml/2006/main">
+              <a:ext uri="{FF2B5EF4-FFF2-40B4-BE49-F238E27FC236}">
+                <a16:creationId xmlns:a16="http://schemas.microsoft.com/office/drawing/2014/main" id="{D4342A97-3791-461F-A305-9671DA4948CE}"/>
+              </a:ext>
+            </a:extLst>
+          </p:cNvPr>
+          <p:cNvSpPr>
+            <a:spLocks xmlns:a="http://schemas.openxmlformats.org/drawingml/2006/main" noGrp="1"/>
+          </p:cNvSpPr>
+          <p:nvPr/>
+        </p:nvSpPr>
+        <p:spPr>
+          <a:xfrm xmlns:a="http://schemas.openxmlformats.org/drawingml/2006/main">
+            <a:off x="6629400" y="3086100"/>
+            <a:ext cx="2247900" cy="2266950"/>
+          </a:xfrm>
+          <a:prstGeom xmlns:a="http://schemas.openxmlformats.org/drawingml/2006/main" prst="roundRect">
+            <a:avLst>
+              <a:gd name="adj" fmla="val 5085"/>
+            </a:avLst>
+          </a:prstGeom>
+          <a:solidFill xmlns:a="http://schemas.openxmlformats.org/drawingml/2006/main">
+            <a:srgbClr val="062433"/>
+          </a:solidFill>
+          <a:ln xmlns:a="http://schemas.openxmlformats.org/drawingml/2006/main" w="9525">
+            <a:solidFill>
+              <a:srgbClr val="062433"/>
+            </a:solidFill>
+            <a:prstDash val="solid"/>
+          </a:ln>
+        </p:spPr>
+      </p:sp>
+      <p:sp>
+        <p:nvSpPr>
+          <p:cNvPr id="12" name="">
+            <a:extLst xmlns:a="http://schemas.openxmlformats.org/drawingml/2006/main">
+              <a:ext uri="{FF2B5EF4-FFF2-40B4-BE49-F238E27FC236}">
+                <a16:creationId xmlns:a16="http://schemas.microsoft.com/office/drawing/2014/main" id="{64E49A95-2D88-4387-8BD5-FA749ABD0960}"/>
+              </a:ext>
+            </a:extLst>
+          </p:cNvPr>
+          <p:cNvSpPr>
+            <a:spLocks xmlns:a="http://schemas.openxmlformats.org/drawingml/2006/main" noGrp="1"/>
+          </p:cNvSpPr>
+          <p:nvPr/>
+        </p:nvSpPr>
+        <p:spPr>
+          <a:xfrm xmlns:a="http://schemas.openxmlformats.org/drawingml/2006/main">
+            <a:off x="6819900" y="3295650"/>
+            <a:ext cx="514350" cy="285750"/>
+          </a:xfrm>
+          <a:prstGeom xmlns:a="http://schemas.openxmlformats.org/drawingml/2006/main" prst="rect">
+            <a:avLst/>
+          </a:prstGeom>
+          <a:noFill xmlns:a="http://schemas.openxmlformats.org/drawingml/2006/main"/>
+          <a:ln xmlns:a="http://schemas.openxmlformats.org/drawingml/2006/main" w="0">
+            <a:noFill/>
+            <a:prstDash val="solid"/>
+          </a:ln>
+        </p:spPr>
+        <p:txBody>
+          <a:bodyPr xmlns:a="http://schemas.openxmlformats.org/drawingml/2006/main" wrap="square" lIns="0" tIns="0" rIns="0" bIns="0" anchor="ctr">
+            <a:noAutofit/>
+          </a:bodyPr>
+          <a:lstStyle xmlns:a="http://schemas.openxmlformats.org/drawingml/2006/main"/>
+          <a:p xmlns:a="http://schemas.openxmlformats.org/drawingml/2006/main">
+            <a:pPr algn="l">
+              <a:lnSpc>
+                <a:spcPct val="100000"/>
+              </a:lnSpc>
+              <a:buNone/>
+              <a:defRPr sz="1350" b="1">
+                <a:solidFill>
+                  <a:srgbClr val="00A2EB"/>
+                </a:solidFill>
+                <a:latin typeface="Calibri"/>
+                <a:ea typeface="Calibri"/>
+                <a:cs typeface="Calibri"/>
+              </a:defRPr>
+            </a:pPr>
+            <a:r>
+              <a:rPr sz="1800" b="1">
+                <a:solidFill>
+                  <a:srgbClr val="00A2EB"/>
+                </a:solidFill>
+                <a:latin typeface="Calibri"/>
+                <a:ea typeface="Calibri"/>
+                <a:cs typeface="Calibri"/>
+              </a:rPr>
+              <a:t>03</a:t>
+            </a:r>
+          </a:p>
+        </p:txBody>
+      </p:sp>
+      <p:sp>
+        <p:nvSpPr>
+          <p:cNvPr id="13" name="">
+            <a:extLst xmlns:a="http://schemas.openxmlformats.org/drawingml/2006/main">
+              <a:ext uri="{FF2B5EF4-FFF2-40B4-BE49-F238E27FC236}">
+                <a16:creationId xmlns:a16="http://schemas.microsoft.com/office/drawing/2014/main" id="{572D3874-F985-4CD0-BBFF-D59F5B7B32BE}"/>
+              </a:ext>
+            </a:extLst>
+          </p:cNvPr>
+          <p:cNvSpPr>
+            <a:spLocks xmlns:a="http://schemas.openxmlformats.org/drawingml/2006/main" noGrp="1"/>
+          </p:cNvSpPr>
+          <p:nvPr/>
+        </p:nvSpPr>
+        <p:spPr>
+          <a:xfrm xmlns:a="http://schemas.openxmlformats.org/drawingml/2006/main">
+            <a:off x="6743700" y="3752850"/>
+            <a:ext cx="2019300" cy="685800"/>
+          </a:xfrm>
+          <a:prstGeom xmlns:a="http://schemas.openxmlformats.org/drawingml/2006/main" prst="rect">
+            <a:avLst/>
+          </a:prstGeom>
+          <a:noFill xmlns:a="http://schemas.openxmlformats.org/drawingml/2006/main"/>
+          <a:ln xmlns:a="http://schemas.openxmlformats.org/drawingml/2006/main" w="0">
+            <a:noFill/>
+            <a:prstDash val="solid"/>
+          </a:ln>
+        </p:spPr>
+        <p:txBody>
+          <a:bodyPr xmlns:a="http://schemas.openxmlformats.org/drawingml/2006/main" wrap="square" lIns="0" tIns="0" rIns="0" bIns="0" anchor="ctr">
+            <a:noAutofit/>
+          </a:bodyPr>
+          <a:lstStyle xmlns:a="http://schemas.openxmlformats.org/drawingml/2006/main"/>
+          <a:p xmlns:a="http://schemas.openxmlformats.org/drawingml/2006/main">
+            <a:pPr algn="l">
+              <a:lnSpc>
+                <a:spcPct val="100000"/>
+              </a:lnSpc>
+              <a:buNone/>
+              <a:defRPr sz="1650" b="1">
+                <a:solidFill>
+                  <a:srgbClr val="FFFFFF"/>
+                </a:solidFill>
+                <a:latin typeface="Calibri"/>
+                <a:ea typeface="Calibri"/>
+                <a:cs typeface="Calibri"/>
+              </a:defRPr>
+            </a:pPr>
+            <a:r>
+              <a:rPr sz="1800" b="1">
+                <a:solidFill>
+                  <a:srgbClr val="FFFFFF"/>
+                </a:solidFill>
+                <a:latin typeface="Calibri"/>
+                <a:ea typeface="Calibri"/>
+                <a:cs typeface="Calibri"/>
+              </a:rPr>
+              <a:t>Embeddings</a:t>
+            </a:r>
+          </a:p>
+        </p:txBody>
+      </p:sp>
+      <p:sp>
+        <p:nvSpPr>
+          <p:cNvPr id="14" name="">
+            <a:extLst xmlns:a="http://schemas.openxmlformats.org/drawingml/2006/main">
+              <a:ext uri="{FF2B5EF4-FFF2-40B4-BE49-F238E27FC236}">
+                <a16:creationId xmlns:a16="http://schemas.microsoft.com/office/drawing/2014/main" id="{9599AF29-91DE-47C0-8189-B0778BB52724}"/>
+              </a:ext>
+            </a:extLst>
+          </p:cNvPr>
+          <p:cNvSpPr>
+            <a:spLocks xmlns:a="http://schemas.openxmlformats.org/drawingml/2006/main" noGrp="1"/>
+          </p:cNvSpPr>
+          <p:nvPr/>
+        </p:nvSpPr>
+        <p:spPr>
+          <a:xfrm xmlns:a="http://schemas.openxmlformats.org/drawingml/2006/main">
+            <a:off x="6819900" y="4610100"/>
+            <a:ext cx="1866900" cy="514350"/>
+          </a:xfrm>
+          <a:prstGeom xmlns:a="http://schemas.openxmlformats.org/drawingml/2006/main" prst="rect">
+            <a:avLst/>
+          </a:prstGeom>
+          <a:noFill xmlns:a="http://schemas.openxmlformats.org/drawingml/2006/main"/>
+          <a:ln xmlns:a="http://schemas.openxmlformats.org/drawingml/2006/main" w="0">
+            <a:noFill/>
+            <a:prstDash val="solid"/>
+          </a:ln>
+        </p:spPr>
+        <p:txBody>
+          <a:bodyPr xmlns:a="http://schemas.openxmlformats.org/drawingml/2006/main" wrap="square" lIns="0" tIns="0" rIns="0" bIns="0" anchor="ctr">
+            <a:normAutofit fontScale="100000"/>
+          </a:bodyPr>
+          <a:lstStyle xmlns:a="http://schemas.openxmlformats.org/drawingml/2006/main"/>
+          <a:p xmlns:a="http://schemas.openxmlformats.org/drawingml/2006/main">
+            <a:pPr algn="l">
+              <a:lnSpc>
+                <a:spcPct val="100000"/>
+              </a:lnSpc>
+              <a:buNone/>
+              <a:defRPr sz="1200" b="0">
+                <a:solidFill>
+                  <a:srgbClr val="00A2EB"/>
+                </a:solidFill>
+                <a:latin typeface="Calibri"/>
+                <a:ea typeface="Calibri"/>
+                <a:cs typeface="Calibri"/>
+              </a:defRPr>
+            </a:pPr>
+            <a:r>
+              <a:rPr sz="1200" b="0">
+                <a:solidFill>
+                  <a:srgbClr val="00A2EB"/>
+                </a:solidFill>
+                <a:latin typeface="Calibri"/>
+                <a:ea typeface="Calibri"/>
+                <a:cs typeface="Calibri"/>
+              </a:rPr>
+              <a:t>model · dimensions · vector</a:t>
+            </a:r>
+          </a:p>
+        </p:txBody>
+      </p:sp>
+      <p:sp>
+        <p:nvSpPr>
+          <p:cNvPr id="15" name="ingestion-4">
+            <a:extLst xmlns:a="http://schemas.openxmlformats.org/drawingml/2006/main">
+              <a:ext uri="{FF2B5EF4-FFF2-40B4-BE49-F238E27FC236}">
+                <a16:creationId xmlns:a16="http://schemas.microsoft.com/office/drawing/2014/main" id="{7952DE37-BD86-481C-A575-8709971DD74E}"/>
+              </a:ext>
+            </a:extLst>
+          </p:cNvPr>
+          <p:cNvSpPr>
+            <a:spLocks xmlns:a="http://schemas.openxmlformats.org/drawingml/2006/main" noGrp="1"/>
+          </p:cNvSpPr>
+          <p:nvPr/>
+        </p:nvSpPr>
+        <p:spPr>
+          <a:xfrm xmlns:a="http://schemas.openxmlformats.org/drawingml/2006/main">
+            <a:off x="9448800" y="3086100"/>
+            <a:ext cx="2247900" cy="2266950"/>
+          </a:xfrm>
+          <a:prstGeom xmlns:a="http://schemas.openxmlformats.org/drawingml/2006/main" prst="roundRect">
+            <a:avLst>
+              <a:gd name="adj" fmla="val 5085"/>
+            </a:avLst>
+          </a:prstGeom>
+          <a:solidFill xmlns:a="http://schemas.openxmlformats.org/drawingml/2006/main">
+            <a:srgbClr val="FFFFFF"/>
+          </a:solidFill>
+          <a:ln xmlns:a="http://schemas.openxmlformats.org/drawingml/2006/main" w="9525">
+            <a:solidFill>
+              <a:srgbClr val="E4E7E9"/>
+            </a:solidFill>
+            <a:prstDash val="solid"/>
+          </a:ln>
+        </p:spPr>
+      </p:sp>
+      <p:sp>
+        <p:nvSpPr>
+          <p:cNvPr id="16" name="">
+            <a:extLst xmlns:a="http://schemas.openxmlformats.org/drawingml/2006/main">
+              <a:ext uri="{FF2B5EF4-FFF2-40B4-BE49-F238E27FC236}">
+                <a16:creationId xmlns:a16="http://schemas.microsoft.com/office/drawing/2014/main" id="{62EC2EC9-18A1-4F72-A64D-AF536DDC8F61}"/>
+              </a:ext>
+            </a:extLst>
+          </p:cNvPr>
+          <p:cNvSpPr>
+            <a:spLocks xmlns:a="http://schemas.openxmlformats.org/drawingml/2006/main" noGrp="1"/>
+          </p:cNvSpPr>
+          <p:nvPr/>
+        </p:nvSpPr>
+        <p:spPr>
+          <a:xfrm xmlns:a="http://schemas.openxmlformats.org/drawingml/2006/main">
+            <a:off x="9639300" y="3295650"/>
+            <a:ext cx="514350" cy="285750"/>
+          </a:xfrm>
+          <a:prstGeom xmlns:a="http://schemas.openxmlformats.org/drawingml/2006/main" prst="rect">
+            <a:avLst/>
+          </a:prstGeom>
+          <a:noFill xmlns:a="http://schemas.openxmlformats.org/drawingml/2006/main"/>
+          <a:ln xmlns:a="http://schemas.openxmlformats.org/drawingml/2006/main" w="0">
+            <a:noFill/>
+            <a:prstDash val="solid"/>
+          </a:ln>
+        </p:spPr>
+        <p:txBody>
+          <a:bodyPr xmlns:a="http://schemas.openxmlformats.org/drawingml/2006/main" wrap="square" lIns="0" tIns="0" rIns="0" bIns="0" anchor="ctr">
+            <a:noAutofit/>
+          </a:bodyPr>
+          <a:lstStyle xmlns:a="http://schemas.openxmlformats.org/drawingml/2006/main"/>
+          <a:p xmlns:a="http://schemas.openxmlformats.org/drawingml/2006/main">
+            <a:pPr algn="l">
+              <a:lnSpc>
+                <a:spcPct val="100000"/>
+              </a:lnSpc>
+              <a:buNone/>
+              <a:defRPr sz="1350" b="1">
+                <a:solidFill>
+                  <a:srgbClr val="00A2EB"/>
+                </a:solidFill>
+                <a:latin typeface="Calibri"/>
+                <a:ea typeface="Calibri"/>
+                <a:cs typeface="Calibri"/>
+              </a:defRPr>
+            </a:pPr>
+            <a:r>
+              <a:rPr sz="1800" b="1">
+                <a:solidFill>
+                  <a:srgbClr val="00A2EB"/>
+                </a:solidFill>
+                <a:latin typeface="Calibri"/>
+                <a:ea typeface="Calibri"/>
+                <a:cs typeface="Calibri"/>
+              </a:rPr>
+              <a:t>04</a:t>
+            </a:r>
+          </a:p>
+        </p:txBody>
+      </p:sp>
+      <p:sp>
+        <p:nvSpPr>
+          <p:cNvPr id="17" name="">
+            <a:extLst xmlns:a="http://schemas.openxmlformats.org/drawingml/2006/main">
+              <a:ext uri="{FF2B5EF4-FFF2-40B4-BE49-F238E27FC236}">
+                <a16:creationId xmlns:a16="http://schemas.microsoft.com/office/drawing/2014/main" id="{8540FD5A-1C0F-4BE1-B862-685F20D0F43C}"/>
+              </a:ext>
+            </a:extLst>
+          </p:cNvPr>
+          <p:cNvSpPr>
+            <a:spLocks xmlns:a="http://schemas.openxmlformats.org/drawingml/2006/main" noGrp="1"/>
+          </p:cNvSpPr>
+          <p:nvPr/>
+        </p:nvSpPr>
+        <p:spPr>
+          <a:xfrm xmlns:a="http://schemas.openxmlformats.org/drawingml/2006/main">
+            <a:off x="9563100" y="3752850"/>
+            <a:ext cx="2019300" cy="685800"/>
+          </a:xfrm>
+          <a:prstGeom xmlns:a="http://schemas.openxmlformats.org/drawingml/2006/main" prst="rect">
+            <a:avLst/>
+          </a:prstGeom>
+          <a:noFill xmlns:a="http://schemas.openxmlformats.org/drawingml/2006/main"/>
+          <a:ln xmlns:a="http://schemas.openxmlformats.org/drawingml/2006/main" w="0">
+            <a:noFill/>
+            <a:prstDash val="solid"/>
+          </a:ln>
+        </p:spPr>
+        <p:txBody>
+          <a:bodyPr xmlns:a="http://schemas.openxmlformats.org/drawingml/2006/main" wrap="square" lIns="0" tIns="0" rIns="0" bIns="0" anchor="ctr">
+            <a:normAutofit fontScale="100000"/>
+          </a:bodyPr>
+          <a:lstStyle xmlns:a="http://schemas.openxmlformats.org/drawingml/2006/main"/>
+          <a:p xmlns:a="http://schemas.openxmlformats.org/drawingml/2006/main">
+            <a:pPr algn="l">
+              <a:lnSpc>
+                <a:spcPct val="100000"/>
+              </a:lnSpc>
+              <a:buNone/>
+              <a:defRPr sz="1950" b="1">
+                <a:solidFill>
+                  <a:srgbClr val="051C2A"/>
+                </a:solidFill>
+                <a:latin typeface="Calibri"/>
+                <a:ea typeface="Calibri"/>
+                <a:cs typeface="Calibri"/>
+              </a:defRPr>
+            </a:pPr>
+            <a:r>
+              <a:rPr sz="1950" b="1">
+                <a:solidFill>
+                  <a:srgbClr val="051C2A"/>
+                </a:solidFill>
+                <a:latin typeface="Calibri"/>
+                <a:ea typeface="Calibri"/>
+                <a:cs typeface="Calibri"/>
+              </a:rPr>
+              <a:t>Local index</a:t>
+            </a:r>
+          </a:p>
+        </p:txBody>
+      </p:sp>
+      <p:sp>
+        <p:nvSpPr>
+          <p:cNvPr id="18" name="">
+            <a:extLst xmlns:a="http://schemas.openxmlformats.org/drawingml/2006/main">
+              <a:ext uri="{FF2B5EF4-FFF2-40B4-BE49-F238E27FC236}">
+                <a16:creationId xmlns:a16="http://schemas.microsoft.com/office/drawing/2014/main" id="{67E52B70-645C-40F7-B0DE-1D1D177875CC}"/>
+              </a:ext>
+            </a:extLst>
+          </p:cNvPr>
+          <p:cNvSpPr>
+            <a:spLocks xmlns:a="http://schemas.openxmlformats.org/drawingml/2006/main" noGrp="1"/>
+          </p:cNvSpPr>
+          <p:nvPr/>
+        </p:nvSpPr>
+        <p:spPr>
+          <a:xfrm xmlns:a="http://schemas.openxmlformats.org/drawingml/2006/main">
+            <a:off x="9639300" y="4610100"/>
+            <a:ext cx="1866900" cy="514350"/>
+          </a:xfrm>
+          <a:prstGeom xmlns:a="http://schemas.openxmlformats.org/drawingml/2006/main" prst="rect">
+            <a:avLst/>
+          </a:prstGeom>
+          <a:noFill xmlns:a="http://schemas.openxmlformats.org/drawingml/2006/main"/>
+          <a:ln xmlns:a="http://schemas.openxmlformats.org/drawingml/2006/main" w="0">
+            <a:noFill/>
+            <a:prstDash val="solid"/>
+          </a:ln>
+        </p:spPr>
+        <p:txBody>
+          <a:bodyPr xmlns:a="http://schemas.openxmlformats.org/drawingml/2006/main" wrap="square" lIns="0" tIns="0" rIns="0" bIns="0" anchor="ctr">
+            <a:normAutofit fontScale="100000"/>
+          </a:bodyPr>
+          <a:lstStyle xmlns:a="http://schemas.openxmlformats.org/drawingml/2006/main"/>
+          <a:p xmlns:a="http://schemas.openxmlformats.org/drawingml/2006/main">
+            <a:pPr algn="l">
+              <a:lnSpc>
+                <a:spcPct val="100000"/>
+              </a:lnSpc>
+              <a:buNone/>
+              <a:defRPr sz="1200" b="0">
+                <a:solidFill>
+                  <a:srgbClr val="1F40CB"/>
+                </a:solidFill>
+                <a:latin typeface="Calibri"/>
+                <a:ea typeface="Calibri"/>
+                <a:cs typeface="Calibri"/>
+              </a:defRPr>
+            </a:pPr>
+            <a:r>
+              <a:rPr sz="1200" b="0">
+                <a:solidFill>
+                  <a:srgbClr val="1F40CB"/>
+                </a:solidFill>
+                <a:latin typeface="Calibri"/>
+                <a:ea typeface="Calibri"/>
+                <a:cs typeface="Calibri"/>
+              </a:rPr>
+              <a:t>NumPy · exact search</a:t>
+            </a:r>
+          </a:p>
+        </p:txBody>
+      </p:sp>
+      <p:sp>
+        <p:nvSpPr>
+          <p:cNvPr id="19" name="ingestion-5">
+            <a:extLst xmlns:a="http://schemas.openxmlformats.org/drawingml/2006/main">
+              <a:ext uri="{FF2B5EF4-FFF2-40B4-BE49-F238E27FC236}">
+                <a16:creationId xmlns:a16="http://schemas.microsoft.com/office/drawing/2014/main" id="{43F7E1B1-E237-4A79-B0C4-38965CF32D74}"/>
+              </a:ext>
+            </a:extLst>
+          </p:cNvPr>
+          <p:cNvSpPr>
+            <a:spLocks xmlns:a="http://schemas.openxmlformats.org/drawingml/2006/main" noGrp="1"/>
+          </p:cNvSpPr>
+          <p:nvPr/>
+        </p:nvSpPr>
+        <p:spPr>
+          <a:xfrm xmlns:a="http://schemas.openxmlformats.org/drawingml/2006/main">
+            <a:off x="12268200" y="3086100"/>
+            <a:ext cx="2247900" cy="2266950"/>
+          </a:xfrm>
+          <a:prstGeom xmlns:a="http://schemas.openxmlformats.org/drawingml/2006/main" prst="roundRect">
+            <a:avLst>
+              <a:gd name="adj" fmla="val 5085"/>
+            </a:avLst>
+          </a:prstGeom>
+          <a:solidFill xmlns:a="http://schemas.openxmlformats.org/drawingml/2006/main">
+            <a:srgbClr val="FFFFFF"/>
+          </a:solidFill>
+          <a:ln xmlns:a="http://schemas.openxmlformats.org/drawingml/2006/main" w="19050">
+            <a:solidFill>
+              <a:srgbClr val="F07D00"/>
+            </a:solidFill>
+            <a:prstDash val="solid"/>
+          </a:ln>
+        </p:spPr>
+      </p:sp>
+      <p:sp>
+        <p:nvSpPr>
+          <p:cNvPr id="20" name="">
+            <a:extLst xmlns:a="http://schemas.openxmlformats.org/drawingml/2006/main">
+              <a:ext uri="{FF2B5EF4-FFF2-40B4-BE49-F238E27FC236}">
+                <a16:creationId xmlns:a16="http://schemas.microsoft.com/office/drawing/2014/main" id="{51764D39-05B0-4F08-BC2B-2221BE2F38D6}"/>
+              </a:ext>
+            </a:extLst>
+          </p:cNvPr>
+          <p:cNvSpPr>
+            <a:spLocks xmlns:a="http://schemas.openxmlformats.org/drawingml/2006/main" noGrp="1"/>
+          </p:cNvSpPr>
+          <p:nvPr/>
+        </p:nvSpPr>
+        <p:spPr>
+          <a:xfrm xmlns:a="http://schemas.openxmlformats.org/drawingml/2006/main">
+            <a:off x="12458700" y="3295650"/>
+            <a:ext cx="514350" cy="285750"/>
+          </a:xfrm>
+          <a:prstGeom xmlns:a="http://schemas.openxmlformats.org/drawingml/2006/main" prst="rect">
+            <a:avLst/>
+          </a:prstGeom>
+          <a:noFill xmlns:a="http://schemas.openxmlformats.org/drawingml/2006/main"/>
+          <a:ln xmlns:a="http://schemas.openxmlformats.org/drawingml/2006/main" w="0">
+            <a:noFill/>
+            <a:prstDash val="solid"/>
+          </a:ln>
+        </p:spPr>
+        <p:txBody>
+          <a:bodyPr xmlns:a="http://schemas.openxmlformats.org/drawingml/2006/main" wrap="square" lIns="0" tIns="0" rIns="0" bIns="0" anchor="ctr">
+            <a:noAutofit/>
+          </a:bodyPr>
+          <a:lstStyle xmlns:a="http://schemas.openxmlformats.org/drawingml/2006/main"/>
+          <a:p xmlns:a="http://schemas.openxmlformats.org/drawingml/2006/main">
+            <a:pPr algn="l">
+              <a:lnSpc>
+                <a:spcPct val="100000"/>
+              </a:lnSpc>
+              <a:buNone/>
+              <a:defRPr sz="1350" b="1">
+                <a:solidFill>
+                  <a:srgbClr val="00A2EB"/>
+                </a:solidFill>
+                <a:latin typeface="Calibri"/>
+                <a:ea typeface="Calibri"/>
+                <a:cs typeface="Calibri"/>
+              </a:defRPr>
+            </a:pPr>
+            <a:r>
+              <a:rPr sz="1800" b="1">
+                <a:solidFill>
+                  <a:srgbClr val="00A2EB"/>
+                </a:solidFill>
+                <a:latin typeface="Calibri"/>
+                <a:ea typeface="Calibri"/>
+                <a:cs typeface="Calibri"/>
+              </a:rPr>
+              <a:t>05</a:t>
+            </a:r>
+          </a:p>
+        </p:txBody>
+      </p:sp>
+      <p:sp>
+        <p:nvSpPr>
+          <p:cNvPr id="21" name="">
+            <a:extLst xmlns:a="http://schemas.openxmlformats.org/drawingml/2006/main">
+              <a:ext uri="{FF2B5EF4-FFF2-40B4-BE49-F238E27FC236}">
+                <a16:creationId xmlns:a16="http://schemas.microsoft.com/office/drawing/2014/main" id="{C0F4CBB5-9FF7-4C7B-8D8C-5AA3541DD5E4}"/>
+              </a:ext>
+            </a:extLst>
+          </p:cNvPr>
+          <p:cNvSpPr>
+            <a:spLocks xmlns:a="http://schemas.openxmlformats.org/drawingml/2006/main" noGrp="1"/>
+          </p:cNvSpPr>
+          <p:nvPr/>
+        </p:nvSpPr>
+        <p:spPr>
+          <a:xfrm xmlns:a="http://schemas.openxmlformats.org/drawingml/2006/main">
+            <a:off x="12382500" y="3752850"/>
+            <a:ext cx="2019300" cy="685800"/>
+          </a:xfrm>
+          <a:prstGeom xmlns:a="http://schemas.openxmlformats.org/drawingml/2006/main" prst="rect">
+            <a:avLst/>
+          </a:prstGeom>
+          <a:noFill xmlns:a="http://schemas.openxmlformats.org/drawingml/2006/main"/>
+          <a:ln xmlns:a="http://schemas.openxmlformats.org/drawingml/2006/main" w="0">
+            <a:noFill/>
+            <a:prstDash val="solid"/>
+          </a:ln>
+        </p:spPr>
+        <p:txBody>
+          <a:bodyPr xmlns:a="http://schemas.openxmlformats.org/drawingml/2006/main" wrap="square" lIns="0" tIns="0" rIns="0" bIns="0" anchor="ctr">
+            <a:normAutofit fontScale="100000"/>
+          </a:bodyPr>
+          <a:lstStyle xmlns:a="http://schemas.openxmlformats.org/drawingml/2006/main"/>
+          <a:p xmlns:a="http://schemas.openxmlformats.org/drawingml/2006/main">
+            <a:pPr algn="l">
+              <a:lnSpc>
+                <a:spcPct val="100000"/>
+              </a:lnSpc>
+              <a:buNone/>
+              <a:defRPr sz="1950" b="1">
+                <a:solidFill>
+                  <a:srgbClr val="051C2A"/>
+                </a:solidFill>
+                <a:latin typeface="Calibri"/>
+                <a:ea typeface="Calibri"/>
+                <a:cs typeface="Calibri"/>
+              </a:defRPr>
+            </a:pPr>
+            <a:r>
+              <a:rPr sz="1950" b="1">
+                <a:solidFill>
+                  <a:srgbClr val="051C2A"/>
+                </a:solidFill>
+                <a:latin typeface="Calibri"/>
+                <a:ea typeface="Calibri"/>
+                <a:cs typeface="Calibri"/>
+              </a:rPr>
+              <a:t>pgvector / HNSW</a:t>
+            </a:r>
+          </a:p>
+        </p:txBody>
+      </p:sp>
+      <p:sp>
+        <p:nvSpPr>
+          <p:cNvPr id="22" name="">
+            <a:extLst xmlns:a="http://schemas.openxmlformats.org/drawingml/2006/main">
+              <a:ext uri="{FF2B5EF4-FFF2-40B4-BE49-F238E27FC236}">
+                <a16:creationId xmlns:a16="http://schemas.microsoft.com/office/drawing/2014/main" id="{8856B515-B8BF-4B9C-8D6B-EC909D2B3B4E}"/>
+              </a:ext>
+            </a:extLst>
+          </p:cNvPr>
+          <p:cNvSpPr>
+            <a:spLocks xmlns:a="http://schemas.openxmlformats.org/drawingml/2006/main" noGrp="1"/>
+          </p:cNvSpPr>
+          <p:nvPr/>
+        </p:nvSpPr>
+        <p:spPr>
+          <a:xfrm xmlns:a="http://schemas.openxmlformats.org/drawingml/2006/main">
+            <a:off x="12458700" y="4610100"/>
+            <a:ext cx="1866900" cy="514350"/>
+          </a:xfrm>
+          <a:prstGeom xmlns:a="http://schemas.openxmlformats.org/drawingml/2006/main" prst="rect">
+            <a:avLst/>
+          </a:prstGeom>
+          <a:noFill xmlns:a="http://schemas.openxmlformats.org/drawingml/2006/main"/>
+          <a:ln xmlns:a="http://schemas.openxmlformats.org/drawingml/2006/main" w="0">
+            <a:noFill/>
+            <a:prstDash val="solid"/>
+          </a:ln>
+        </p:spPr>
+        <p:txBody>
+          <a:bodyPr xmlns:a="http://schemas.openxmlformats.org/drawingml/2006/main" wrap="square" lIns="0" tIns="0" rIns="0" bIns="0" anchor="ctr">
+            <a:normAutofit fontScale="100000"/>
+          </a:bodyPr>
+          <a:lstStyle xmlns:a="http://schemas.openxmlformats.org/drawingml/2006/main"/>
+          <a:p xmlns:a="http://schemas.openxmlformats.org/drawingml/2006/main">
+            <a:pPr algn="l">
+              <a:lnSpc>
+                <a:spcPct val="100000"/>
+              </a:lnSpc>
+              <a:buNone/>
+              <a:defRPr sz="1200" b="0">
+                <a:solidFill>
+                  <a:srgbClr val="1F40CB"/>
+                </a:solidFill>
+                <a:latin typeface="Calibri"/>
+                <a:ea typeface="Calibri"/>
+                <a:cs typeface="Calibri"/>
+              </a:defRPr>
+            </a:pPr>
+            <a:r>
+              <a:rPr sz="1200" b="0">
+                <a:solidFill>
+                  <a:srgbClr val="1F40CB"/>
+                </a:solidFill>
+                <a:latin typeface="Calibri"/>
+                <a:ea typeface="Calibri"/>
+                <a:cs typeface="Calibri"/>
+              </a:rPr>
+              <a:t>persistent · approximate search</a:t>
+            </a:r>
+          </a:p>
+        </p:txBody>
+      </p:sp>
+      <p:cxnSp>
+        <p:nvCxnSpPr>
+          <p:cNvPr id="317" name=""/>
+          <p:cNvCxnSpPr>
+            <a:stCxn xmlns:a="http://schemas.openxmlformats.org/drawingml/2006/main" id="3" idx="3"/>
+            <a:endCxn xmlns:a="http://schemas.openxmlformats.org/drawingml/2006/main" id="7" idx="1"/>
+          </p:cNvCxnSpPr>
+          <p:nvPr/>
+        </p:nvCxnSpPr>
+        <p:spPr>
+          <a:xfrm xmlns:a="http://schemas.openxmlformats.org/drawingml/2006/main">
+            <a:off x="3238500" y="4219575"/>
+            <a:ext cx="571500" cy="0"/>
+          </a:xfrm>
+          <a:prstGeom xmlns:a="http://schemas.openxmlformats.org/drawingml/2006/main" prst="straightConnector1">
+            <a:avLst/>
+          </a:prstGeom>
+          <a:ln xmlns:a="http://schemas.openxmlformats.org/drawingml/2006/main" w="28575">
+            <a:solidFill>
+              <a:srgbClr val="9A9A9F"/>
+            </a:solidFill>
+            <a:prstDash val="solid"/>
+            <a:tailEnd type="triangle" w="med" len="med"/>
+          </a:ln>
+        </p:spPr>
+      </p:cxnSp>
+      <p:cxnSp>
+        <p:nvCxnSpPr>
+          <p:cNvPr id="318" name=""/>
+          <p:cNvCxnSpPr>
+            <a:stCxn xmlns:a="http://schemas.openxmlformats.org/drawingml/2006/main" id="7" idx="3"/>
+            <a:endCxn xmlns:a="http://schemas.openxmlformats.org/drawingml/2006/main" id="11" idx="1"/>
+          </p:cNvCxnSpPr>
+          <p:nvPr/>
+        </p:nvCxnSpPr>
+        <p:spPr>
+          <a:xfrm xmlns:a="http://schemas.openxmlformats.org/drawingml/2006/main">
+            <a:off x="6057900" y="4219575"/>
+            <a:ext cx="571500" cy="0"/>
+          </a:xfrm>
+          <a:prstGeom xmlns:a="http://schemas.openxmlformats.org/drawingml/2006/main" prst="straightConnector1">
+            <a:avLst/>
+          </a:prstGeom>
+          <a:ln xmlns:a="http://schemas.openxmlformats.org/drawingml/2006/main" w="28575">
+            <a:solidFill>
+              <a:srgbClr val="9A9A9F"/>
+            </a:solidFill>
+            <a:prstDash val="solid"/>
+            <a:tailEnd type="triangle" w="med" len="med"/>
+          </a:ln>
+        </p:spPr>
+      </p:cxnSp>
+      <p:cxnSp>
+        <p:nvCxnSpPr>
+          <p:cNvPr id="319" name=""/>
+          <p:cNvCxnSpPr>
+            <a:stCxn xmlns:a="http://schemas.openxmlformats.org/drawingml/2006/main" id="11" idx="3"/>
+            <a:endCxn xmlns:a="http://schemas.openxmlformats.org/drawingml/2006/main" id="15" idx="1"/>
+          </p:cNvCxnSpPr>
+          <p:nvPr/>
+        </p:nvCxnSpPr>
+        <p:spPr>
+          <a:xfrm xmlns:a="http://schemas.openxmlformats.org/drawingml/2006/main">
+            <a:off x="8877300" y="4219575"/>
+            <a:ext cx="571500" cy="0"/>
+          </a:xfrm>
+          <a:prstGeom xmlns:a="http://schemas.openxmlformats.org/drawingml/2006/main" prst="straightConnector1">
+            <a:avLst/>
+          </a:prstGeom>
+          <a:ln xmlns:a="http://schemas.openxmlformats.org/drawingml/2006/main" w="28575">
+            <a:solidFill>
+              <a:srgbClr val="9A9A9F"/>
+            </a:solidFill>
+            <a:prstDash val="solid"/>
+            <a:tailEnd type="triangle" w="med" len="med"/>
+          </a:ln>
+        </p:spPr>
+      </p:cxnSp>
+      <p:cxnSp>
+        <p:nvCxnSpPr>
+          <p:cNvPr id="320" name=""/>
+          <p:cNvCxnSpPr>
+            <a:stCxn xmlns:a="http://schemas.openxmlformats.org/drawingml/2006/main" id="15" idx="3"/>
+            <a:endCxn xmlns:a="http://schemas.openxmlformats.org/drawingml/2006/main" id="19" idx="1"/>
+          </p:cNvCxnSpPr>
+          <p:nvPr/>
+        </p:nvCxnSpPr>
+        <p:spPr>
+          <a:xfrm xmlns:a="http://schemas.openxmlformats.org/drawingml/2006/main">
+            <a:off x="11696700" y="4219575"/>
+            <a:ext cx="571500" cy="0"/>
+          </a:xfrm>
+          <a:prstGeom xmlns:a="http://schemas.openxmlformats.org/drawingml/2006/main" prst="straightConnector1">
+            <a:avLst/>
+          </a:prstGeom>
+          <a:ln xmlns:a="http://schemas.openxmlformats.org/drawingml/2006/main" w="28575">
+            <a:solidFill>
+              <a:srgbClr val="9A9A9F"/>
+            </a:solidFill>
+            <a:prstDash val="solid"/>
+            <a:tailEnd type="triangle" w="med" len="med"/>
+          </a:ln>
+        </p:spPr>
+      </p:cxnSp>
+      <p:sp>
+        <p:nvSpPr>
+          <p:cNvPr id="27" name="">
+            <a:extLst xmlns:a="http://schemas.openxmlformats.org/drawingml/2006/main">
+              <a:ext uri="{FF2B5EF4-FFF2-40B4-BE49-F238E27FC236}">
+                <a16:creationId xmlns:a16="http://schemas.microsoft.com/office/drawing/2014/main" id="{79128475-820B-447C-A724-7D8A31328FFE}"/>
+              </a:ext>
+            </a:extLst>
+          </p:cNvPr>
+          <p:cNvSpPr>
+            <a:spLocks xmlns:a="http://schemas.openxmlformats.org/drawingml/2006/main" noGrp="1"/>
+          </p:cNvSpPr>
+          <p:nvPr/>
+        </p:nvSpPr>
+        <p:spPr>
+          <a:xfrm xmlns:a="http://schemas.openxmlformats.org/drawingml/2006/main">
+            <a:off x="2381250" y="6210300"/>
+            <a:ext cx="10477500" cy="457200"/>
+          </a:xfrm>
+          <a:prstGeom xmlns:a="http://schemas.openxmlformats.org/drawingml/2006/main" prst="rect">
+            <a:avLst/>
+          </a:prstGeom>
+          <a:noFill xmlns:a="http://schemas.openxmlformats.org/drawingml/2006/main"/>
+          <a:ln xmlns:a="http://schemas.openxmlformats.org/drawingml/2006/main" w="0">
+            <a:noFill/>
+            <a:prstDash val="solid"/>
+          </a:ln>
+        </p:spPr>
+        <p:txBody>
+          <a:bodyPr xmlns:a="http://schemas.openxmlformats.org/drawingml/2006/main" wrap="square" lIns="0" tIns="0" rIns="0" bIns="0" anchor="ctr">
+            <a:normAutofit fontScale="100000"/>
+          </a:bodyPr>
+          <a:lstStyle xmlns:a="http://schemas.openxmlformats.org/drawingml/2006/main"/>
+          <a:p xmlns:a="http://schemas.openxmlformats.org/drawingml/2006/main">
+            <a:pPr algn="ctr">
+              <a:lnSpc>
+                <a:spcPct val="100000"/>
+              </a:lnSpc>
+              <a:buNone/>
+              <a:defRPr sz="2100" b="1">
+                <a:solidFill>
+                  <a:srgbClr val="051C2A"/>
+                </a:solidFill>
+                <a:latin typeface="Calibri"/>
+                <a:ea typeface="Calibri"/>
+                <a:cs typeface="Calibri"/>
+              </a:defRPr>
+            </a:pPr>
+            <a:r>
+              <a:rPr sz="2100" b="1">
+                <a:solidFill>
+                  <a:srgbClr val="051C2A"/>
+                </a:solidFill>
+                <a:latin typeface="Calibri"/>
+                <a:ea typeface="Calibri"/>
+                <a:cs typeface="Calibri"/>
+              </a:rPr>
+              <a:t>IDs, filters and evaluation contracts stay unchanged.</a:t>
+            </a:r>
+          </a:p>
+        </p:txBody>
+      </p:sp>
+      <p:sp>
+        <p:nvSpPr>
+          <p:cNvPr id="28" name="">
+            <a:extLst xmlns:a="http://schemas.openxmlformats.org/drawingml/2006/main">
+              <a:ext uri="{FF2B5EF4-FFF2-40B4-BE49-F238E27FC236}">
+                <a16:creationId xmlns:a16="http://schemas.microsoft.com/office/drawing/2014/main" id="{685F2AAD-81FC-436A-88F7-89F49C9F1671}"/>
+              </a:ext>
+            </a:extLst>
+          </p:cNvPr>
+          <p:cNvSpPr>
+            <a:spLocks xmlns:a="http://schemas.openxmlformats.org/drawingml/2006/main" noGrp="1"/>
+          </p:cNvSpPr>
+          <p:nvPr/>
+        </p:nvSpPr>
+        <p:spPr>
+          <a:xfrm xmlns:a="http://schemas.openxmlformats.org/drawingml/2006/main">
+            <a:off x="1885950" y="6838950"/>
+            <a:ext cx="4476750" cy="323850"/>
+          </a:xfrm>
+          <a:prstGeom xmlns:a="http://schemas.openxmlformats.org/drawingml/2006/main" prst="rect">
+            <a:avLst/>
+          </a:prstGeom>
+          <a:noFill xmlns:a="http://schemas.openxmlformats.org/drawingml/2006/main"/>
+          <a:ln xmlns:a="http://schemas.openxmlformats.org/drawingml/2006/main" w="0">
+            <a:noFill/>
+            <a:prstDash val="solid"/>
+          </a:ln>
+        </p:spPr>
+        <p:txBody>
+          <a:bodyPr xmlns:a="http://schemas.openxmlformats.org/drawingml/2006/main" wrap="square" lIns="0" tIns="0" rIns="0" bIns="0" anchor="ctr">
+            <a:normAutofit fontScale="100000"/>
+          </a:bodyPr>
+          <a:lstStyle xmlns:a="http://schemas.openxmlformats.org/drawingml/2006/main"/>
+          <a:p xmlns:a="http://schemas.openxmlformats.org/drawingml/2006/main">
+            <a:pPr algn="ctr">
+              <a:lnSpc>
+                <a:spcPct val="100000"/>
+              </a:lnSpc>
+              <a:buNone/>
+              <a:defRPr sz="1500" b="0">
+                <a:solidFill>
+                  <a:srgbClr val="64748B"/>
+                </a:solidFill>
+                <a:latin typeface="Calibri"/>
+                <a:ea typeface="Calibri"/>
+                <a:cs typeface="Calibri"/>
+              </a:defRPr>
+            </a:pPr>
+            <a:r>
+              <a:rPr sz="1500" b="0">
+                <a:solidFill>
+                  <a:srgbClr val="64748B"/>
+                </a:solidFill>
+                <a:latin typeface="Calibri"/>
+                <a:ea typeface="Calibri"/>
+                <a:cs typeface="Calibri"/>
+              </a:rPr>
+              <a:t>prototype · simple + inspectable</a:t>
+            </a:r>
+          </a:p>
+        </p:txBody>
+      </p:sp>
+      <p:sp>
+        <p:nvSpPr>
+          <p:cNvPr id="29" name="">
+            <a:extLst xmlns:a="http://schemas.openxmlformats.org/drawingml/2006/main">
+              <a:ext uri="{FF2B5EF4-FFF2-40B4-BE49-F238E27FC236}">
+                <a16:creationId xmlns:a16="http://schemas.microsoft.com/office/drawing/2014/main" id="{CDE04AD7-6CBE-4792-B549-765578FB3E1E}"/>
+              </a:ext>
+            </a:extLst>
+          </p:cNvPr>
+          <p:cNvSpPr>
+            <a:spLocks xmlns:a="http://schemas.openxmlformats.org/drawingml/2006/main" noGrp="1"/>
+          </p:cNvSpPr>
+          <p:nvPr/>
+        </p:nvSpPr>
+        <p:spPr>
+          <a:xfrm xmlns:a="http://schemas.openxmlformats.org/drawingml/2006/main">
+            <a:off x="8801100" y="6838950"/>
+            <a:ext cx="4762500" cy="323850"/>
+          </a:xfrm>
+          <a:prstGeom xmlns:a="http://schemas.openxmlformats.org/drawingml/2006/main" prst="rect">
+            <a:avLst/>
+          </a:prstGeom>
+          <a:noFill xmlns:a="http://schemas.openxmlformats.org/drawingml/2006/main"/>
+          <a:ln xmlns:a="http://schemas.openxmlformats.org/drawingml/2006/main" w="0">
+            <a:noFill/>
+            <a:prstDash val="solid"/>
+          </a:ln>
+        </p:spPr>
+        <p:txBody>
+          <a:bodyPr xmlns:a="http://schemas.openxmlformats.org/drawingml/2006/main" wrap="square" lIns="0" tIns="0" rIns="0" bIns="0" anchor="ctr">
+            <a:normAutofit fontScale="100000"/>
+          </a:bodyPr>
+          <a:lstStyle xmlns:a="http://schemas.openxmlformats.org/drawingml/2006/main"/>
+          <a:p xmlns:a="http://schemas.openxmlformats.org/drawingml/2006/main">
+            <a:pPr algn="ctr">
+              <a:lnSpc>
+                <a:spcPct val="100000"/>
+              </a:lnSpc>
+              <a:buNone/>
+              <a:defRPr sz="1500" b="0">
+                <a:solidFill>
+                  <a:srgbClr val="64748B"/>
+                </a:solidFill>
+                <a:latin typeface="Calibri"/>
+                <a:ea typeface="Calibri"/>
+                <a:cs typeface="Calibri"/>
+              </a:defRPr>
+            </a:pPr>
+            <a:r>
+              <a:rPr sz="1500" b="0">
+                <a:solidFill>
+                  <a:srgbClr val="64748B"/>
+                </a:solidFill>
+                <a:latin typeface="Calibri"/>
+                <a:ea typeface="Calibri"/>
+                <a:cs typeface="Calibri"/>
+              </a:rPr>
+              <a:t>production · persistence + scale</a:t>
+            </a:r>
+          </a:p>
+        </p:txBody>
+      </p:sp>
+      <p:sp>
+        <p:nvSpPr>
+          <p:cNvPr id="30" name="">
+            <a:extLst xmlns:a="http://schemas.openxmlformats.org/drawingml/2006/main">
+              <a:ext uri="{FF2B5EF4-FFF2-40B4-BE49-F238E27FC236}">
+                <a16:creationId xmlns:a16="http://schemas.microsoft.com/office/drawing/2014/main" id="{28CBA7AE-993C-4F84-A696-8D1323AC4E80}"/>
+              </a:ext>
+            </a:extLst>
+          </p:cNvPr>
+          <p:cNvSpPr>
+            <a:spLocks xmlns:a="http://schemas.openxmlformats.org/drawingml/2006/main" noGrp="1"/>
+          </p:cNvSpPr>
+          <p:nvPr/>
+        </p:nvSpPr>
+        <p:spPr>
+          <a:xfrm xmlns:a="http://schemas.openxmlformats.org/drawingml/2006/main">
+            <a:off x="857250" y="7896225"/>
+            <a:ext cx="13525500" cy="28575"/>
+          </a:xfrm>
+          <a:prstGeom xmlns:a="http://schemas.openxmlformats.org/drawingml/2006/main" prst="rect">
+            <a:avLst/>
+          </a:prstGeom>
+          <a:solidFill xmlns:a="http://schemas.openxmlformats.org/drawingml/2006/main">
+            <a:srgbClr val="E4E7E9"/>
+          </a:solidFill>
+          <a:ln xmlns:a="http://schemas.openxmlformats.org/drawingml/2006/main" w="0">
+            <a:solidFill>
+              <a:srgbClr val="E4E7E9"/>
+            </a:solidFill>
+            <a:prstDash val="solid"/>
+          </a:ln>
+        </p:spPr>
+      </p:sp>
+      <p:sp>
+        <p:nvSpPr>
+          <p:cNvPr id="31" name="">
+            <a:extLst xmlns:a="http://schemas.openxmlformats.org/drawingml/2006/main">
+              <a:ext uri="{FF2B5EF4-FFF2-40B4-BE49-F238E27FC236}">
+                <a16:creationId xmlns:a16="http://schemas.microsoft.com/office/drawing/2014/main" id="{DE97BF4D-EDBC-4480-A82B-512A72221950}"/>
+              </a:ext>
+            </a:extLst>
+          </p:cNvPr>
+          <p:cNvSpPr>
+            <a:spLocks xmlns:a="http://schemas.openxmlformats.org/drawingml/2006/main" noGrp="1"/>
+          </p:cNvSpPr>
+          <p:nvPr/>
+        </p:nvSpPr>
+        <p:spPr>
+          <a:xfrm xmlns:a="http://schemas.openxmlformats.org/drawingml/2006/main">
+            <a:off x="857250" y="7896225"/>
+            <a:ext cx="8001000" cy="38100"/>
+          </a:xfrm>
+          <a:prstGeom xmlns:a="http://schemas.openxmlformats.org/drawingml/2006/main" prst="rect">
+            <a:avLst/>
+          </a:prstGeom>
+          <a:solidFill xmlns:a="http://schemas.openxmlformats.org/drawingml/2006/main">
+            <a:srgbClr val="00A2EB"/>
+          </a:solidFill>
+          <a:ln xmlns:a="http://schemas.openxmlformats.org/drawingml/2006/main" w="0">
+            <a:solidFill>
+              <a:srgbClr val="00A2EB"/>
+            </a:solidFill>
+            <a:prstDash val="solid"/>
+          </a:ln>
+        </p:spPr>
+      </p:sp>
+      <p:sp>
+        <p:nvSpPr>
+          <p:cNvPr id="32" name="">
+            <a:extLst xmlns:a="http://schemas.openxmlformats.org/drawingml/2006/main">
+              <a:ext uri="{FF2B5EF4-FFF2-40B4-BE49-F238E27FC236}">
+                <a16:creationId xmlns:a16="http://schemas.microsoft.com/office/drawing/2014/main" id="{49281B64-2F0F-4357-A085-C65451F28236}"/>
+              </a:ext>
+            </a:extLst>
+          </p:cNvPr>
+          <p:cNvSpPr>
+            <a:spLocks xmlns:a="http://schemas.openxmlformats.org/drawingml/2006/main" noGrp="1"/>
+          </p:cNvSpPr>
+          <p:nvPr/>
+        </p:nvSpPr>
+        <p:spPr>
+          <a:xfrm xmlns:a="http://schemas.openxmlformats.org/drawingml/2006/main">
+            <a:off x="971550" y="8058150"/>
+            <a:ext cx="3714750" cy="323850"/>
+          </a:xfrm>
+          <a:prstGeom xmlns:a="http://schemas.openxmlformats.org/drawingml/2006/main" prst="rect">
+            <a:avLst/>
+          </a:prstGeom>
+          <a:noFill xmlns:a="http://schemas.openxmlformats.org/drawingml/2006/main"/>
+          <a:ln xmlns:a="http://schemas.openxmlformats.org/drawingml/2006/main" w="0">
+            <a:noFill/>
+            <a:prstDash val="solid"/>
+          </a:ln>
+        </p:spPr>
+        <p:txBody>
+          <a:bodyPr xmlns:a="http://schemas.openxmlformats.org/drawingml/2006/main" wrap="square" lIns="0" tIns="0" rIns="0" bIns="0" anchor="ctr">
+            <a:normAutofit fontScale="100000"/>
+          </a:bodyPr>
+          <a:lstStyle xmlns:a="http://schemas.openxmlformats.org/drawingml/2006/main"/>
+          <a:p xmlns:a="http://schemas.openxmlformats.org/drawingml/2006/main">
+            <a:pPr algn="l">
+              <a:lnSpc>
+                <a:spcPct val="100000"/>
+              </a:lnSpc>
+              <a:buNone/>
+              <a:defRPr sz="1200" b="0">
+                <a:solidFill>
+                  <a:srgbClr val="9A9A9F"/>
+                </a:solidFill>
+                <a:latin typeface="Calibri"/>
+                <a:ea typeface="Calibri"/>
+                <a:cs typeface="Calibri"/>
+              </a:defRPr>
+            </a:pPr>
+            <a:r>
+              <a:rPr sz="1200" b="0">
+                <a:solidFill>
+                  <a:srgbClr val="9A9A9F"/>
+                </a:solidFill>
+                <a:latin typeface="Calibri"/>
+                <a:ea typeface="Calibri"/>
+                <a:cs typeface="Calibri"/>
+              </a:rPr>
+              <a:t>First Finance - Arnaud Demes</a:t>
+            </a:r>
+          </a:p>
+        </p:txBody>
+      </p:sp>
+      <p:sp>
+        <p:nvSpPr>
+          <p:cNvPr id="33" name="">
+            <a:extLst xmlns:a="http://schemas.openxmlformats.org/drawingml/2006/main">
+              <a:ext uri="{FF2B5EF4-FFF2-40B4-BE49-F238E27FC236}">
+                <a16:creationId xmlns:a16="http://schemas.microsoft.com/office/drawing/2014/main" id="{EAA325A4-7EC6-42CE-A13A-4B38A32DE7F2}"/>
+              </a:ext>
+            </a:extLst>
+          </p:cNvPr>
+          <p:cNvSpPr>
+            <a:spLocks xmlns:a="http://schemas.openxmlformats.org/drawingml/2006/main" noGrp="1"/>
+          </p:cNvSpPr>
+          <p:nvPr/>
+        </p:nvSpPr>
+        <p:spPr>
+          <a:xfrm xmlns:a="http://schemas.openxmlformats.org/drawingml/2006/main">
+            <a:off x="12192000" y="8058150"/>
+            <a:ext cx="1809750" cy="323850"/>
+          </a:xfrm>
+          <a:prstGeom xmlns:a="http://schemas.openxmlformats.org/drawingml/2006/main" prst="rect">
+            <a:avLst/>
+          </a:prstGeom>
+          <a:noFill xmlns:a="http://schemas.openxmlformats.org/drawingml/2006/main"/>
+          <a:ln xmlns:a="http://schemas.openxmlformats.org/drawingml/2006/main" w="0">
+            <a:noFill/>
+            <a:prstDash val="solid"/>
+          </a:ln>
+        </p:spPr>
+        <p:txBody>
+          <a:bodyPr xmlns:a="http://schemas.openxmlformats.org/drawingml/2006/main" wrap="square" lIns="0" tIns="0" rIns="0" bIns="0" anchor="ctr">
+            <a:normAutofit fontScale="100000"/>
+          </a:bodyPr>
+          <a:lstStyle xmlns:a="http://schemas.openxmlformats.org/drawingml/2006/main"/>
+          <a:p xmlns:a="http://schemas.openxmlformats.org/drawingml/2006/main">
+            <a:pPr algn="r">
+              <a:lnSpc>
+                <a:spcPct val="100000"/>
+              </a:lnSpc>
+              <a:buNone/>
+              <a:defRPr sz="1200" b="1">
+                <a:solidFill>
+                  <a:srgbClr val="9A9A9F"/>
+                </a:solidFill>
+                <a:latin typeface="Calibri"/>
+                <a:ea typeface="Calibri"/>
+                <a:cs typeface="Calibri"/>
+              </a:defRPr>
+            </a:pPr>
+            <a:r>
+              <a:rPr sz="1200" b="1">
+                <a:solidFill>
+                  <a:srgbClr val="9A9A9F"/>
+                </a:solidFill>
+                <a:latin typeface="Calibri"/>
+                <a:ea typeface="Calibri"/>
+                <a:cs typeface="Calibri"/>
+              </a:rPr>
+              <a:t>STORAGE</a:t>
+            </a:r>
+          </a:p>
+        </p:txBody>
+      </p:sp>
+      <p:sp>
+        <p:nvSpPr>
+          <p:cNvPr id="34" name="">
+            <a:extLst xmlns:a="http://schemas.openxmlformats.org/drawingml/2006/main">
+              <a:ext uri="{FF2B5EF4-FFF2-40B4-BE49-F238E27FC236}">
+                <a16:creationId xmlns:a16="http://schemas.microsoft.com/office/drawing/2014/main" id="{5F7FB65A-4A0D-4595-92F4-FD9B71638842}"/>
+              </a:ext>
+            </a:extLst>
+          </p:cNvPr>
+          <p:cNvSpPr>
+            <a:spLocks xmlns:a="http://schemas.openxmlformats.org/drawingml/2006/main" noGrp="1"/>
+          </p:cNvSpPr>
+          <p:nvPr/>
+        </p:nvSpPr>
+        <p:spPr>
+          <a:xfrm xmlns:a="http://schemas.openxmlformats.org/drawingml/2006/main">
+            <a:off x="14135100" y="8058150"/>
+            <a:ext cx="266700" cy="323850"/>
+          </a:xfrm>
+          <a:prstGeom xmlns:a="http://schemas.openxmlformats.org/drawingml/2006/main" prst="rect">
+            <a:avLst/>
+          </a:prstGeom>
+          <a:noFill xmlns:a="http://schemas.openxmlformats.org/drawingml/2006/main"/>
+          <a:ln xmlns:a="http://schemas.openxmlformats.org/drawingml/2006/main" w="0">
+            <a:noFill/>
+            <a:prstDash val="solid"/>
+          </a:ln>
+        </p:spPr>
+        <p:txBody>
+          <a:bodyPr xmlns:a="http://schemas.openxmlformats.org/drawingml/2006/main" wrap="square" lIns="0" tIns="0" rIns="0" bIns="0" anchor="ctr">
+            <a:normAutofit fontScale="100000"/>
+          </a:bodyPr>
+          <a:lstStyle xmlns:a="http://schemas.openxmlformats.org/drawingml/2006/main"/>
+          <a:p xmlns:a="http://schemas.openxmlformats.org/drawingml/2006/main">
+            <a:pPr algn="r">
+              <a:lnSpc>
+                <a:spcPct val="100000"/>
+              </a:lnSpc>
+              <a:buNone/>
+              <a:defRPr sz="1200" b="1">
+                <a:solidFill>
+                  <a:srgbClr val="9A9A9F"/>
+                </a:solidFill>
+                <a:latin typeface="Calibri"/>
+                <a:ea typeface="Calibri"/>
+                <a:cs typeface="Calibri"/>
+              </a:defRPr>
+            </a:pPr>
+            <a:r>
+              <a:rPr sz="1200" b="1">
+                <a:solidFill>
+                  <a:srgbClr val="9A9A9F"/>
+                </a:solidFill>
+                <a:latin typeface="Calibri"/>
+                <a:ea typeface="Calibri"/>
+                <a:cs typeface="Calibri"/>
+              </a:rPr>
+              <a:t>08</a:t>
+            </a:r>
+          </a:p>
+        </p:txBody>
+      </p:sp>
+    </p:spTree>
+    <p:extLst>
+      <p:ext uri="{BB962C8B-B14F-4D97-AF65-F5344CB8AC3E}">
+        <p14:creationId xmlns:p14="http://schemas.microsoft.com/office/powerpoint/2010/main" val="1169510731"/>
+      </p:ext>
+    </p:extLst>
+  </p:cSld>
+</p:sld>
+</file>
+
+<file path=ppt/slides/slide9.xml><?xml version="1.0" encoding="utf-8"?>
+<p:sld xmlns:p="http://schemas.openxmlformats.org/presentationml/2006/main">
+  <p:cSld>
+    <p:bg>
+      <p:bgPr>
+        <a:solidFill xmlns:a="http://schemas.openxmlformats.org/drawingml/2006/main">
+          <a:srgbClr val="F5F5F5"/>
+        </a:solidFill>
+      </p:bgPr>
+    </p:bg>
+    <p:spTree>
+      <p:nvGrpSpPr>
+        <p:cNvPr id="1" name=""/>
+        <p:cNvGrpSpPr/>
+        <p:nvPr/>
+      </p:nvGrpSpPr>
+      <p:grpSpPr>
+        <a:xfrm xmlns:a="http://schemas.openxmlformats.org/drawingml/2006/main"/>
+      </p:grpSpPr>
+      <p:sp>
+        <p:nvSpPr>
+          <p:cNvPr id="35" name="">
+            <a:extLst xmlns:a="http://schemas.openxmlformats.org/drawingml/2006/main">
+              <a:ext uri="{FF2B5EF4-FFF2-40B4-BE49-F238E27FC236}">
+                <a16:creationId xmlns:a16="http://schemas.microsoft.com/office/drawing/2014/main" id="{45EAFBC5-0120-406B-9113-A189734D7D27}"/>
+              </a:ext>
+            </a:extLst>
+          </p:cNvPr>
+          <p:cNvSpPr>
+            <a:spLocks xmlns:a="http://schemas.openxmlformats.org/drawingml/2006/main" noGrp="1"/>
+          </p:cNvSpPr>
+          <p:nvPr/>
+        </p:nvSpPr>
+        <p:spPr>
+          <a:xfrm xmlns:a="http://schemas.openxmlformats.org/drawingml/2006/main">
+            <a:off x="971550" y="666750"/>
+            <a:ext cx="4762500" cy="342900"/>
+          </a:xfrm>
+          <a:prstGeom xmlns:a="http://schemas.openxmlformats.org/drawingml/2006/main" prst="rect">
+            <a:avLst/>
+          </a:prstGeom>
+          <a:noFill xmlns:a="http://schemas.openxmlformats.org/drawingml/2006/main"/>
+          <a:ln xmlns:a="http://schemas.openxmlformats.org/drawingml/2006/main" w="0">
+            <a:noFill/>
+            <a:prstDash val="solid"/>
+          </a:ln>
+        </p:spPr>
+        <p:txBody>
+          <a:bodyPr xmlns:a="http://schemas.openxmlformats.org/drawingml/2006/main" wrap="square" lIns="0" tIns="0" rIns="0" bIns="0" anchor="ctr">
+            <a:noAutofit/>
+          </a:bodyPr>
+          <a:lstStyle xmlns:a="http://schemas.openxmlformats.org/drawingml/2006/main"/>
+          <a:p xmlns:a="http://schemas.openxmlformats.org/drawingml/2006/main">
+            <a:pPr algn="l">
+              <a:lnSpc>
+                <a:spcPct val="100000"/>
+              </a:lnSpc>
+              <a:buNone/>
+              <a:defRPr sz="1425" b="1">
+                <a:solidFill>
+                  <a:srgbClr val="1F40CB"/>
+                </a:solidFill>
+                <a:latin typeface="Calibri"/>
+                <a:ea typeface="Calibri"/>
+                <a:cs typeface="Calibri"/>
+              </a:defRPr>
+            </a:pPr>
+            <a:r>
+              <a:rPr sz="1800" b="1">
+                <a:solidFill>
+                  <a:srgbClr val="1F40CB"/>
+                </a:solidFill>
+                <a:latin typeface="Calibri"/>
+                <a:ea typeface="Calibri"/>
+                <a:cs typeface="Calibri"/>
+              </a:rPr>
+              <a:t>MEASUREMENT HANDOFF</a:t>
+            </a:r>
+          </a:p>
+        </p:txBody>
+      </p:sp>
+      <p:sp>
+        <p:nvSpPr>
+          <p:cNvPr id="2" name="">
+            <a:extLst xmlns:a="http://schemas.openxmlformats.org/drawingml/2006/main">
+              <a:ext uri="{FF2B5EF4-FFF2-40B4-BE49-F238E27FC236}">
+                <a16:creationId xmlns:a16="http://schemas.microsoft.com/office/drawing/2014/main" id="{E788E1BA-062C-4D13-89C4-9762E55DD5F6}"/>
+              </a:ext>
+            </a:extLst>
+          </p:cNvPr>
+          <p:cNvSpPr>
+            <a:spLocks xmlns:a="http://schemas.openxmlformats.org/drawingml/2006/main" noGrp="1"/>
+          </p:cNvSpPr>
+          <p:nvPr/>
+        </p:nvSpPr>
+        <p:spPr>
+          <a:xfrm xmlns:a="http://schemas.openxmlformats.org/drawingml/2006/main">
+            <a:off x="971550" y="1181100"/>
+            <a:ext cx="13296900" cy="781050"/>
+          </a:xfrm>
+          <a:prstGeom xmlns:a="http://schemas.openxmlformats.org/drawingml/2006/main" prst="rect">
+            <a:avLst/>
+          </a:prstGeom>
+          <a:noFill xmlns:a="http://schemas.openxmlformats.org/drawingml/2006/main"/>
+          <a:ln xmlns:a="http://schemas.openxmlformats.org/drawingml/2006/main" w="0">
+            <a:noFill/>
+            <a:prstDash val="solid"/>
+          </a:ln>
+        </p:spPr>
+        <p:txBody>
+          <a:bodyPr xmlns:a="http://schemas.openxmlformats.org/drawingml/2006/main" wrap="none" lIns="0" tIns="0" rIns="0" bIns="0" anchor="ctr">
+            <a:normAutofit fontScale="100000"/>
+          </a:bodyPr>
+          <a:lstStyle xmlns:a="http://schemas.openxmlformats.org/drawingml/2006/main"/>
+          <a:p xmlns:a="http://schemas.openxmlformats.org/drawingml/2006/main">
+            <a:pPr algn="l">
+              <a:lnSpc>
+                <a:spcPct val="100000"/>
+              </a:lnSpc>
+              <a:buNone/>
+              <a:defRPr sz="3600" b="1">
+                <a:solidFill>
+                  <a:srgbClr val="051C2A"/>
+                </a:solidFill>
+                <a:latin typeface="Calibri"/>
+                <a:ea typeface="Calibri"/>
+                <a:cs typeface="Calibri"/>
+              </a:defRPr>
+            </a:pPr>
+            <a:r>
+              <a:rPr sz="3600" b="1">
+                <a:solidFill>
+                  <a:srgbClr val="051C2A"/>
+                </a:solidFill>
+                <a:latin typeface="Calibri"/>
+                <a:ea typeface="Calibri"/>
+                <a:cs typeface="Calibri"/>
+              </a:rPr>
+              <a:t>Measure each retrieval stage before adding MLflow</a:t>
+            </a:r>
+          </a:p>
+        </p:txBody>
+      </p:sp>
+      <p:sp>
+        <p:nvSpPr>
+          <p:cNvPr id="3" name="ingestion-1">
+            <a:extLst xmlns:a="http://schemas.openxmlformats.org/drawingml/2006/main">
+              <a:ext uri="{FF2B5EF4-FFF2-40B4-BE49-F238E27FC236}">
+                <a16:creationId xmlns:a16="http://schemas.microsoft.com/office/drawing/2014/main" id="{EF5CEA91-0836-4E99-95C1-43A271A11FFF}"/>
+              </a:ext>
+            </a:extLst>
+          </p:cNvPr>
+          <p:cNvSpPr>
+            <a:spLocks xmlns:a="http://schemas.openxmlformats.org/drawingml/2006/main" noGrp="1"/>
+          </p:cNvSpPr>
+          <p:nvPr/>
+        </p:nvSpPr>
+        <p:spPr>
+          <a:xfrm xmlns:a="http://schemas.openxmlformats.org/drawingml/2006/main">
+            <a:off x="990600" y="3086100"/>
+            <a:ext cx="2247900" cy="2266950"/>
+          </a:xfrm>
+          <a:prstGeom xmlns:a="http://schemas.openxmlformats.org/drawingml/2006/main" prst="roundRect">
+            <a:avLst>
+              <a:gd name="adj" fmla="val 5085"/>
+            </a:avLst>
+          </a:prstGeom>
+          <a:solidFill xmlns:a="http://schemas.openxmlformats.org/drawingml/2006/main">
+            <a:srgbClr val="FFFFFF"/>
+          </a:solidFill>
+          <a:ln xmlns:a="http://schemas.openxmlformats.org/drawingml/2006/main" w="9525">
+            <a:solidFill>
+              <a:srgbClr val="E4E7E9"/>
+            </a:solidFill>
+            <a:prstDash val="solid"/>
+          </a:ln>
+        </p:spPr>
+      </p:sp>
+      <p:sp>
+        <p:nvSpPr>
+          <p:cNvPr id="4" name="">
+            <a:extLst xmlns:a="http://schemas.openxmlformats.org/drawingml/2006/main">
+              <a:ext uri="{FF2B5EF4-FFF2-40B4-BE49-F238E27FC236}">
+                <a16:creationId xmlns:a16="http://schemas.microsoft.com/office/drawing/2014/main" id="{4A163ADC-FDBA-49AB-AB53-62FA29104479}"/>
+              </a:ext>
+            </a:extLst>
+          </p:cNvPr>
+          <p:cNvSpPr>
+            <a:spLocks xmlns:a="http://schemas.openxmlformats.org/drawingml/2006/main" noGrp="1"/>
+          </p:cNvSpPr>
+          <p:nvPr/>
+        </p:nvSpPr>
+        <p:spPr>
+          <a:xfrm xmlns:a="http://schemas.openxmlformats.org/drawingml/2006/main">
+            <a:off x="1181100" y="3295650"/>
+            <a:ext cx="514350" cy="285750"/>
+          </a:xfrm>
+          <a:prstGeom xmlns:a="http://schemas.openxmlformats.org/drawingml/2006/main" prst="rect">
+            <a:avLst/>
+          </a:prstGeom>
+          <a:noFill xmlns:a="http://schemas.openxmlformats.org/drawingml/2006/main"/>
+          <a:ln xmlns:a="http://schemas.openxmlformats.org/drawingml/2006/main" w="0">
+            <a:noFill/>
+            <a:prstDash val="solid"/>
+          </a:ln>
+        </p:spPr>
+        <p:txBody>
+          <a:bodyPr xmlns:a="http://schemas.openxmlformats.org/drawingml/2006/main" wrap="square" lIns="0" tIns="0" rIns="0" bIns="0" anchor="ctr">
+            <a:noAutofit/>
+          </a:bodyPr>
+          <a:lstStyle xmlns:a="http://schemas.openxmlformats.org/drawingml/2006/main"/>
+          <a:p xmlns:a="http://schemas.openxmlformats.org/drawingml/2006/main">
+            <a:pPr algn="l">
+              <a:lnSpc>
+                <a:spcPct val="100000"/>
+              </a:lnSpc>
+              <a:buNone/>
+              <a:defRPr sz="1350" b="1">
+                <a:solidFill>
+                  <a:srgbClr val="00A2EB"/>
+                </a:solidFill>
+                <a:latin typeface="Calibri"/>
+                <a:ea typeface="Calibri"/>
+                <a:cs typeface="Calibri"/>
+              </a:defRPr>
+            </a:pPr>
+            <a:r>
+              <a:rPr sz="1800" b="1">
+                <a:solidFill>
+                  <a:srgbClr val="00A2EB"/>
+                </a:solidFill>
+                <a:latin typeface="Calibri"/>
+                <a:ea typeface="Calibri"/>
+                <a:cs typeface="Calibri"/>
+              </a:rPr>
+              <a:t>01</a:t>
+            </a:r>
+          </a:p>
+        </p:txBody>
+      </p:sp>
+      <p:sp>
+        <p:nvSpPr>
+          <p:cNvPr id="5" name="">
+            <a:extLst xmlns:a="http://schemas.openxmlformats.org/drawingml/2006/main">
+              <a:ext uri="{FF2B5EF4-FFF2-40B4-BE49-F238E27FC236}">
+                <a16:creationId xmlns:a16="http://schemas.microsoft.com/office/drawing/2014/main" id="{26D1AD73-F995-4369-A266-8FA41354CE3D}"/>
+              </a:ext>
+            </a:extLst>
+          </p:cNvPr>
+          <p:cNvSpPr>
+            <a:spLocks xmlns:a="http://schemas.openxmlformats.org/drawingml/2006/main" noGrp="1"/>
+          </p:cNvSpPr>
+          <p:nvPr/>
+        </p:nvSpPr>
+        <p:spPr>
+          <a:xfrm xmlns:a="http://schemas.openxmlformats.org/drawingml/2006/main">
+            <a:off x="1104900" y="3752850"/>
+            <a:ext cx="2019300" cy="685800"/>
+          </a:xfrm>
+          <a:prstGeom xmlns:a="http://schemas.openxmlformats.org/drawingml/2006/main" prst="rect">
+            <a:avLst/>
+          </a:prstGeom>
+          <a:noFill xmlns:a="http://schemas.openxmlformats.org/drawingml/2006/main"/>
+          <a:ln xmlns:a="http://schemas.openxmlformats.org/drawingml/2006/main" w="0">
+            <a:noFill/>
+            <a:prstDash val="solid"/>
+          </a:ln>
+        </p:spPr>
+        <p:txBody>
+          <a:bodyPr xmlns:a="http://schemas.openxmlformats.org/drawingml/2006/main" wrap="square" lIns="0" tIns="0" rIns="0" bIns="0" anchor="ctr">
+            <a:normAutofit fontScale="100000"/>
+          </a:bodyPr>
+          <a:lstStyle xmlns:a="http://schemas.openxmlformats.org/drawingml/2006/main"/>
+          <a:p xmlns:a="http://schemas.openxmlformats.org/drawingml/2006/main">
+            <a:pPr algn="l">
+              <a:lnSpc>
+                <a:spcPct val="100000"/>
+              </a:lnSpc>
+              <a:buNone/>
+              <a:defRPr sz="1950" b="1">
+                <a:solidFill>
+                  <a:srgbClr val="051C2A"/>
+                </a:solidFill>
+                <a:latin typeface="Calibri"/>
+                <a:ea typeface="Calibri"/>
+                <a:cs typeface="Calibri"/>
+              </a:defRPr>
+            </a:pPr>
+            <a:r>
+              <a:rPr sz="1950" b="1">
+                <a:solidFill>
+                  <a:srgbClr val="051C2A"/>
+                </a:solidFill>
+                <a:latin typeface="Calibri"/>
+                <a:ea typeface="Calibri"/>
+                <a:cs typeface="Calibri"/>
+              </a:rPr>
+              <a:t>Eligibility</a:t>
+            </a:r>
+          </a:p>
+        </p:txBody>
+      </p:sp>
+      <p:sp>
+        <p:nvSpPr>
+          <p:cNvPr id="6" name="">
+            <a:extLst xmlns:a="http://schemas.openxmlformats.org/drawingml/2006/main">
+              <a:ext uri="{FF2B5EF4-FFF2-40B4-BE49-F238E27FC236}">
+                <a16:creationId xmlns:a16="http://schemas.microsoft.com/office/drawing/2014/main" id="{4CA7F72B-07B6-4BF4-A3F9-5860F8AC7245}"/>
+              </a:ext>
+            </a:extLst>
+          </p:cNvPr>
+          <p:cNvSpPr>
+            <a:spLocks xmlns:a="http://schemas.openxmlformats.org/drawingml/2006/main" noGrp="1"/>
+          </p:cNvSpPr>
+          <p:nvPr/>
+        </p:nvSpPr>
+        <p:spPr>
+          <a:xfrm xmlns:a="http://schemas.openxmlformats.org/drawingml/2006/main">
+            <a:off x="1181100" y="4610100"/>
+            <a:ext cx="1866900" cy="514350"/>
+          </a:xfrm>
+          <a:prstGeom xmlns:a="http://schemas.openxmlformats.org/drawingml/2006/main" prst="rect">
+            <a:avLst/>
+          </a:prstGeom>
+          <a:noFill xmlns:a="http://schemas.openxmlformats.org/drawingml/2006/main"/>
+          <a:ln xmlns:a="http://schemas.openxmlformats.org/drawingml/2006/main" w="0">
+            <a:noFill/>
+            <a:prstDash val="solid"/>
+          </a:ln>
+        </p:spPr>
+        <p:txBody>
+          <a:bodyPr xmlns:a="http://schemas.openxmlformats.org/drawingml/2006/main" wrap="square" lIns="0" tIns="0" rIns="0" bIns="0" anchor="ctr">
+            <a:normAutofit fontScale="100000"/>
+          </a:bodyPr>
+          <a:lstStyle xmlns:a="http://schemas.openxmlformats.org/drawingml/2006/main"/>
+          <a:p xmlns:a="http://schemas.openxmlformats.org/drawingml/2006/main">
+            <a:pPr algn="l">
+              <a:lnSpc>
+                <a:spcPct val="100000"/>
+              </a:lnSpc>
+              <a:buNone/>
+              <a:defRPr sz="1200" b="0">
+                <a:solidFill>
+                  <a:srgbClr val="1F40CB"/>
+                </a:solidFill>
+                <a:latin typeface="Calibri"/>
+                <a:ea typeface="Calibri"/>
+                <a:cs typeface="Calibri"/>
+              </a:defRPr>
+            </a:pPr>
+            <a:r>
+              <a:rPr sz="1200" b="0">
+                <a:solidFill>
+                  <a:srgbClr val="1F40CB"/>
+                </a:solidFill>
+                <a:latin typeface="Calibri"/>
+                <a:ea typeface="Calibri"/>
+                <a:cs typeface="Calibri"/>
+              </a:rPr>
+              <a:t>0.00 ms · complete</a:t>
+            </a:r>
+          </a:p>
+        </p:txBody>
+      </p:sp>
+      <p:sp>
+        <p:nvSpPr>
+          <p:cNvPr id="7" name="ingestion-2">
+            <a:extLst xmlns:a="http://schemas.openxmlformats.org/drawingml/2006/main">
+              <a:ext uri="{FF2B5EF4-FFF2-40B4-BE49-F238E27FC236}">
+                <a16:creationId xmlns:a16="http://schemas.microsoft.com/office/drawing/2014/main" id="{B39DEECB-E0D1-415A-8F2A-C8075A6D97BA}"/>
+              </a:ext>
+            </a:extLst>
+          </p:cNvPr>
+          <p:cNvSpPr>
+            <a:spLocks xmlns:a="http://schemas.openxmlformats.org/drawingml/2006/main" noGrp="1"/>
+          </p:cNvSpPr>
+          <p:nvPr/>
+        </p:nvSpPr>
+        <p:spPr>
+          <a:xfrm xmlns:a="http://schemas.openxmlformats.org/drawingml/2006/main">
+            <a:off x="3810000" y="3086100"/>
+            <a:ext cx="2247900" cy="2266950"/>
+          </a:xfrm>
+          <a:prstGeom xmlns:a="http://schemas.openxmlformats.org/drawingml/2006/main" prst="roundRect">
+            <a:avLst>
+              <a:gd name="adj" fmla="val 5085"/>
+            </a:avLst>
+          </a:prstGeom>
+          <a:solidFill xmlns:a="http://schemas.openxmlformats.org/drawingml/2006/main">
+            <a:srgbClr val="FFFFFF"/>
+          </a:solidFill>
+          <a:ln xmlns:a="http://schemas.openxmlformats.org/drawingml/2006/main" w="9525">
+            <a:solidFill>
+              <a:srgbClr val="E4E7E9"/>
+            </a:solidFill>
+            <a:prstDash val="solid"/>
+          </a:ln>
+        </p:spPr>
+      </p:sp>
+      <p:sp>
+        <p:nvSpPr>
+          <p:cNvPr id="8" name="">
+            <a:extLst xmlns:a="http://schemas.openxmlformats.org/drawingml/2006/main">
+              <a:ext uri="{FF2B5EF4-FFF2-40B4-BE49-F238E27FC236}">
+                <a16:creationId xmlns:a16="http://schemas.microsoft.com/office/drawing/2014/main" id="{18679081-8A68-4B7E-9199-340CF95714DE}"/>
+              </a:ext>
+            </a:extLst>
+          </p:cNvPr>
+          <p:cNvSpPr>
+            <a:spLocks xmlns:a="http://schemas.openxmlformats.org/drawingml/2006/main" noGrp="1"/>
+          </p:cNvSpPr>
+          <p:nvPr/>
+        </p:nvSpPr>
+        <p:spPr>
+          <a:xfrm xmlns:a="http://schemas.openxmlformats.org/drawingml/2006/main">
+            <a:off x="4000500" y="3295650"/>
+            <a:ext cx="514350" cy="285750"/>
+          </a:xfrm>
+          <a:prstGeom xmlns:a="http://schemas.openxmlformats.org/drawingml/2006/main" prst="rect">
+            <a:avLst/>
+          </a:prstGeom>
+          <a:noFill xmlns:a="http://schemas.openxmlformats.org/drawingml/2006/main"/>
+          <a:ln xmlns:a="http://schemas.openxmlformats.org/drawingml/2006/main" w="0">
+            <a:noFill/>
+            <a:prstDash val="solid"/>
+          </a:ln>
+        </p:spPr>
+        <p:txBody>
+          <a:bodyPr xmlns:a="http://schemas.openxmlformats.org/drawingml/2006/main" wrap="square" lIns="0" tIns="0" rIns="0" bIns="0" anchor="ctr">
+            <a:noAutofit/>
+          </a:bodyPr>
+          <a:lstStyle xmlns:a="http://schemas.openxmlformats.org/drawingml/2006/main"/>
+          <a:p xmlns:a="http://schemas.openxmlformats.org/drawingml/2006/main">
+            <a:pPr algn="l">
+              <a:lnSpc>
+                <a:spcPct val="100000"/>
+              </a:lnSpc>
+              <a:buNone/>
+              <a:defRPr sz="1350" b="1">
+                <a:solidFill>
+                  <a:srgbClr val="00A2EB"/>
+                </a:solidFill>
+                <a:latin typeface="Calibri"/>
+                <a:ea typeface="Calibri"/>
+                <a:cs typeface="Calibri"/>
+              </a:defRPr>
+            </a:pPr>
+            <a:r>
+              <a:rPr sz="1800" b="1">
+                <a:solidFill>
+                  <a:srgbClr val="00A2EB"/>
+                </a:solidFill>
+                <a:latin typeface="Calibri"/>
+                <a:ea typeface="Calibri"/>
+                <a:cs typeface="Calibri"/>
+              </a:rPr>
+              <a:t>02</a:t>
+            </a:r>
+          </a:p>
+        </p:txBody>
+      </p:sp>
+      <p:sp>
+        <p:nvSpPr>
+          <p:cNvPr id="9" name="">
+            <a:extLst xmlns:a="http://schemas.openxmlformats.org/drawingml/2006/main">
+              <a:ext uri="{FF2B5EF4-FFF2-40B4-BE49-F238E27FC236}">
+                <a16:creationId xmlns:a16="http://schemas.microsoft.com/office/drawing/2014/main" id="{ED095E54-44DC-4092-9EB7-0C81E4B47710}"/>
+              </a:ext>
+            </a:extLst>
+          </p:cNvPr>
+          <p:cNvSpPr>
+            <a:spLocks xmlns:a="http://schemas.openxmlformats.org/drawingml/2006/main" noGrp="1"/>
+          </p:cNvSpPr>
+          <p:nvPr/>
+        </p:nvSpPr>
+        <p:spPr>
+          <a:xfrm xmlns:a="http://schemas.openxmlformats.org/drawingml/2006/main">
+            <a:off x="3924300" y="3752850"/>
+            <a:ext cx="2019300" cy="685800"/>
+          </a:xfrm>
+          <a:prstGeom xmlns:a="http://schemas.openxmlformats.org/drawingml/2006/main" prst="rect">
+            <a:avLst/>
+          </a:prstGeom>
+          <a:noFill xmlns:a="http://schemas.openxmlformats.org/drawingml/2006/main"/>
+          <a:ln xmlns:a="http://schemas.openxmlformats.org/drawingml/2006/main" w="0">
+            <a:noFill/>
+            <a:prstDash val="solid"/>
+          </a:ln>
+        </p:spPr>
+        <p:txBody>
+          <a:bodyPr xmlns:a="http://schemas.openxmlformats.org/drawingml/2006/main" wrap="square" lIns="0" tIns="0" rIns="0" bIns="0" anchor="ctr">
+            <a:normAutofit fontScale="100000"/>
+          </a:bodyPr>
+          <a:lstStyle xmlns:a="http://schemas.openxmlformats.org/drawingml/2006/main"/>
+          <a:p xmlns:a="http://schemas.openxmlformats.org/drawingml/2006/main">
+            <a:pPr algn="l">
+              <a:lnSpc>
+                <a:spcPct val="100000"/>
+              </a:lnSpc>
+              <a:buNone/>
+              <a:defRPr sz="1950" b="1">
+                <a:solidFill>
+                  <a:srgbClr val="051C2A"/>
+                </a:solidFill>
+                <a:latin typeface="Calibri"/>
+                <a:ea typeface="Calibri"/>
+                <a:cs typeface="Calibri"/>
+              </a:defRPr>
+            </a:pPr>
+            <a:r>
+              <a:rPr sz="1950" b="1">
+                <a:solidFill>
+                  <a:srgbClr val="051C2A"/>
+                </a:solidFill>
+                <a:latin typeface="Calibri"/>
+                <a:ea typeface="Calibri"/>
+                <a:cs typeface="Calibri"/>
+              </a:rPr>
+              <a:t>Keyword</a:t>
+            </a:r>
+          </a:p>
+        </p:txBody>
+      </p:sp>
+      <p:sp>
+        <p:nvSpPr>
+          <p:cNvPr id="10" name="">
+            <a:extLst xmlns:a="http://schemas.openxmlformats.org/drawingml/2006/main">
+              <a:ext uri="{FF2B5EF4-FFF2-40B4-BE49-F238E27FC236}">
+                <a16:creationId xmlns:a16="http://schemas.microsoft.com/office/drawing/2014/main" id="{4DB65E8E-6BA9-40DB-99F9-46D3397B13A3}"/>
+              </a:ext>
+            </a:extLst>
+          </p:cNvPr>
+          <p:cNvSpPr>
+            <a:spLocks xmlns:a="http://schemas.openxmlformats.org/drawingml/2006/main" noGrp="1"/>
+          </p:cNvSpPr>
+          <p:nvPr/>
+        </p:nvSpPr>
+        <p:spPr>
+          <a:xfrm xmlns:a="http://schemas.openxmlformats.org/drawingml/2006/main">
+            <a:off x="4000500" y="4610100"/>
+            <a:ext cx="1866900" cy="514350"/>
+          </a:xfrm>
+          <a:prstGeom xmlns:a="http://schemas.openxmlformats.org/drawingml/2006/main" prst="rect">
+            <a:avLst/>
+          </a:prstGeom>
+          <a:noFill xmlns:a="http://schemas.openxmlformats.org/drawingml/2006/main"/>
+          <a:ln xmlns:a="http://schemas.openxmlformats.org/drawingml/2006/main" w="0">
+            <a:noFill/>
+            <a:prstDash val="solid"/>
+          </a:ln>
+        </p:spPr>
+        <p:txBody>
+          <a:bodyPr xmlns:a="http://schemas.openxmlformats.org/drawingml/2006/main" wrap="square" lIns="0" tIns="0" rIns="0" bIns="0" anchor="ctr">
+            <a:normAutofit fontScale="100000"/>
+          </a:bodyPr>
+          <a:lstStyle xmlns:a="http://schemas.openxmlformats.org/drawingml/2006/main"/>
+          <a:p xmlns:a="http://schemas.openxmlformats.org/drawingml/2006/main">
+            <a:pPr algn="l">
+              <a:lnSpc>
+                <a:spcPct val="100000"/>
+              </a:lnSpc>
+              <a:buNone/>
+              <a:defRPr sz="1200" b="0">
+                <a:solidFill>
+                  <a:srgbClr val="1F40CB"/>
+                </a:solidFill>
+                <a:latin typeface="Calibri"/>
+                <a:ea typeface="Calibri"/>
+                <a:cs typeface="Calibri"/>
+              </a:defRPr>
+            </a:pPr>
+            <a:r>
+              <a:rPr sz="1200" b="0">
+                <a:solidFill>
+                  <a:srgbClr val="1F40CB"/>
+                </a:solidFill>
+                <a:latin typeface="Calibri"/>
+                <a:ea typeface="Calibri"/>
+                <a:cs typeface="Calibri"/>
+              </a:rPr>
+              <a:t>1.04 ms · complete</a:t>
+            </a:r>
+          </a:p>
+        </p:txBody>
+      </p:sp>
+      <p:sp>
+        <p:nvSpPr>
+          <p:cNvPr id="11" name="ingestion-3">
+            <a:extLst xmlns:a="http://schemas.openxmlformats.org/drawingml/2006/main">
+              <a:ext uri="{FF2B5EF4-FFF2-40B4-BE49-F238E27FC236}">
+                <a16:creationId xmlns:a16="http://schemas.microsoft.com/office/drawing/2014/main" id="{D4342A97-3791-461F-A305-9671DA4948CE}"/>
+              </a:ext>
+            </a:extLst>
+          </p:cNvPr>
+          <p:cNvSpPr>
+            <a:spLocks xmlns:a="http://schemas.openxmlformats.org/drawingml/2006/main" noGrp="1"/>
+          </p:cNvSpPr>
+          <p:nvPr/>
+        </p:nvSpPr>
+        <p:spPr>
+          <a:xfrm xmlns:a="http://schemas.openxmlformats.org/drawingml/2006/main">
+            <a:off x="6629400" y="3086100"/>
+            <a:ext cx="2247900" cy="2266950"/>
+          </a:xfrm>
+          <a:prstGeom xmlns:a="http://schemas.openxmlformats.org/drawingml/2006/main" prst="roundRect">
+            <a:avLst>
+              <a:gd name="adj" fmla="val 5085"/>
+            </a:avLst>
+          </a:prstGeom>
+          <a:solidFill xmlns:a="http://schemas.openxmlformats.org/drawingml/2006/main">
+            <a:srgbClr val="062433"/>
+          </a:solidFill>
+          <a:ln xmlns:a="http://schemas.openxmlformats.org/drawingml/2006/main" w="9525">
+            <a:solidFill>
+              <a:srgbClr val="062433"/>
+            </a:solidFill>
+            <a:prstDash val="solid"/>
+          </a:ln>
+        </p:spPr>
+      </p:sp>
+      <p:sp>
+        <p:nvSpPr>
+          <p:cNvPr id="12" name="">
+            <a:extLst xmlns:a="http://schemas.openxmlformats.org/drawingml/2006/main">
+              <a:ext uri="{FF2B5EF4-FFF2-40B4-BE49-F238E27FC236}">
+                <a16:creationId xmlns:a16="http://schemas.microsoft.com/office/drawing/2014/main" id="{64E49A95-2D88-4387-8BD5-FA749ABD0960}"/>
+              </a:ext>
+            </a:extLst>
+          </p:cNvPr>
+          <p:cNvSpPr>
+            <a:spLocks xmlns:a="http://schemas.openxmlformats.org/drawingml/2006/main" noGrp="1"/>
+          </p:cNvSpPr>
+          <p:nvPr/>
+        </p:nvSpPr>
+        <p:spPr>
+          <a:xfrm xmlns:a="http://schemas.openxmlformats.org/drawingml/2006/main">
+            <a:off x="6819900" y="3295650"/>
+            <a:ext cx="514350" cy="285750"/>
+          </a:xfrm>
+          <a:prstGeom xmlns:a="http://schemas.openxmlformats.org/drawingml/2006/main" prst="rect">
+            <a:avLst/>
+          </a:prstGeom>
+          <a:noFill xmlns:a="http://schemas.openxmlformats.org/drawingml/2006/main"/>
+          <a:ln xmlns:a="http://schemas.openxmlformats.org/drawingml/2006/main" w="0">
+            <a:noFill/>
+            <a:prstDash val="solid"/>
+          </a:ln>
+        </p:spPr>
+        <p:txBody>
+          <a:bodyPr xmlns:a="http://schemas.openxmlformats.org/drawingml/2006/main" wrap="square" lIns="0" tIns="0" rIns="0" bIns="0" anchor="ctr">
+            <a:noAutofit/>
+          </a:bodyPr>
+          <a:lstStyle xmlns:a="http://schemas.openxmlformats.org/drawingml/2006/main"/>
+          <a:p xmlns:a="http://schemas.openxmlformats.org/drawingml/2006/main">
+            <a:pPr algn="l">
+              <a:lnSpc>
+                <a:spcPct val="100000"/>
+              </a:lnSpc>
+              <a:buNone/>
+              <a:defRPr sz="1350" b="1">
+                <a:solidFill>
+                  <a:srgbClr val="00A2EB"/>
+                </a:solidFill>
+                <a:latin typeface="Calibri"/>
+                <a:ea typeface="Calibri"/>
+                <a:cs typeface="Calibri"/>
+              </a:defRPr>
+            </a:pPr>
+            <a:r>
+              <a:rPr sz="1800" b="1">
+                <a:solidFill>
+                  <a:srgbClr val="00A2EB"/>
+                </a:solidFill>
+                <a:latin typeface="Calibri"/>
+                <a:ea typeface="Calibri"/>
+                <a:cs typeface="Calibri"/>
+              </a:rPr>
+              <a:t>03</a:t>
+            </a:r>
+          </a:p>
+        </p:txBody>
+      </p:sp>
+      <p:sp>
+        <p:nvSpPr>
+          <p:cNvPr id="13" name="">
+            <a:extLst xmlns:a="http://schemas.openxmlformats.org/drawingml/2006/main">
+              <a:ext uri="{FF2B5EF4-FFF2-40B4-BE49-F238E27FC236}">
+                <a16:creationId xmlns:a16="http://schemas.microsoft.com/office/drawing/2014/main" id="{572D3874-F985-4CD0-BBFF-D59F5B7B32BE}"/>
+              </a:ext>
+            </a:extLst>
+          </p:cNvPr>
+          <p:cNvSpPr>
+            <a:spLocks xmlns:a="http://schemas.openxmlformats.org/drawingml/2006/main" noGrp="1"/>
+          </p:cNvSpPr>
+          <p:nvPr/>
+        </p:nvSpPr>
+        <p:spPr>
+          <a:xfrm xmlns:a="http://schemas.openxmlformats.org/drawingml/2006/main">
+            <a:off x="6743700" y="3752850"/>
+            <a:ext cx="2019300" cy="685800"/>
+          </a:xfrm>
+          <a:prstGeom xmlns:a="http://schemas.openxmlformats.org/drawingml/2006/main" prst="rect">
+            <a:avLst/>
+          </a:prstGeom>
+          <a:noFill xmlns:a="http://schemas.openxmlformats.org/drawingml/2006/main"/>
+          <a:ln xmlns:a="http://schemas.openxmlformats.org/drawingml/2006/main" w="0">
+            <a:noFill/>
+            <a:prstDash val="solid"/>
+          </a:ln>
+        </p:spPr>
+        <p:txBody>
+          <a:bodyPr xmlns:a="http://schemas.openxmlformats.org/drawingml/2006/main" wrap="square" lIns="0" tIns="0" rIns="0" bIns="0" anchor="ctr">
+            <a:noAutofit/>
+          </a:bodyPr>
+          <a:lstStyle xmlns:a="http://schemas.openxmlformats.org/drawingml/2006/main"/>
+          <a:p xmlns:a="http://schemas.openxmlformats.org/drawingml/2006/main">
+            <a:pPr algn="l">
+              <a:lnSpc>
+                <a:spcPct val="100000"/>
+              </a:lnSpc>
+              <a:buNone/>
+              <a:defRPr sz="1650" b="1">
+                <a:solidFill>
+                  <a:srgbClr val="FFFFFF"/>
+                </a:solidFill>
+                <a:latin typeface="Calibri"/>
+                <a:ea typeface="Calibri"/>
+                <a:cs typeface="Calibri"/>
+              </a:defRPr>
+            </a:pPr>
+            <a:r>
+              <a:rPr sz="1800" b="1">
+                <a:solidFill>
+                  <a:srgbClr val="FFFFFF"/>
+                </a:solidFill>
+                <a:latin typeface="Calibri"/>
+                <a:ea typeface="Calibri"/>
+                <a:cs typeface="Calibri"/>
+              </a:rPr>
+              <a:t>Dense</a:t>
+            </a:r>
+          </a:p>
+        </p:txBody>
+      </p:sp>
+      <p:sp>
+        <p:nvSpPr>
+          <p:cNvPr id="14" name="">
+            <a:extLst xmlns:a="http://schemas.openxmlformats.org/drawingml/2006/main">
+              <a:ext uri="{FF2B5EF4-FFF2-40B4-BE49-F238E27FC236}">
+                <a16:creationId xmlns:a16="http://schemas.microsoft.com/office/drawing/2014/main" id="{9599AF29-91DE-47C0-8189-B0778BB52724}"/>
+              </a:ext>
+            </a:extLst>
+          </p:cNvPr>
+          <p:cNvSpPr>
+            <a:spLocks xmlns:a="http://schemas.openxmlformats.org/drawingml/2006/main" noGrp="1"/>
+          </p:cNvSpPr>
+          <p:nvPr/>
+        </p:nvSpPr>
+        <p:spPr>
+          <a:xfrm xmlns:a="http://schemas.openxmlformats.org/drawingml/2006/main">
+            <a:off x="6819900" y="4610100"/>
+            <a:ext cx="1866900" cy="514350"/>
+          </a:xfrm>
+          <a:prstGeom xmlns:a="http://schemas.openxmlformats.org/drawingml/2006/main" prst="rect">
+            <a:avLst/>
+          </a:prstGeom>
+          <a:noFill xmlns:a="http://schemas.openxmlformats.org/drawingml/2006/main"/>
+          <a:ln xmlns:a="http://schemas.openxmlformats.org/drawingml/2006/main" w="0">
+            <a:noFill/>
+            <a:prstDash val="solid"/>
+          </a:ln>
+        </p:spPr>
+        <p:txBody>
+          <a:bodyPr xmlns:a="http://schemas.openxmlformats.org/drawingml/2006/main" wrap="square" lIns="0" tIns="0" rIns="0" bIns="0" anchor="ctr">
+            <a:normAutofit fontScale="100000"/>
+          </a:bodyPr>
+          <a:lstStyle xmlns:a="http://schemas.openxmlformats.org/drawingml/2006/main"/>
+          <a:p xmlns:a="http://schemas.openxmlformats.org/drawingml/2006/main">
+            <a:pPr algn="l">
+              <a:lnSpc>
+                <a:spcPct val="100000"/>
+              </a:lnSpc>
+              <a:buNone/>
+              <a:defRPr sz="1200" b="0">
+                <a:solidFill>
+                  <a:srgbClr val="00A2EB"/>
+                </a:solidFill>
+                <a:latin typeface="Calibri"/>
+                <a:ea typeface="Calibri"/>
+                <a:cs typeface="Calibri"/>
+              </a:defRPr>
+            </a:pPr>
+            <a:r>
+              <a:rPr sz="1200" b="0">
+                <a:solidFill>
+                  <a:srgbClr val="00A2EB"/>
+                </a:solidFill>
+                <a:latin typeface="Calibri"/>
+                <a:ea typeface="Calibri"/>
+                <a:cs typeface="Calibri"/>
+              </a:rPr>
+              <a:t>0.03 ms · complete</a:t>
+            </a:r>
+          </a:p>
+        </p:txBody>
+      </p:sp>
+      <p:sp>
+        <p:nvSpPr>
+          <p:cNvPr id="15" name="ingestion-4">
+            <a:extLst xmlns:a="http://schemas.openxmlformats.org/drawingml/2006/main">
+              <a:ext uri="{FF2B5EF4-FFF2-40B4-BE49-F238E27FC236}">
+                <a16:creationId xmlns:a16="http://schemas.microsoft.com/office/drawing/2014/main" id="{7952DE37-BD86-481C-A575-8709971DD74E}"/>
+              </a:ext>
+            </a:extLst>
+          </p:cNvPr>
+          <p:cNvSpPr>
+            <a:spLocks xmlns:a="http://schemas.openxmlformats.org/drawingml/2006/main" noGrp="1"/>
+          </p:cNvSpPr>
+          <p:nvPr/>
+        </p:nvSpPr>
+        <p:spPr>
+          <a:xfrm xmlns:a="http://schemas.openxmlformats.org/drawingml/2006/main">
+            <a:off x="9448800" y="3086100"/>
+            <a:ext cx="2247900" cy="2266950"/>
+          </a:xfrm>
+          <a:prstGeom xmlns:a="http://schemas.openxmlformats.org/drawingml/2006/main" prst="roundRect">
+            <a:avLst>
+              <a:gd name="adj" fmla="val 5085"/>
+            </a:avLst>
+          </a:prstGeom>
+          <a:solidFill xmlns:a="http://schemas.openxmlformats.org/drawingml/2006/main">
+            <a:srgbClr val="FFFFFF"/>
+          </a:solidFill>
+          <a:ln xmlns:a="http://schemas.openxmlformats.org/drawingml/2006/main" w="9525">
+            <a:solidFill>
+              <a:srgbClr val="E4E7E9"/>
+            </a:solidFill>
+            <a:prstDash val="solid"/>
+          </a:ln>
+        </p:spPr>
+      </p:sp>
+      <p:sp>
+        <p:nvSpPr>
+          <p:cNvPr id="16" name="">
+            <a:extLst xmlns:a="http://schemas.openxmlformats.org/drawingml/2006/main">
+              <a:ext uri="{FF2B5EF4-FFF2-40B4-BE49-F238E27FC236}">
+                <a16:creationId xmlns:a16="http://schemas.microsoft.com/office/drawing/2014/main" id="{62EC2EC9-18A1-4F72-A64D-AF536DDC8F61}"/>
+              </a:ext>
+            </a:extLst>
+          </p:cNvPr>
+          <p:cNvSpPr>
+            <a:spLocks xmlns:a="http://schemas.openxmlformats.org/drawingml/2006/main" noGrp="1"/>
+          </p:cNvSpPr>
+          <p:nvPr/>
+        </p:nvSpPr>
+        <p:spPr>
+          <a:xfrm xmlns:a="http://schemas.openxmlformats.org/drawingml/2006/main">
+            <a:off x="9639300" y="3295650"/>
+            <a:ext cx="514350" cy="285750"/>
+          </a:xfrm>
+          <a:prstGeom xmlns:a="http://schemas.openxmlformats.org/drawingml/2006/main" prst="rect">
+            <a:avLst/>
+          </a:prstGeom>
+          <a:noFill xmlns:a="http://schemas.openxmlformats.org/drawingml/2006/main"/>
+          <a:ln xmlns:a="http://schemas.openxmlformats.org/drawingml/2006/main" w="0">
+            <a:noFill/>
+            <a:prstDash val="solid"/>
+          </a:ln>
+        </p:spPr>
+        <p:txBody>
+          <a:bodyPr xmlns:a="http://schemas.openxmlformats.org/drawingml/2006/main" wrap="square" lIns="0" tIns="0" rIns="0" bIns="0" anchor="ctr">
+            <a:noAutofit/>
+          </a:bodyPr>
+          <a:lstStyle xmlns:a="http://schemas.openxmlformats.org/drawingml/2006/main"/>
+          <a:p xmlns:a="http://schemas.openxmlformats.org/drawingml/2006/main">
+            <a:pPr algn="l">
+              <a:lnSpc>
+                <a:spcPct val="100000"/>
+              </a:lnSpc>
+              <a:buNone/>
+              <a:defRPr sz="1350" b="1">
+                <a:solidFill>
+                  <a:srgbClr val="00A2EB"/>
+                </a:solidFill>
+                <a:latin typeface="Calibri"/>
+                <a:ea typeface="Calibri"/>
+                <a:cs typeface="Calibri"/>
+              </a:defRPr>
+            </a:pPr>
+            <a:r>
+              <a:rPr sz="1800" b="1">
+                <a:solidFill>
+                  <a:srgbClr val="00A2EB"/>
+                </a:solidFill>
+                <a:latin typeface="Calibri"/>
+                <a:ea typeface="Calibri"/>
+                <a:cs typeface="Calibri"/>
+              </a:rPr>
+              <a:t>04</a:t>
+            </a:r>
+          </a:p>
+        </p:txBody>
+      </p:sp>
+      <p:sp>
+        <p:nvSpPr>
+          <p:cNvPr id="17" name="">
+            <a:extLst xmlns:a="http://schemas.openxmlformats.org/drawingml/2006/main">
+              <a:ext uri="{FF2B5EF4-FFF2-40B4-BE49-F238E27FC236}">
+                <a16:creationId xmlns:a16="http://schemas.microsoft.com/office/drawing/2014/main" id="{8540FD5A-1C0F-4BE1-B862-685F20D0F43C}"/>
+              </a:ext>
+            </a:extLst>
+          </p:cNvPr>
+          <p:cNvSpPr>
+            <a:spLocks xmlns:a="http://schemas.openxmlformats.org/drawingml/2006/main" noGrp="1"/>
+          </p:cNvSpPr>
+          <p:nvPr/>
+        </p:nvSpPr>
+        <p:spPr>
+          <a:xfrm xmlns:a="http://schemas.openxmlformats.org/drawingml/2006/main">
+            <a:off x="9563100" y="3752850"/>
+            <a:ext cx="2019300" cy="685800"/>
+          </a:xfrm>
+          <a:prstGeom xmlns:a="http://schemas.openxmlformats.org/drawingml/2006/main" prst="rect">
+            <a:avLst/>
+          </a:prstGeom>
+          <a:noFill xmlns:a="http://schemas.openxmlformats.org/drawingml/2006/main"/>
+          <a:ln xmlns:a="http://schemas.openxmlformats.org/drawingml/2006/main" w="0">
+            <a:noFill/>
+            <a:prstDash val="solid"/>
+          </a:ln>
+        </p:spPr>
+        <p:txBody>
+          <a:bodyPr xmlns:a="http://schemas.openxmlformats.org/drawingml/2006/main" wrap="square" lIns="0" tIns="0" rIns="0" bIns="0" anchor="ctr">
+            <a:normAutofit fontScale="100000"/>
+          </a:bodyPr>
+          <a:lstStyle xmlns:a="http://schemas.openxmlformats.org/drawingml/2006/main"/>
+          <a:p xmlns:a="http://schemas.openxmlformats.org/drawingml/2006/main">
+            <a:pPr algn="l">
+              <a:lnSpc>
+                <a:spcPct val="100000"/>
+              </a:lnSpc>
+              <a:buNone/>
+              <a:defRPr sz="1950" b="1">
+                <a:solidFill>
+                  <a:srgbClr val="051C2A"/>
+                </a:solidFill>
+                <a:latin typeface="Calibri"/>
+                <a:ea typeface="Calibri"/>
+                <a:cs typeface="Calibri"/>
+              </a:defRPr>
+            </a:pPr>
+            <a:r>
+              <a:rPr sz="1950" b="1">
+                <a:solidFill>
+                  <a:srgbClr val="051C2A"/>
+                </a:solidFill>
+                <a:latin typeface="Calibri"/>
+                <a:ea typeface="Calibri"/>
+                <a:cs typeface="Calibri"/>
+              </a:rPr>
+              <a:t>Fusion</a:t>
+            </a:r>
+          </a:p>
+        </p:txBody>
+      </p:sp>
+      <p:sp>
+        <p:nvSpPr>
+          <p:cNvPr id="18" name="">
+            <a:extLst xmlns:a="http://schemas.openxmlformats.org/drawingml/2006/main">
+              <a:ext uri="{FF2B5EF4-FFF2-40B4-BE49-F238E27FC236}">
+                <a16:creationId xmlns:a16="http://schemas.microsoft.com/office/drawing/2014/main" id="{67E52B70-645C-40F7-B0DE-1D1D177875CC}"/>
+              </a:ext>
+            </a:extLst>
+          </p:cNvPr>
+          <p:cNvSpPr>
+            <a:spLocks xmlns:a="http://schemas.openxmlformats.org/drawingml/2006/main" noGrp="1"/>
+          </p:cNvSpPr>
+          <p:nvPr/>
+        </p:nvSpPr>
+        <p:spPr>
+          <a:xfrm xmlns:a="http://schemas.openxmlformats.org/drawingml/2006/main">
+            <a:off x="9639300" y="4610100"/>
+            <a:ext cx="1866900" cy="514350"/>
+          </a:xfrm>
+          <a:prstGeom xmlns:a="http://schemas.openxmlformats.org/drawingml/2006/main" prst="rect">
+            <a:avLst/>
+          </a:prstGeom>
+          <a:noFill xmlns:a="http://schemas.openxmlformats.org/drawingml/2006/main"/>
+          <a:ln xmlns:a="http://schemas.openxmlformats.org/drawingml/2006/main" w="0">
+            <a:noFill/>
+            <a:prstDash val="solid"/>
+          </a:ln>
+        </p:spPr>
+        <p:txBody>
+          <a:bodyPr xmlns:a="http://schemas.openxmlformats.org/drawingml/2006/main" wrap="square" lIns="0" tIns="0" rIns="0" bIns="0" anchor="ctr">
+            <a:normAutofit fontScale="100000"/>
+          </a:bodyPr>
+          <a:lstStyle xmlns:a="http://schemas.openxmlformats.org/drawingml/2006/main"/>
+          <a:p xmlns:a="http://schemas.openxmlformats.org/drawingml/2006/main">
+            <a:pPr algn="l">
+              <a:lnSpc>
+                <a:spcPct val="100000"/>
+              </a:lnSpc>
+              <a:buNone/>
+              <a:defRPr sz="1200" b="0">
+                <a:solidFill>
+                  <a:srgbClr val="1F40CB"/>
+                </a:solidFill>
+                <a:latin typeface="Calibri"/>
+                <a:ea typeface="Calibri"/>
+                <a:cs typeface="Calibri"/>
+              </a:defRPr>
+            </a:pPr>
+            <a:r>
+              <a:rPr sz="1200" b="0">
+                <a:solidFill>
+                  <a:srgbClr val="1F40CB"/>
+                </a:solidFill>
+                <a:latin typeface="Calibri"/>
+                <a:ea typeface="Calibri"/>
+                <a:cs typeface="Calibri"/>
+              </a:rPr>
+              <a:t>0.01 ms · complete</a:t>
+            </a:r>
+          </a:p>
+        </p:txBody>
+      </p:sp>
+      <p:sp>
+        <p:nvSpPr>
+          <p:cNvPr id="19" name="ingestion-5">
+            <a:extLst xmlns:a="http://schemas.openxmlformats.org/drawingml/2006/main">
+              <a:ext uri="{FF2B5EF4-FFF2-40B4-BE49-F238E27FC236}">
+                <a16:creationId xmlns:a16="http://schemas.microsoft.com/office/drawing/2014/main" id="{43F7E1B1-E237-4A79-B0C4-38965CF32D74}"/>
+              </a:ext>
+            </a:extLst>
+          </p:cNvPr>
+          <p:cNvSpPr>
+            <a:spLocks xmlns:a="http://schemas.openxmlformats.org/drawingml/2006/main" noGrp="1"/>
+          </p:cNvSpPr>
+          <p:nvPr/>
+        </p:nvSpPr>
+        <p:spPr>
+          <a:xfrm xmlns:a="http://schemas.openxmlformats.org/drawingml/2006/main">
+            <a:off x="12268200" y="3086100"/>
+            <a:ext cx="2247900" cy="2266950"/>
+          </a:xfrm>
+          <a:prstGeom xmlns:a="http://schemas.openxmlformats.org/drawingml/2006/main" prst="roundRect">
+            <a:avLst>
+              <a:gd name="adj" fmla="val 5085"/>
+            </a:avLst>
+          </a:prstGeom>
+          <a:solidFill xmlns:a="http://schemas.openxmlformats.org/drawingml/2006/main">
+            <a:srgbClr val="FFFFFF"/>
+          </a:solidFill>
+          <a:ln xmlns:a="http://schemas.openxmlformats.org/drawingml/2006/main" w="19050">
+            <a:solidFill>
+              <a:srgbClr val="F07D00"/>
+            </a:solidFill>
+            <a:prstDash val="solid"/>
+          </a:ln>
+        </p:spPr>
+      </p:sp>
+      <p:sp>
+        <p:nvSpPr>
+          <p:cNvPr id="20" name="">
+            <a:extLst xmlns:a="http://schemas.openxmlformats.org/drawingml/2006/main">
+              <a:ext uri="{FF2B5EF4-FFF2-40B4-BE49-F238E27FC236}">
+                <a16:creationId xmlns:a16="http://schemas.microsoft.com/office/drawing/2014/main" id="{51764D39-05B0-4F08-BC2B-2221BE2F38D6}"/>
+              </a:ext>
+            </a:extLst>
+          </p:cNvPr>
+          <p:cNvSpPr>
+            <a:spLocks xmlns:a="http://schemas.openxmlformats.org/drawingml/2006/main" noGrp="1"/>
+          </p:cNvSpPr>
+          <p:nvPr/>
+        </p:nvSpPr>
+        <p:spPr>
+          <a:xfrm xmlns:a="http://schemas.openxmlformats.org/drawingml/2006/main">
+            <a:off x="12458700" y="3295650"/>
+            <a:ext cx="514350" cy="285750"/>
+          </a:xfrm>
+          <a:prstGeom xmlns:a="http://schemas.openxmlformats.org/drawingml/2006/main" prst="rect">
+            <a:avLst/>
+          </a:prstGeom>
+          <a:noFill xmlns:a="http://schemas.openxmlformats.org/drawingml/2006/main"/>
+          <a:ln xmlns:a="http://schemas.openxmlformats.org/drawingml/2006/main" w="0">
+            <a:noFill/>
+            <a:prstDash val="solid"/>
+          </a:ln>
+        </p:spPr>
+        <p:txBody>
+          <a:bodyPr xmlns:a="http://schemas.openxmlformats.org/drawingml/2006/main" wrap="square" lIns="0" tIns="0" rIns="0" bIns="0" anchor="ctr">
+            <a:noAutofit/>
+          </a:bodyPr>
+          <a:lstStyle xmlns:a="http://schemas.openxmlformats.org/drawingml/2006/main"/>
+          <a:p xmlns:a="http://schemas.openxmlformats.org/drawingml/2006/main">
+            <a:pPr algn="l">
+              <a:lnSpc>
+                <a:spcPct val="100000"/>
+              </a:lnSpc>
+              <a:buNone/>
+              <a:defRPr sz="1350" b="1">
+                <a:solidFill>
+                  <a:srgbClr val="00A2EB"/>
+                </a:solidFill>
+                <a:latin typeface="Calibri"/>
+                <a:ea typeface="Calibri"/>
+                <a:cs typeface="Calibri"/>
+              </a:defRPr>
+            </a:pPr>
+            <a:r>
+              <a:rPr sz="1800" b="1">
+                <a:solidFill>
+                  <a:srgbClr val="00A2EB"/>
+                </a:solidFill>
+                <a:latin typeface="Calibri"/>
+                <a:ea typeface="Calibri"/>
+                <a:cs typeface="Calibri"/>
+              </a:rPr>
+              <a:t>05</a:t>
+            </a:r>
+          </a:p>
+        </p:txBody>
+      </p:sp>
+      <p:sp>
+        <p:nvSpPr>
+          <p:cNvPr id="21" name="">
+            <a:extLst xmlns:a="http://schemas.openxmlformats.org/drawingml/2006/main">
+              <a:ext uri="{FF2B5EF4-FFF2-40B4-BE49-F238E27FC236}">
+                <a16:creationId xmlns:a16="http://schemas.microsoft.com/office/drawing/2014/main" id="{C0F4CBB5-9FF7-4C7B-8D8C-5AA3541DD5E4}"/>
+              </a:ext>
+            </a:extLst>
+          </p:cNvPr>
+          <p:cNvSpPr>
+            <a:spLocks xmlns:a="http://schemas.openxmlformats.org/drawingml/2006/main" noGrp="1"/>
+          </p:cNvSpPr>
+          <p:nvPr/>
+        </p:nvSpPr>
+        <p:spPr>
+          <a:xfrm xmlns:a="http://schemas.openxmlformats.org/drawingml/2006/main">
+            <a:off x="12382500" y="3752850"/>
+            <a:ext cx="2019300" cy="685800"/>
+          </a:xfrm>
+          <a:prstGeom xmlns:a="http://schemas.openxmlformats.org/drawingml/2006/main" prst="rect">
+            <a:avLst/>
+          </a:prstGeom>
+          <a:noFill xmlns:a="http://schemas.openxmlformats.org/drawingml/2006/main"/>
+          <a:ln xmlns:a="http://schemas.openxmlformats.org/drawingml/2006/main" w="0">
+            <a:noFill/>
+            <a:prstDash val="solid"/>
+          </a:ln>
+        </p:spPr>
+        <p:txBody>
+          <a:bodyPr xmlns:a="http://schemas.openxmlformats.org/drawingml/2006/main" wrap="square" lIns="0" tIns="0" rIns="0" bIns="0" anchor="ctr">
+            <a:normAutofit fontScale="100000"/>
+          </a:bodyPr>
+          <a:lstStyle xmlns:a="http://schemas.openxmlformats.org/drawingml/2006/main"/>
+          <a:p xmlns:a="http://schemas.openxmlformats.org/drawingml/2006/main">
+            <a:pPr algn="l">
+              <a:lnSpc>
+                <a:spcPct val="100000"/>
+              </a:lnSpc>
+              <a:buNone/>
+              <a:defRPr sz="1950" b="1">
+                <a:solidFill>
+                  <a:srgbClr val="051C2A"/>
+                </a:solidFill>
+                <a:latin typeface="Calibri"/>
+                <a:ea typeface="Calibri"/>
+                <a:cs typeface="Calibri"/>
+              </a:defRPr>
+            </a:pPr>
+            <a:r>
+              <a:rPr sz="1950" b="1">
+                <a:solidFill>
+                  <a:srgbClr val="051C2A"/>
+                </a:solidFill>
+                <a:latin typeface="Calibri"/>
+                <a:ea typeface="Calibri"/>
+                <a:cs typeface="Calibri"/>
+              </a:rPr>
+              <a:t>Rerank</a:t>
+            </a:r>
+          </a:p>
+        </p:txBody>
+      </p:sp>
+      <p:sp>
+        <p:nvSpPr>
+          <p:cNvPr id="22" name="">
+            <a:extLst xmlns:a="http://schemas.openxmlformats.org/drawingml/2006/main">
+              <a:ext uri="{FF2B5EF4-FFF2-40B4-BE49-F238E27FC236}">
+                <a16:creationId xmlns:a16="http://schemas.microsoft.com/office/drawing/2014/main" id="{8856B515-B8BF-4B9C-8D6B-EC909D2B3B4E}"/>
+              </a:ext>
+            </a:extLst>
+          </p:cNvPr>
+          <p:cNvSpPr>
+            <a:spLocks xmlns:a="http://schemas.openxmlformats.org/drawingml/2006/main" noGrp="1"/>
+          </p:cNvSpPr>
+          <p:nvPr/>
+        </p:nvSpPr>
+        <p:spPr>
+          <a:xfrm xmlns:a="http://schemas.openxmlformats.org/drawingml/2006/main">
+            <a:off x="12458700" y="4610100"/>
+            <a:ext cx="1866900" cy="514350"/>
+          </a:xfrm>
+          <a:prstGeom xmlns:a="http://schemas.openxmlformats.org/drawingml/2006/main" prst="rect">
+            <a:avLst/>
+          </a:prstGeom>
+          <a:noFill xmlns:a="http://schemas.openxmlformats.org/drawingml/2006/main"/>
+          <a:ln xmlns:a="http://schemas.openxmlformats.org/drawingml/2006/main" w="0">
+            <a:noFill/>
+            <a:prstDash val="solid"/>
+          </a:ln>
+        </p:spPr>
+        <p:txBody>
+          <a:bodyPr xmlns:a="http://schemas.openxmlformats.org/drawingml/2006/main" wrap="square" lIns="0" tIns="0" rIns="0" bIns="0" anchor="ctr">
+            <a:normAutofit fontScale="100000"/>
+          </a:bodyPr>
+          <a:lstStyle xmlns:a="http://schemas.openxmlformats.org/drawingml/2006/main"/>
+          <a:p xmlns:a="http://schemas.openxmlformats.org/drawingml/2006/main">
+            <a:pPr algn="l">
+              <a:lnSpc>
+                <a:spcPct val="100000"/>
+              </a:lnSpc>
+              <a:buNone/>
+              <a:defRPr sz="1200" b="0">
+                <a:solidFill>
+                  <a:srgbClr val="1F40CB"/>
+                </a:solidFill>
+                <a:latin typeface="Calibri"/>
+                <a:ea typeface="Calibri"/>
+                <a:cs typeface="Calibri"/>
+              </a:defRPr>
+            </a:pPr>
+            <a:r>
+              <a:rPr sz="1200" b="0">
+                <a:solidFill>
+                  <a:srgbClr val="1F40CB"/>
+                </a:solidFill>
+                <a:latin typeface="Calibri"/>
+                <a:ea typeface="Calibri"/>
+                <a:cs typeface="Calibri"/>
+              </a:rPr>
+              <a:t>0.06 ms · complete</a:t>
+            </a:r>
+          </a:p>
+        </p:txBody>
+      </p:sp>
+      <p:cxnSp>
+        <p:nvCxnSpPr>
+          <p:cNvPr id="317" name=""/>
+          <p:cNvCxnSpPr>
+            <a:stCxn xmlns:a="http://schemas.openxmlformats.org/drawingml/2006/main" id="3" idx="3"/>
+            <a:endCxn xmlns:a="http://schemas.openxmlformats.org/drawingml/2006/main" id="7" idx="1"/>
+          </p:cNvCxnSpPr>
+          <p:nvPr/>
+        </p:nvCxnSpPr>
+        <p:spPr>
+          <a:xfrm xmlns:a="http://schemas.openxmlformats.org/drawingml/2006/main">
+            <a:off x="3238500" y="4219575"/>
+            <a:ext cx="571500" cy="0"/>
+          </a:xfrm>
+          <a:prstGeom xmlns:a="http://schemas.openxmlformats.org/drawingml/2006/main" prst="straightConnector1">
+            <a:avLst/>
+          </a:prstGeom>
+          <a:ln xmlns:a="http://schemas.openxmlformats.org/drawingml/2006/main" w="28575">
+            <a:solidFill>
+              <a:srgbClr val="9A9A9F"/>
+            </a:solidFill>
+            <a:prstDash val="solid"/>
+            <a:tailEnd type="triangle" w="med" len="med"/>
+          </a:ln>
+        </p:spPr>
+      </p:cxnSp>
+      <p:cxnSp>
+        <p:nvCxnSpPr>
+          <p:cNvPr id="318" name=""/>
+          <p:cNvCxnSpPr>
+            <a:stCxn xmlns:a="http://schemas.openxmlformats.org/drawingml/2006/main" id="7" idx="3"/>
+            <a:endCxn xmlns:a="http://schemas.openxmlformats.org/drawingml/2006/main" id="11" idx="1"/>
+          </p:cNvCxnSpPr>
+          <p:nvPr/>
+        </p:nvCxnSpPr>
+        <p:spPr>
+          <a:xfrm xmlns:a="http://schemas.openxmlformats.org/drawingml/2006/main">
+            <a:off x="6057900" y="4219575"/>
+            <a:ext cx="571500" cy="0"/>
+          </a:xfrm>
+          <a:prstGeom xmlns:a="http://schemas.openxmlformats.org/drawingml/2006/main" prst="straightConnector1">
+            <a:avLst/>
+          </a:prstGeom>
+          <a:ln xmlns:a="http://schemas.openxmlformats.org/drawingml/2006/main" w="28575">
+            <a:solidFill>
+              <a:srgbClr val="9A9A9F"/>
+            </a:solidFill>
+            <a:prstDash val="solid"/>
+            <a:tailEnd type="triangle" w="med" len="med"/>
+          </a:ln>
+        </p:spPr>
+      </p:cxnSp>
+      <p:cxnSp>
+        <p:nvCxnSpPr>
+          <p:cNvPr id="319" name=""/>
+          <p:cNvCxnSpPr>
+            <a:stCxn xmlns:a="http://schemas.openxmlformats.org/drawingml/2006/main" id="11" idx="3"/>
+            <a:endCxn xmlns:a="http://schemas.openxmlformats.org/drawingml/2006/main" id="15" idx="1"/>
+          </p:cNvCxnSpPr>
+          <p:nvPr/>
+        </p:nvCxnSpPr>
+        <p:spPr>
+          <a:xfrm xmlns:a="http://schemas.openxmlformats.org/drawingml/2006/main">
+            <a:off x="8877300" y="4219575"/>
+            <a:ext cx="571500" cy="0"/>
+          </a:xfrm>
+          <a:prstGeom xmlns:a="http://schemas.openxmlformats.org/drawingml/2006/main" prst="straightConnector1">
+            <a:avLst/>
+          </a:prstGeom>
+          <a:ln xmlns:a="http://schemas.openxmlformats.org/drawingml/2006/main" w="28575">
+            <a:solidFill>
+              <a:srgbClr val="9A9A9F"/>
+            </a:solidFill>
+            <a:prstDash val="solid"/>
+            <a:tailEnd type="triangle" w="med" len="med"/>
+          </a:ln>
+        </p:spPr>
+      </p:cxnSp>
+      <p:cxnSp>
+        <p:nvCxnSpPr>
+          <p:cNvPr id="320" name=""/>
+          <p:cNvCxnSpPr>
+            <a:stCxn xmlns:a="http://schemas.openxmlformats.org/drawingml/2006/main" id="15" idx="3"/>
+            <a:endCxn xmlns:a="http://schemas.openxmlformats.org/drawingml/2006/main" id="19" idx="1"/>
+          </p:cNvCxnSpPr>
+          <p:nvPr/>
+        </p:nvCxnSpPr>
+        <p:spPr>
+          <a:xfrm xmlns:a="http://schemas.openxmlformats.org/drawingml/2006/main">
+            <a:off x="11696700" y="4219575"/>
+            <a:ext cx="571500" cy="0"/>
+          </a:xfrm>
+          <a:prstGeom xmlns:a="http://schemas.openxmlformats.org/drawingml/2006/main" prst="straightConnector1">
+            <a:avLst/>
+          </a:prstGeom>
+          <a:ln xmlns:a="http://schemas.openxmlformats.org/drawingml/2006/main" w="28575">
+            <a:solidFill>
+              <a:srgbClr val="9A9A9F"/>
+            </a:solidFill>
+            <a:prstDash val="solid"/>
+            <a:tailEnd type="triangle" w="med" len="med"/>
+          </a:ln>
+        </p:spPr>
+      </p:cxnSp>
+      <p:sp>
+        <p:nvSpPr>
+          <p:cNvPr id="27" name="">
+            <a:extLst xmlns:a="http://schemas.openxmlformats.org/drawingml/2006/main">
+              <a:ext uri="{FF2B5EF4-FFF2-40B4-BE49-F238E27FC236}">
+                <a16:creationId xmlns:a16="http://schemas.microsoft.com/office/drawing/2014/main" id="{79128475-820B-447C-A724-7D8A31328FFE}"/>
+              </a:ext>
+            </a:extLst>
+          </p:cNvPr>
+          <p:cNvSpPr>
+            <a:spLocks xmlns:a="http://schemas.openxmlformats.org/drawingml/2006/main" noGrp="1"/>
+          </p:cNvSpPr>
+          <p:nvPr/>
+        </p:nvSpPr>
+        <p:spPr>
+          <a:xfrm xmlns:a="http://schemas.openxmlformats.org/drawingml/2006/main">
+            <a:off x="2381250" y="6210300"/>
+            <a:ext cx="10477500" cy="457200"/>
+          </a:xfrm>
+          <a:prstGeom xmlns:a="http://schemas.openxmlformats.org/drawingml/2006/main" prst="rect">
+            <a:avLst/>
+          </a:prstGeom>
+          <a:noFill xmlns:a="http://schemas.openxmlformats.org/drawingml/2006/main"/>
+          <a:ln xmlns:a="http://schemas.openxmlformats.org/drawingml/2006/main" w="0">
+            <a:noFill/>
+            <a:prstDash val="solid"/>
+          </a:ln>
+        </p:spPr>
+        <p:txBody>
+          <a:bodyPr xmlns:a="http://schemas.openxmlformats.org/drawingml/2006/main" wrap="square" lIns="0" tIns="0" rIns="0" bIns="0" anchor="ctr">
+            <a:normAutofit fontScale="100000"/>
+          </a:bodyPr>
+          <a:lstStyle xmlns:a="http://schemas.openxmlformats.org/drawingml/2006/main"/>
+          <a:p xmlns:a="http://schemas.openxmlformats.org/drawingml/2006/main">
+            <a:pPr algn="ctr">
+              <a:lnSpc>
+                <a:spcPct val="100000"/>
+              </a:lnSpc>
+              <a:buNone/>
+              <a:defRPr sz="2100" b="1">
+                <a:solidFill>
+                  <a:srgbClr val="051C2A"/>
+                </a:solidFill>
+                <a:latin typeface="Calibri"/>
+                <a:ea typeface="Calibri"/>
+                <a:cs typeface="Calibri"/>
+              </a:defRPr>
+            </a:pPr>
+            <a:r>
+              <a:rPr sz="2100" b="1">
+                <a:solidFill>
+                  <a:srgbClr val="051C2A"/>
+                </a:solidFill>
+                <a:latin typeface="Calibri"/>
+                <a:ea typeface="Calibri"/>
+                <a:cs typeface="Calibri"/>
+              </a:rPr>
+              <a:t>Lesson 07 maps these stage objects to trace spans—no pipeline rewrite.</a:t>
+            </a:r>
+          </a:p>
+        </p:txBody>
+      </p:sp>
+      <p:sp>
+        <p:nvSpPr>
+          <p:cNvPr id="28" name="">
+            <a:extLst xmlns:a="http://schemas.openxmlformats.org/drawingml/2006/main">
+              <a:ext uri="{FF2B5EF4-FFF2-40B4-BE49-F238E27FC236}">
+                <a16:creationId xmlns:a16="http://schemas.microsoft.com/office/drawing/2014/main" id="{685F2AAD-81FC-436A-88F7-89F49C9F1671}"/>
+              </a:ext>
+            </a:extLst>
+          </p:cNvPr>
+          <p:cNvSpPr>
+            <a:spLocks xmlns:a="http://schemas.openxmlformats.org/drawingml/2006/main" noGrp="1"/>
+          </p:cNvSpPr>
+          <p:nvPr/>
+        </p:nvSpPr>
+        <p:spPr>
+          <a:xfrm xmlns:a="http://schemas.openxmlformats.org/drawingml/2006/main">
+            <a:off x="1885950" y="6838950"/>
+            <a:ext cx="4476750" cy="323850"/>
+          </a:xfrm>
+          <a:prstGeom xmlns:a="http://schemas.openxmlformats.org/drawingml/2006/main" prst="rect">
+            <a:avLst/>
+          </a:prstGeom>
+          <a:noFill xmlns:a="http://schemas.openxmlformats.org/drawingml/2006/main"/>
+          <a:ln xmlns:a="http://schemas.openxmlformats.org/drawingml/2006/main" w="0">
+            <a:noFill/>
+            <a:prstDash val="solid"/>
+          </a:ln>
+        </p:spPr>
+        <p:txBody>
+          <a:bodyPr xmlns:a="http://schemas.openxmlformats.org/drawingml/2006/main" wrap="square" lIns="0" tIns="0" rIns="0" bIns="0" anchor="ctr">
+            <a:normAutofit fontScale="100000"/>
+          </a:bodyPr>
+          <a:lstStyle xmlns:a="http://schemas.openxmlformats.org/drawingml/2006/main"/>
+          <a:p xmlns:a="http://schemas.openxmlformats.org/drawingml/2006/main">
+            <a:pPr algn="ctr">
+              <a:lnSpc>
+                <a:spcPct val="100000"/>
+              </a:lnSpc>
+              <a:buNone/>
+              <a:defRPr sz="1500" b="0">
+                <a:solidFill>
+                  <a:srgbClr val="64748B"/>
+                </a:solidFill>
+                <a:latin typeface="Calibri"/>
+                <a:ea typeface="Calibri"/>
+                <a:cs typeface="Calibri"/>
+              </a:defRPr>
+            </a:pPr>
+            <a:r>
+              <a:rPr sz="1500" b="0">
+                <a:solidFill>
+                  <a:srgbClr val="64748B"/>
+                </a:solidFill>
+                <a:latin typeface="Calibri"/>
+                <a:ea typeface="Calibri"/>
+                <a:cs typeface="Calibri"/>
+              </a:rPr>
+              <a:t>offline example · timings vary by machine</a:t>
+            </a:r>
+          </a:p>
+        </p:txBody>
+      </p:sp>
+      <p:sp>
+        <p:nvSpPr>
+          <p:cNvPr id="29" name="">
+            <a:extLst xmlns:a="http://schemas.openxmlformats.org/drawingml/2006/main">
+              <a:ext uri="{FF2B5EF4-FFF2-40B4-BE49-F238E27FC236}">
+                <a16:creationId xmlns:a16="http://schemas.microsoft.com/office/drawing/2014/main" id="{CDE04AD7-6CBE-4792-B549-765578FB3E1E}"/>
+              </a:ext>
+            </a:extLst>
+          </p:cNvPr>
+          <p:cNvSpPr>
+            <a:spLocks xmlns:a="http://schemas.openxmlformats.org/drawingml/2006/main" noGrp="1"/>
+          </p:cNvSpPr>
+          <p:nvPr/>
+        </p:nvSpPr>
+        <p:spPr>
+          <a:xfrm xmlns:a="http://schemas.openxmlformats.org/drawingml/2006/main">
+            <a:off x="8801100" y="6838950"/>
+            <a:ext cx="4762500" cy="323850"/>
+          </a:xfrm>
+          <a:prstGeom xmlns:a="http://schemas.openxmlformats.org/drawingml/2006/main" prst="rect">
+            <a:avLst/>
+          </a:prstGeom>
+          <a:noFill xmlns:a="http://schemas.openxmlformats.org/drawingml/2006/main"/>
+          <a:ln xmlns:a="http://schemas.openxmlformats.org/drawingml/2006/main" w="0">
+            <a:noFill/>
+            <a:prstDash val="solid"/>
+          </a:ln>
+        </p:spPr>
+        <p:txBody>
+          <a:bodyPr xmlns:a="http://schemas.openxmlformats.org/drawingml/2006/main" wrap="square" lIns="0" tIns="0" rIns="0" bIns="0" anchor="ctr">
+            <a:normAutofit fontScale="100000"/>
+          </a:bodyPr>
+          <a:lstStyle xmlns:a="http://schemas.openxmlformats.org/drawingml/2006/main"/>
+          <a:p xmlns:a="http://schemas.openxmlformats.org/drawingml/2006/main">
+            <a:pPr algn="ctr">
+              <a:lnSpc>
+                <a:spcPct val="100000"/>
+              </a:lnSpc>
+              <a:buNone/>
+              <a:defRPr sz="1500" b="0">
+                <a:solidFill>
+                  <a:srgbClr val="64748B"/>
+                </a:solidFill>
+                <a:latin typeface="Calibri"/>
+                <a:ea typeface="Calibri"/>
+                <a:cs typeface="Calibri"/>
+              </a:defRPr>
+            </a:pPr>
+            <a:r>
+              <a:rPr sz="1500" b="0">
+                <a:solidFill>
+                  <a:srgbClr val="64748B"/>
+                </a:solidFill>
+                <a:latin typeface="Calibri"/>
+                <a:ea typeface="Calibri"/>
+                <a:cs typeface="Calibri"/>
+              </a:rPr>
+              <a:t>future spans · inputs · outputs · duration</a:t>
+            </a:r>
+          </a:p>
+        </p:txBody>
+      </p:sp>
+      <p:sp>
+        <p:nvSpPr>
+          <p:cNvPr id="30" name="">
+            <a:extLst xmlns:a="http://schemas.openxmlformats.org/drawingml/2006/main">
+              <a:ext uri="{FF2B5EF4-FFF2-40B4-BE49-F238E27FC236}">
+                <a16:creationId xmlns:a16="http://schemas.microsoft.com/office/drawing/2014/main" id="{28CBA7AE-993C-4F84-A696-8D1323AC4E80}"/>
+              </a:ext>
+            </a:extLst>
+          </p:cNvPr>
+          <p:cNvSpPr>
+            <a:spLocks xmlns:a="http://schemas.openxmlformats.org/drawingml/2006/main" noGrp="1"/>
+          </p:cNvSpPr>
+          <p:nvPr/>
+        </p:nvSpPr>
+        <p:spPr>
+          <a:xfrm xmlns:a="http://schemas.openxmlformats.org/drawingml/2006/main">
+            <a:off x="857250" y="7896225"/>
+            <a:ext cx="13525500" cy="28575"/>
+          </a:xfrm>
+          <a:prstGeom xmlns:a="http://schemas.openxmlformats.org/drawingml/2006/main" prst="rect">
+            <a:avLst/>
+          </a:prstGeom>
+          <a:solidFill xmlns:a="http://schemas.openxmlformats.org/drawingml/2006/main">
+            <a:srgbClr val="E4E7E9"/>
+          </a:solidFill>
+          <a:ln xmlns:a="http://schemas.openxmlformats.org/drawingml/2006/main" w="0">
+            <a:solidFill>
+              <a:srgbClr val="E4E7E9"/>
+            </a:solidFill>
+            <a:prstDash val="solid"/>
+          </a:ln>
+        </p:spPr>
+      </p:sp>
+      <p:sp>
+        <p:nvSpPr>
+          <p:cNvPr id="31" name="">
+            <a:extLst xmlns:a="http://schemas.openxmlformats.org/drawingml/2006/main">
+              <a:ext uri="{FF2B5EF4-FFF2-40B4-BE49-F238E27FC236}">
+                <a16:creationId xmlns:a16="http://schemas.microsoft.com/office/drawing/2014/main" id="{DE97BF4D-EDBC-4480-A82B-512A72221950}"/>
+              </a:ext>
+            </a:extLst>
+          </p:cNvPr>
+          <p:cNvSpPr>
+            <a:spLocks xmlns:a="http://schemas.openxmlformats.org/drawingml/2006/main" noGrp="1"/>
+          </p:cNvSpPr>
+          <p:nvPr/>
+        </p:nvSpPr>
+        <p:spPr>
+          <a:xfrm xmlns:a="http://schemas.openxmlformats.org/drawingml/2006/main">
+            <a:off x="857250" y="7896225"/>
+            <a:ext cx="8001000" cy="38100"/>
+          </a:xfrm>
+          <a:prstGeom xmlns:a="http://schemas.openxmlformats.org/drawingml/2006/main" prst="rect">
+            <a:avLst/>
+          </a:prstGeom>
+          <a:solidFill xmlns:a="http://schemas.openxmlformats.org/drawingml/2006/main">
+            <a:srgbClr val="00A2EB"/>
+          </a:solidFill>
+          <a:ln xmlns:a="http://schemas.openxmlformats.org/drawingml/2006/main" w="0">
+            <a:solidFill>
+              <a:srgbClr val="00A2EB"/>
+            </a:solidFill>
+            <a:prstDash val="solid"/>
+          </a:ln>
+        </p:spPr>
+      </p:sp>
+      <p:sp>
+        <p:nvSpPr>
+          <p:cNvPr id="32" name="">
+            <a:extLst xmlns:a="http://schemas.openxmlformats.org/drawingml/2006/main">
+              <a:ext uri="{FF2B5EF4-FFF2-40B4-BE49-F238E27FC236}">
+                <a16:creationId xmlns:a16="http://schemas.microsoft.com/office/drawing/2014/main" id="{49281B64-2F0F-4357-A085-C65451F28236}"/>
+              </a:ext>
+            </a:extLst>
+          </p:cNvPr>
+          <p:cNvSpPr>
+            <a:spLocks xmlns:a="http://schemas.openxmlformats.org/drawingml/2006/main" noGrp="1"/>
+          </p:cNvSpPr>
+          <p:nvPr/>
+        </p:nvSpPr>
+        <p:spPr>
+          <a:xfrm xmlns:a="http://schemas.openxmlformats.org/drawingml/2006/main">
+            <a:off x="971550" y="8058150"/>
+            <a:ext cx="3714750" cy="323850"/>
+          </a:xfrm>
+          <a:prstGeom xmlns:a="http://schemas.openxmlformats.org/drawingml/2006/main" prst="rect">
+            <a:avLst/>
+          </a:prstGeom>
+          <a:noFill xmlns:a="http://schemas.openxmlformats.org/drawingml/2006/main"/>
+          <a:ln xmlns:a="http://schemas.openxmlformats.org/drawingml/2006/main" w="0">
+            <a:noFill/>
+            <a:prstDash val="solid"/>
+          </a:ln>
+        </p:spPr>
+        <p:txBody>
+          <a:bodyPr xmlns:a="http://schemas.openxmlformats.org/drawingml/2006/main" wrap="square" lIns="0" tIns="0" rIns="0" bIns="0" anchor="ctr">
+            <a:normAutofit fontScale="100000"/>
+          </a:bodyPr>
+          <a:lstStyle xmlns:a="http://schemas.openxmlformats.org/drawingml/2006/main"/>
+          <a:p xmlns:a="http://schemas.openxmlformats.org/drawingml/2006/main">
+            <a:pPr algn="l">
+              <a:lnSpc>
+                <a:spcPct val="100000"/>
+              </a:lnSpc>
+              <a:buNone/>
+              <a:defRPr sz="1200" b="0">
+                <a:solidFill>
+                  <a:srgbClr val="9A9A9F"/>
+                </a:solidFill>
+                <a:latin typeface="Calibri"/>
+                <a:ea typeface="Calibri"/>
+                <a:cs typeface="Calibri"/>
+              </a:defRPr>
+            </a:pPr>
+            <a:r>
+              <a:rPr sz="1200" b="0">
+                <a:solidFill>
+                  <a:srgbClr val="9A9A9F"/>
+                </a:solidFill>
+                <a:latin typeface="Calibri"/>
+                <a:ea typeface="Calibri"/>
+                <a:cs typeface="Calibri"/>
+              </a:rPr>
+              <a:t>First Finance - Arnaud Demes</a:t>
+            </a:r>
+          </a:p>
+        </p:txBody>
+      </p:sp>
+      <p:sp>
+        <p:nvSpPr>
+          <p:cNvPr id="33" name="">
+            <a:extLst xmlns:a="http://schemas.openxmlformats.org/drawingml/2006/main">
+              <a:ext uri="{FF2B5EF4-FFF2-40B4-BE49-F238E27FC236}">
+                <a16:creationId xmlns:a16="http://schemas.microsoft.com/office/drawing/2014/main" id="{EAA325A4-7EC6-42CE-A13A-4B38A32DE7F2}"/>
+              </a:ext>
+            </a:extLst>
+          </p:cNvPr>
+          <p:cNvSpPr>
+            <a:spLocks xmlns:a="http://schemas.openxmlformats.org/drawingml/2006/main" noGrp="1"/>
+          </p:cNvSpPr>
+          <p:nvPr/>
+        </p:nvSpPr>
+        <p:spPr>
+          <a:xfrm xmlns:a="http://schemas.openxmlformats.org/drawingml/2006/main">
+            <a:off x="12192000" y="8058150"/>
+            <a:ext cx="1809750" cy="323850"/>
+          </a:xfrm>
+          <a:prstGeom xmlns:a="http://schemas.openxmlformats.org/drawingml/2006/main" prst="rect">
+            <a:avLst/>
+          </a:prstGeom>
+          <a:noFill xmlns:a="http://schemas.openxmlformats.org/drawingml/2006/main"/>
+          <a:ln xmlns:a="http://schemas.openxmlformats.org/drawingml/2006/main" w="0">
+            <a:noFill/>
+            <a:prstDash val="solid"/>
+          </a:ln>
+        </p:spPr>
+        <p:txBody>
+          <a:bodyPr xmlns:a="http://schemas.openxmlformats.org/drawingml/2006/main" wrap="square" lIns="0" tIns="0" rIns="0" bIns="0" anchor="ctr">
+            <a:normAutofit fontScale="100000"/>
+          </a:bodyPr>
+          <a:lstStyle xmlns:a="http://schemas.openxmlformats.org/drawingml/2006/main"/>
+          <a:p xmlns:a="http://schemas.openxmlformats.org/drawingml/2006/main">
+            <a:pPr algn="r">
+              <a:lnSpc>
+                <a:spcPct val="100000"/>
+              </a:lnSpc>
+              <a:buNone/>
+              <a:defRPr sz="1200" b="1">
+                <a:solidFill>
+                  <a:srgbClr val="9A9A9F"/>
+                </a:solidFill>
+                <a:latin typeface="Calibri"/>
+                <a:ea typeface="Calibri"/>
+                <a:cs typeface="Calibri"/>
+              </a:defRPr>
+            </a:pPr>
+            <a:r>
+              <a:rPr sz="1200" b="1">
+                <a:solidFill>
+                  <a:srgbClr val="9A9A9F"/>
+                </a:solidFill>
+                <a:latin typeface="Calibri"/>
+                <a:ea typeface="Calibri"/>
+                <a:cs typeface="Calibri"/>
+              </a:rPr>
+              <a:t>OBSERVE</a:t>
+            </a:r>
+          </a:p>
+        </p:txBody>
+      </p:sp>
+      <p:sp>
+        <p:nvSpPr>
+          <p:cNvPr id="34" name="">
+            <a:extLst xmlns:a="http://schemas.openxmlformats.org/drawingml/2006/main">
+              <a:ext uri="{FF2B5EF4-FFF2-40B4-BE49-F238E27FC236}">
+                <a16:creationId xmlns:a16="http://schemas.microsoft.com/office/drawing/2014/main" id="{5F7FB65A-4A0D-4595-92F4-FD9B71638842}"/>
+              </a:ext>
+            </a:extLst>
+          </p:cNvPr>
+          <p:cNvSpPr>
+            <a:spLocks xmlns:a="http://schemas.openxmlformats.org/drawingml/2006/main" noGrp="1"/>
+          </p:cNvSpPr>
+          <p:nvPr/>
+        </p:nvSpPr>
+        <p:spPr>
+          <a:xfrm xmlns:a="http://schemas.openxmlformats.org/drawingml/2006/main">
+            <a:off x="14135100" y="8058150"/>
+            <a:ext cx="266700" cy="323850"/>
+          </a:xfrm>
+          <a:prstGeom xmlns:a="http://schemas.openxmlformats.org/drawingml/2006/main" prst="rect">
+            <a:avLst/>
+          </a:prstGeom>
+          <a:noFill xmlns:a="http://schemas.openxmlformats.org/drawingml/2006/main"/>
+          <a:ln xmlns:a="http://schemas.openxmlformats.org/drawingml/2006/main" w="0">
+            <a:noFill/>
+            <a:prstDash val="solid"/>
+          </a:ln>
+        </p:spPr>
+        <p:txBody>
+          <a:bodyPr xmlns:a="http://schemas.openxmlformats.org/drawingml/2006/main" wrap="square" lIns="0" tIns="0" rIns="0" bIns="0" anchor="ctr">
+            <a:normAutofit fontScale="100000"/>
+          </a:bodyPr>
+          <a:lstStyle xmlns:a="http://schemas.openxmlformats.org/drawingml/2006/main"/>
+          <a:p xmlns:a="http://schemas.openxmlformats.org/drawingml/2006/main">
+            <a:pPr algn="r">
+              <a:lnSpc>
+                <a:spcPct val="100000"/>
+              </a:lnSpc>
+              <a:buNone/>
+              <a:defRPr sz="1200" b="1">
+                <a:solidFill>
+                  <a:srgbClr val="9A9A9F"/>
+                </a:solidFill>
+                <a:latin typeface="Calibri"/>
+                <a:ea typeface="Calibri"/>
+                <a:cs typeface="Calibri"/>
+              </a:defRPr>
+            </a:pPr>
+            <a:r>
+              <a:rPr sz="1200" b="1">
+                <a:solidFill>
+                  <a:srgbClr val="9A9A9F"/>
+                </a:solidFill>
+                <a:latin typeface="Calibri"/>
+                <a:ea typeface="Calibri"/>
+                <a:cs typeface="Calibri"/>
+              </a:rPr>
+              <a:t>09</a:t>
             </a:r>
           </a:p>
         </p:txBody>

</xml_diff>